<commit_message>
Integration des donnees sourcees (DataReportal, Min. Dev. industriel), tarifs benchmark reels, bibliographie corrigee
Co-authored-by: arena-agent <297053741+arena-agent@users.noreply.github.com>
</commit_message>
<xml_diff>
--- a/Pitch_Deck_Sadiya_Digital_Agri.pptx
+++ b/Pitch_Deck_Sadiya_Digital_Agri.pptx
@@ -28912,12 +28912,12 @@
         </p:nvSpPr>
         <p:spPr>
           <a:xfrm>
-            <a:off x="4622800" y="2082800"/>
-            <a:ext cx="2184400" cy="660400"/>
+            <a:off x="4622800" y="2032000"/>
+            <a:ext cx="2184400" cy="711200"/>
           </a:xfrm>
           <a:prstGeom prst="roundRect">
             <a:avLst>
-              <a:gd name="adj" fmla="val 15384"/>
+              <a:gd name="adj" fmla="val 14285"/>
             </a:avLst>
           </a:prstGeom>
           <a:solidFill>
@@ -28956,8 +28956,8 @@
         </p:nvSpPr>
         <p:spPr>
           <a:xfrm>
-            <a:off x="4749800" y="2211832"/>
-            <a:ext cx="1930400" cy="240983"/>
+            <a:off x="4699000" y="2161032"/>
+            <a:ext cx="2032000" cy="233680"/>
           </a:xfrm>
           <a:prstGeom prst="rect">
             <a:avLst/>
@@ -28972,7 +28972,7 @@
           <a:p>
             <a:pPr algn="ctr">
               <a:lnSpc>
-                <a:spcPts val="1437"/>
+                <a:spcPts val="1380"/>
               </a:lnSpc>
             </a:pPr>
             <a:r>
@@ -28989,18 +28989,57 @@
       </p:sp>
       <p:sp>
         <p:nvSpPr>
-          <p:cNvPr id="14" name="Rounded Rectangle 13"/>
-          <p:cNvSpPr/>
-          <p:nvPr/>
-        </p:nvSpPr>
-        <p:spPr>
-          <a:xfrm>
-            <a:off x="7010400" y="2082800"/>
-            <a:ext cx="2184400" cy="660400"/>
+          <p:cNvPr id="14" name="TextBox 13"/>
+          <p:cNvSpPr txBox="1"/>
+          <p:nvPr/>
+        </p:nvSpPr>
+        <p:spPr>
+          <a:xfrm>
+            <a:off x="4699000" y="2422957"/>
+            <a:ext cx="2032000" cy="164084"/>
+          </a:xfrm>
+          <a:prstGeom prst="rect">
+            <a:avLst/>
+          </a:prstGeom>
+          <a:noFill/>
+        </p:spPr>
+        <p:txBody>
+          <a:bodyPr wrap="none" lIns="0" rIns="0" tIns="0" bIns="0" anchor="t">
+            <a:spAutoFit/>
+          </a:bodyPr>
+          <a:lstStyle/>
+          <a:p>
+            <a:pPr algn="ctr">
+              <a:lnSpc>
+                <a:spcPts val="987"/>
+              </a:lnSpc>
+            </a:pPr>
+            <a:r>
+              <a:rPr sz="760" b="0" i="0">
+                <a:solidFill>
+                  <a:srgbClr val="1AAB70"/>
+                </a:solidFill>
+                <a:latin typeface="Poppins"/>
+              </a:rPr>
+              <a:t>75 000 – 250 000 FCFA/mois</a:t>
+            </a:r>
+          </a:p>
+        </p:txBody>
+      </p:sp>
+      <p:sp>
+        <p:nvSpPr>
+          <p:cNvPr id="15" name="Rounded Rectangle 14"/>
+          <p:cNvSpPr/>
+          <p:nvPr/>
+        </p:nvSpPr>
+        <p:spPr>
+          <a:xfrm>
+            <a:off x="7010400" y="2032000"/>
+            <a:ext cx="2184400" cy="711200"/>
           </a:xfrm>
           <a:prstGeom prst="roundRect">
             <a:avLst>
-              <a:gd name="adj" fmla="val 15384"/>
+              <a:gd name="adj" fmla="val 14285"/>
             </a:avLst>
           </a:prstGeom>
           <a:solidFill>
@@ -29035,14 +29074,14 @@
       </p:sp>
       <p:sp>
         <p:nvSpPr>
-          <p:cNvPr id="15" name="TextBox 14"/>
+          <p:cNvPr id="16" name="TextBox 15"/>
           <p:cNvSpPr txBox="1"/>
           <p:nvPr/>
         </p:nvSpPr>
         <p:spPr>
           <a:xfrm>
-            <a:off x="7137400" y="2211832"/>
-            <a:ext cx="1930400" cy="240983"/>
+            <a:off x="7086600" y="2161032"/>
+            <a:ext cx="2032000" cy="233680"/>
           </a:xfrm>
           <a:prstGeom prst="rect">
             <a:avLst/>
@@ -29057,7 +29096,7 @@
           <a:p>
             <a:pPr algn="ctr">
               <a:lnSpc>
-                <a:spcPts val="1437"/>
+                <a:spcPts val="1380"/>
               </a:lnSpc>
             </a:pPr>
             <a:r>
@@ -29074,18 +29113,57 @@
       </p:sp>
       <p:sp>
         <p:nvSpPr>
-          <p:cNvPr id="16" name="Rounded Rectangle 15"/>
-          <p:cNvSpPr/>
-          <p:nvPr/>
-        </p:nvSpPr>
-        <p:spPr>
-          <a:xfrm>
-            <a:off x="9398000" y="2082800"/>
-            <a:ext cx="2184400" cy="660400"/>
+          <p:cNvPr id="17" name="TextBox 16"/>
+          <p:cNvSpPr txBox="1"/>
+          <p:nvPr/>
+        </p:nvSpPr>
+        <p:spPr>
+          <a:xfrm>
+            <a:off x="7086600" y="2422957"/>
+            <a:ext cx="2032000" cy="164084"/>
+          </a:xfrm>
+          <a:prstGeom prst="rect">
+            <a:avLst/>
+          </a:prstGeom>
+          <a:noFill/>
+        </p:spPr>
+        <p:txBody>
+          <a:bodyPr wrap="none" lIns="0" rIns="0" tIns="0" bIns="0" anchor="t">
+            <a:spAutoFit/>
+          </a:bodyPr>
+          <a:lstStyle/>
+          <a:p>
+            <a:pPr algn="ctr">
+              <a:lnSpc>
+                <a:spcPts val="987"/>
+              </a:lnSpc>
+            </a:pPr>
+            <a:r>
+              <a:rPr sz="760" b="0" i="0">
+                <a:solidFill>
+                  <a:srgbClr val="42612D"/>
+                </a:solidFill>
+                <a:latin typeface="Poppins"/>
+              </a:rPr>
+              <a:t>130 000 – 600 000 FCFA/mois</a:t>
+            </a:r>
+          </a:p>
+        </p:txBody>
+      </p:sp>
+      <p:sp>
+        <p:nvSpPr>
+          <p:cNvPr id="18" name="Rounded Rectangle 17"/>
+          <p:cNvSpPr/>
+          <p:nvPr/>
+        </p:nvSpPr>
+        <p:spPr>
+          <a:xfrm>
+            <a:off x="9398000" y="2032000"/>
+            <a:ext cx="2184400" cy="711200"/>
           </a:xfrm>
           <a:prstGeom prst="roundRect">
             <a:avLst>
-              <a:gd name="adj" fmla="val 15384"/>
+              <a:gd name="adj" fmla="val 14285"/>
             </a:avLst>
           </a:prstGeom>
           <a:solidFill>
@@ -29120,14 +29198,14 @@
       </p:sp>
       <p:sp>
         <p:nvSpPr>
-          <p:cNvPr id="17" name="TextBox 16"/>
+          <p:cNvPr id="19" name="TextBox 18"/>
           <p:cNvSpPr txBox="1"/>
           <p:nvPr/>
         </p:nvSpPr>
         <p:spPr>
           <a:xfrm>
-            <a:off x="9525000" y="2211832"/>
-            <a:ext cx="1930400" cy="240983"/>
+            <a:off x="9474200" y="2161032"/>
+            <a:ext cx="2032000" cy="233680"/>
           </a:xfrm>
           <a:prstGeom prst="rect">
             <a:avLst/>
@@ -29142,7 +29220,7 @@
           <a:p>
             <a:pPr algn="ctr">
               <a:lnSpc>
-                <a:spcPts val="1437"/>
+                <a:spcPts val="1380"/>
               </a:lnSpc>
             </a:pPr>
             <a:r>
@@ -29159,7 +29237,46 @@
       </p:sp>
       <p:sp>
         <p:nvSpPr>
-          <p:cNvPr id="18" name="Rounded Rectangle 17"/>
+          <p:cNvPr id="20" name="TextBox 19"/>
+          <p:cNvSpPr txBox="1"/>
+          <p:nvPr/>
+        </p:nvSpPr>
+        <p:spPr>
+          <a:xfrm>
+            <a:off x="9474200" y="2422957"/>
+            <a:ext cx="2032000" cy="164084"/>
+          </a:xfrm>
+          <a:prstGeom prst="rect">
+            <a:avLst/>
+          </a:prstGeom>
+          <a:noFill/>
+        </p:spPr>
+        <p:txBody>
+          <a:bodyPr wrap="none" lIns="0" rIns="0" tIns="0" bIns="0" anchor="t">
+            <a:spAutoFit/>
+          </a:bodyPr>
+          <a:lstStyle/>
+          <a:p>
+            <a:pPr algn="ctr">
+              <a:lnSpc>
+                <a:spcPts val="987"/>
+              </a:lnSpc>
+            </a:pPr>
+            <a:r>
+              <a:rPr sz="760" b="0" i="0">
+                <a:solidFill>
+                  <a:srgbClr val="42612D"/>
+                </a:solidFill>
+                <a:latin typeface="Poppins"/>
+              </a:rPr>
+              <a:t>50 000 – 150 000 FCFA/mois</a:t>
+            </a:r>
+          </a:p>
+        </p:txBody>
+      </p:sp>
+      <p:sp>
+        <p:nvSpPr>
+          <p:cNvPr id="21" name="Rounded Rectangle 20"/>
           <p:cNvSpPr/>
           <p:nvPr/>
         </p:nvSpPr>
@@ -29205,7 +29322,7 @@
       </p:sp>
       <p:sp>
         <p:nvSpPr>
-          <p:cNvPr id="19" name="TextBox 18"/>
+          <p:cNvPr id="22" name="TextBox 21"/>
           <p:cNvSpPr txBox="1"/>
           <p:nvPr/>
         </p:nvSpPr>
@@ -29244,7 +29361,7 @@
       </p:sp>
       <p:sp>
         <p:nvSpPr>
-          <p:cNvPr id="20" name="Rounded Rectangle 19"/>
+          <p:cNvPr id="23" name="Rounded Rectangle 22"/>
           <p:cNvSpPr/>
           <p:nvPr/>
         </p:nvSpPr>
@@ -29290,7 +29407,7 @@
       </p:sp>
       <p:sp>
         <p:nvSpPr>
-          <p:cNvPr id="21" name="Oval 20"/>
+          <p:cNvPr id="24" name="Oval 23"/>
           <p:cNvSpPr/>
           <p:nvPr/>
         </p:nvSpPr>
@@ -29334,7 +29451,7 @@
       </p:sp>
       <p:cxnSp>
         <p:nvCxnSpPr>
-          <p:cNvPr id="22" name="Connector 21"/>
+          <p:cNvPr id="25" name="Connector 24"/>
           <p:cNvCxnSpPr/>
           <p:nvPr/>
         </p:nvCxnSpPr>
@@ -29369,7 +29486,7 @@
       </p:cxnSp>
       <p:cxnSp>
         <p:nvCxnSpPr>
-          <p:cNvPr id="23" name="Connector 22"/>
+          <p:cNvPr id="26" name="Connector 25"/>
           <p:cNvCxnSpPr/>
           <p:nvPr/>
         </p:nvCxnSpPr>
@@ -29404,7 +29521,7 @@
       </p:cxnSp>
       <p:sp>
         <p:nvSpPr>
-          <p:cNvPr id="24" name="Rounded Rectangle 23"/>
+          <p:cNvPr id="27" name="Rounded Rectangle 26"/>
           <p:cNvSpPr/>
           <p:nvPr/>
         </p:nvSpPr>
@@ -29450,7 +29567,7 @@
       </p:sp>
       <p:sp>
         <p:nvSpPr>
-          <p:cNvPr id="25" name="Oval 24"/>
+          <p:cNvPr id="28" name="Oval 27"/>
           <p:cNvSpPr/>
           <p:nvPr/>
         </p:nvSpPr>
@@ -29494,7 +29611,7 @@
       </p:sp>
       <p:cxnSp>
         <p:nvCxnSpPr>
-          <p:cNvPr id="26" name="Connector 25"/>
+          <p:cNvPr id="29" name="Connector 28"/>
           <p:cNvCxnSpPr/>
           <p:nvPr/>
         </p:nvCxnSpPr>
@@ -29529,7 +29646,7 @@
       </p:cxnSp>
       <p:cxnSp>
         <p:nvCxnSpPr>
-          <p:cNvPr id="27" name="Connector 26"/>
+          <p:cNvPr id="30" name="Connector 29"/>
           <p:cNvCxnSpPr/>
           <p:nvPr/>
         </p:nvCxnSpPr>
@@ -29564,7 +29681,7 @@
       </p:cxnSp>
       <p:sp>
         <p:nvSpPr>
-          <p:cNvPr id="28" name="Rounded Rectangle 27"/>
+          <p:cNvPr id="31" name="Rounded Rectangle 30"/>
           <p:cNvSpPr/>
           <p:nvPr/>
         </p:nvSpPr>
@@ -29610,7 +29727,7 @@
       </p:sp>
       <p:sp>
         <p:nvSpPr>
-          <p:cNvPr id="29" name="Oval 28"/>
+          <p:cNvPr id="32" name="Oval 31"/>
           <p:cNvSpPr/>
           <p:nvPr/>
         </p:nvSpPr>
@@ -29654,7 +29771,7 @@
       </p:sp>
       <p:cxnSp>
         <p:nvCxnSpPr>
-          <p:cNvPr id="30" name="Connector 29"/>
+          <p:cNvPr id="33" name="Connector 32"/>
           <p:cNvCxnSpPr/>
           <p:nvPr/>
         </p:nvCxnSpPr>
@@ -29689,7 +29806,7 @@
       </p:cxnSp>
       <p:cxnSp>
         <p:nvCxnSpPr>
-          <p:cNvPr id="31" name="Connector 30"/>
+          <p:cNvPr id="34" name="Connector 33"/>
           <p:cNvCxnSpPr/>
           <p:nvPr/>
         </p:nvCxnSpPr>
@@ -29724,7 +29841,7 @@
       </p:cxnSp>
       <p:sp>
         <p:nvSpPr>
-          <p:cNvPr id="32" name="Rounded Rectangle 31"/>
+          <p:cNvPr id="35" name="Rounded Rectangle 34"/>
           <p:cNvSpPr/>
           <p:nvPr/>
         </p:nvSpPr>
@@ -29770,7 +29887,7 @@
       </p:sp>
       <p:sp>
         <p:nvSpPr>
-          <p:cNvPr id="33" name="TextBox 32"/>
+          <p:cNvPr id="36" name="TextBox 35"/>
           <p:cNvSpPr txBox="1"/>
           <p:nvPr/>
         </p:nvSpPr>
@@ -29809,7 +29926,7 @@
       </p:sp>
       <p:sp>
         <p:nvSpPr>
-          <p:cNvPr id="34" name="Rounded Rectangle 33"/>
+          <p:cNvPr id="37" name="Rounded Rectangle 36"/>
           <p:cNvSpPr/>
           <p:nvPr/>
         </p:nvSpPr>
@@ -29855,7 +29972,7 @@
       </p:sp>
       <p:sp>
         <p:nvSpPr>
-          <p:cNvPr id="35" name="Oval 34"/>
+          <p:cNvPr id="38" name="Oval 37"/>
           <p:cNvSpPr/>
           <p:nvPr/>
         </p:nvSpPr>
@@ -29899,7 +30016,7 @@
       </p:sp>
       <p:cxnSp>
         <p:nvCxnSpPr>
-          <p:cNvPr id="36" name="Connector 35"/>
+          <p:cNvPr id="39" name="Connector 38"/>
           <p:cNvCxnSpPr/>
           <p:nvPr/>
         </p:nvCxnSpPr>
@@ -29934,7 +30051,7 @@
       </p:cxnSp>
       <p:cxnSp>
         <p:nvCxnSpPr>
-          <p:cNvPr id="37" name="Connector 36"/>
+          <p:cNvPr id="40" name="Connector 39"/>
           <p:cNvCxnSpPr/>
           <p:nvPr/>
         </p:nvCxnSpPr>
@@ -29969,7 +30086,7 @@
       </p:cxnSp>
       <p:sp>
         <p:nvSpPr>
-          <p:cNvPr id="38" name="Rounded Rectangle 37"/>
+          <p:cNvPr id="41" name="Rounded Rectangle 40"/>
           <p:cNvSpPr/>
           <p:nvPr/>
         </p:nvSpPr>
@@ -30015,7 +30132,7 @@
       </p:sp>
       <p:sp>
         <p:nvSpPr>
-          <p:cNvPr id="39" name="Oval 38"/>
+          <p:cNvPr id="42" name="Oval 41"/>
           <p:cNvSpPr/>
           <p:nvPr/>
         </p:nvSpPr>
@@ -30059,7 +30176,7 @@
       </p:sp>
       <p:cxnSp>
         <p:nvCxnSpPr>
-          <p:cNvPr id="40" name="Connector 39"/>
+          <p:cNvPr id="43" name="Connector 42"/>
           <p:cNvCxnSpPr/>
           <p:nvPr/>
         </p:nvCxnSpPr>
@@ -30094,7 +30211,7 @@
       </p:cxnSp>
       <p:cxnSp>
         <p:nvCxnSpPr>
-          <p:cNvPr id="41" name="Connector 40"/>
+          <p:cNvPr id="44" name="Connector 43"/>
           <p:cNvCxnSpPr/>
           <p:nvPr/>
         </p:nvCxnSpPr>
@@ -30129,7 +30246,7 @@
       </p:cxnSp>
       <p:sp>
         <p:nvSpPr>
-          <p:cNvPr id="42" name="Rounded Rectangle 41"/>
+          <p:cNvPr id="45" name="Rounded Rectangle 44"/>
           <p:cNvSpPr/>
           <p:nvPr/>
         </p:nvSpPr>
@@ -30175,7 +30292,7 @@
       </p:sp>
       <p:sp>
         <p:nvSpPr>
-          <p:cNvPr id="43" name="Oval 42"/>
+          <p:cNvPr id="46" name="Oval 45"/>
           <p:cNvSpPr/>
           <p:nvPr/>
         </p:nvSpPr>
@@ -30219,7 +30336,7 @@
       </p:sp>
       <p:cxnSp>
         <p:nvCxnSpPr>
-          <p:cNvPr id="44" name="Connector 43"/>
+          <p:cNvPr id="47" name="Connector 46"/>
           <p:cNvCxnSpPr/>
           <p:nvPr/>
         </p:nvCxnSpPr>
@@ -30254,7 +30371,7 @@
       </p:cxnSp>
       <p:cxnSp>
         <p:nvCxnSpPr>
-          <p:cNvPr id="45" name="Connector 44"/>
+          <p:cNvPr id="48" name="Connector 47"/>
           <p:cNvCxnSpPr/>
           <p:nvPr/>
         </p:nvCxnSpPr>
@@ -30289,7 +30406,7 @@
       </p:cxnSp>
       <p:sp>
         <p:nvSpPr>
-          <p:cNvPr id="46" name="Rounded Rectangle 45"/>
+          <p:cNvPr id="49" name="Rounded Rectangle 48"/>
           <p:cNvSpPr/>
           <p:nvPr/>
         </p:nvSpPr>
@@ -30335,7 +30452,7 @@
       </p:sp>
       <p:sp>
         <p:nvSpPr>
-          <p:cNvPr id="47" name="TextBox 46"/>
+          <p:cNvPr id="50" name="TextBox 49"/>
           <p:cNvSpPr txBox="1"/>
           <p:nvPr/>
         </p:nvSpPr>
@@ -30374,7 +30491,7 @@
       </p:sp>
       <p:sp>
         <p:nvSpPr>
-          <p:cNvPr id="48" name="Rounded Rectangle 47"/>
+          <p:cNvPr id="51" name="Rounded Rectangle 50"/>
           <p:cNvSpPr/>
           <p:nvPr/>
         </p:nvSpPr>
@@ -30420,7 +30537,7 @@
       </p:sp>
       <p:sp>
         <p:nvSpPr>
-          <p:cNvPr id="49" name="Oval 48"/>
+          <p:cNvPr id="52" name="Oval 51"/>
           <p:cNvSpPr/>
           <p:nvPr/>
         </p:nvSpPr>
@@ -30464,7 +30581,7 @@
       </p:sp>
       <p:cxnSp>
         <p:nvCxnSpPr>
-          <p:cNvPr id="50" name="Connector 49"/>
+          <p:cNvPr id="53" name="Connector 52"/>
           <p:cNvCxnSpPr/>
           <p:nvPr/>
         </p:nvCxnSpPr>
@@ -30499,7 +30616,7 @@
       </p:cxnSp>
       <p:cxnSp>
         <p:nvCxnSpPr>
-          <p:cNvPr id="51" name="Connector 50"/>
+          <p:cNvPr id="54" name="Connector 53"/>
           <p:cNvCxnSpPr/>
           <p:nvPr/>
         </p:nvCxnSpPr>
@@ -30534,7 +30651,7 @@
       </p:cxnSp>
       <p:sp>
         <p:nvSpPr>
-          <p:cNvPr id="52" name="Rounded Rectangle 51"/>
+          <p:cNvPr id="55" name="Rounded Rectangle 54"/>
           <p:cNvSpPr/>
           <p:nvPr/>
         </p:nvSpPr>
@@ -30580,7 +30697,7 @@
       </p:sp>
       <p:sp>
         <p:nvSpPr>
-          <p:cNvPr id="53" name="Oval 52"/>
+          <p:cNvPr id="56" name="Oval 55"/>
           <p:cNvSpPr/>
           <p:nvPr/>
         </p:nvSpPr>
@@ -30624,7 +30741,7 @@
       </p:sp>
       <p:cxnSp>
         <p:nvCxnSpPr>
-          <p:cNvPr id="54" name="Connector 53"/>
+          <p:cNvPr id="57" name="Connector 56"/>
           <p:cNvCxnSpPr/>
           <p:nvPr/>
         </p:nvCxnSpPr>
@@ -30659,7 +30776,7 @@
       </p:cxnSp>
       <p:cxnSp>
         <p:nvCxnSpPr>
-          <p:cNvPr id="55" name="Connector 54"/>
+          <p:cNvPr id="58" name="Connector 57"/>
           <p:cNvCxnSpPr/>
           <p:nvPr/>
         </p:nvCxnSpPr>
@@ -30694,7 +30811,7 @@
       </p:cxnSp>
       <p:sp>
         <p:nvSpPr>
-          <p:cNvPr id="56" name="Rounded Rectangle 55"/>
+          <p:cNvPr id="59" name="Rounded Rectangle 58"/>
           <p:cNvSpPr/>
           <p:nvPr/>
         </p:nvSpPr>
@@ -30740,7 +30857,7 @@
       </p:sp>
       <p:sp>
         <p:nvSpPr>
-          <p:cNvPr id="57" name="Oval 56"/>
+          <p:cNvPr id="60" name="Oval 59"/>
           <p:cNvSpPr/>
           <p:nvPr/>
         </p:nvSpPr>
@@ -30784,7 +30901,7 @@
       </p:sp>
       <p:sp>
         <p:nvSpPr>
-          <p:cNvPr id="58" name="Rounded Rectangle 57"/>
+          <p:cNvPr id="61" name="Rounded Rectangle 60"/>
           <p:cNvSpPr/>
           <p:nvPr/>
         </p:nvSpPr>
@@ -30828,7 +30945,7 @@
       </p:sp>
       <p:sp>
         <p:nvSpPr>
-          <p:cNvPr id="59" name="Rounded Rectangle 58"/>
+          <p:cNvPr id="62" name="Rounded Rectangle 61"/>
           <p:cNvSpPr/>
           <p:nvPr/>
         </p:nvSpPr>
@@ -30874,7 +30991,7 @@
       </p:sp>
       <p:sp>
         <p:nvSpPr>
-          <p:cNvPr id="60" name="TextBox 59"/>
+          <p:cNvPr id="63" name="TextBox 62"/>
           <p:cNvSpPr txBox="1"/>
           <p:nvPr/>
         </p:nvSpPr>
@@ -30913,7 +31030,7 @@
       </p:sp>
       <p:sp>
         <p:nvSpPr>
-          <p:cNvPr id="61" name="Rounded Rectangle 60"/>
+          <p:cNvPr id="64" name="Rounded Rectangle 63"/>
           <p:cNvSpPr/>
           <p:nvPr/>
         </p:nvSpPr>
@@ -30959,7 +31076,7 @@
       </p:sp>
       <p:sp>
         <p:nvSpPr>
-          <p:cNvPr id="62" name="Oval 61"/>
+          <p:cNvPr id="65" name="Oval 64"/>
           <p:cNvSpPr/>
           <p:nvPr/>
         </p:nvSpPr>
@@ -31003,7 +31120,7 @@
       </p:sp>
       <p:cxnSp>
         <p:nvCxnSpPr>
-          <p:cNvPr id="63" name="Connector 62"/>
+          <p:cNvPr id="66" name="Connector 65"/>
           <p:cNvCxnSpPr/>
           <p:nvPr/>
         </p:nvCxnSpPr>
@@ -31038,7 +31155,7 @@
       </p:cxnSp>
       <p:cxnSp>
         <p:nvCxnSpPr>
-          <p:cNvPr id="64" name="Connector 63"/>
+          <p:cNvPr id="67" name="Connector 66"/>
           <p:cNvCxnSpPr/>
           <p:nvPr/>
         </p:nvCxnSpPr>
@@ -31073,7 +31190,7 @@
       </p:cxnSp>
       <p:sp>
         <p:nvSpPr>
-          <p:cNvPr id="65" name="Rounded Rectangle 64"/>
+          <p:cNvPr id="68" name="Rounded Rectangle 67"/>
           <p:cNvSpPr/>
           <p:nvPr/>
         </p:nvSpPr>
@@ -31119,7 +31236,7 @@
       </p:sp>
       <p:sp>
         <p:nvSpPr>
-          <p:cNvPr id="66" name="Oval 65"/>
+          <p:cNvPr id="69" name="Oval 68"/>
           <p:cNvSpPr/>
           <p:nvPr/>
         </p:nvSpPr>
@@ -31163,7 +31280,7 @@
       </p:sp>
       <p:cxnSp>
         <p:nvCxnSpPr>
-          <p:cNvPr id="67" name="Connector 66"/>
+          <p:cNvPr id="70" name="Connector 69"/>
           <p:cNvCxnSpPr/>
           <p:nvPr/>
         </p:nvCxnSpPr>
@@ -31198,7 +31315,7 @@
       </p:cxnSp>
       <p:cxnSp>
         <p:nvCxnSpPr>
-          <p:cNvPr id="68" name="Connector 67"/>
+          <p:cNvPr id="71" name="Connector 70"/>
           <p:cNvCxnSpPr/>
           <p:nvPr/>
         </p:nvCxnSpPr>
@@ -31233,7 +31350,7 @@
       </p:cxnSp>
       <p:sp>
         <p:nvSpPr>
-          <p:cNvPr id="69" name="Rounded Rectangle 68"/>
+          <p:cNvPr id="72" name="Rounded Rectangle 71"/>
           <p:cNvSpPr/>
           <p:nvPr/>
         </p:nvSpPr>
@@ -31279,7 +31396,7 @@
       </p:sp>
       <p:sp>
         <p:nvSpPr>
-          <p:cNvPr id="70" name="Oval 69"/>
+          <p:cNvPr id="73" name="Oval 72"/>
           <p:cNvSpPr/>
           <p:nvPr/>
         </p:nvSpPr>
@@ -31323,7 +31440,7 @@
       </p:sp>
       <p:cxnSp>
         <p:nvCxnSpPr>
-          <p:cNvPr id="71" name="Connector 70"/>
+          <p:cNvPr id="74" name="Connector 73"/>
           <p:cNvCxnSpPr/>
           <p:nvPr/>
         </p:nvCxnSpPr>
@@ -31358,7 +31475,7 @@
       </p:cxnSp>
       <p:cxnSp>
         <p:nvCxnSpPr>
-          <p:cNvPr id="72" name="Connector 71"/>
+          <p:cNvPr id="75" name="Connector 74"/>
           <p:cNvCxnSpPr/>
           <p:nvPr/>
         </p:nvCxnSpPr>
@@ -31393,7 +31510,7 @@
       </p:cxnSp>
       <p:sp>
         <p:nvSpPr>
-          <p:cNvPr id="73" name="Rounded Rectangle 72"/>
+          <p:cNvPr id="76" name="Rounded Rectangle 75"/>
           <p:cNvSpPr/>
           <p:nvPr/>
         </p:nvSpPr>
@@ -31439,7 +31556,7 @@
       </p:sp>
       <p:sp>
         <p:nvSpPr>
-          <p:cNvPr id="74" name="TextBox 73"/>
+          <p:cNvPr id="77" name="TextBox 76"/>
           <p:cNvSpPr txBox="1"/>
           <p:nvPr/>
         </p:nvSpPr>
@@ -31478,7 +31595,7 @@
       </p:sp>
       <p:sp>
         <p:nvSpPr>
-          <p:cNvPr id="75" name="Rounded Rectangle 74"/>
+          <p:cNvPr id="78" name="Rounded Rectangle 77"/>
           <p:cNvSpPr/>
           <p:nvPr/>
         </p:nvSpPr>
@@ -31524,7 +31641,7 @@
       </p:sp>
       <p:sp>
         <p:nvSpPr>
-          <p:cNvPr id="76" name="Oval 75"/>
+          <p:cNvPr id="79" name="Oval 78"/>
           <p:cNvSpPr/>
           <p:nvPr/>
         </p:nvSpPr>
@@ -31568,7 +31685,7 @@
       </p:sp>
       <p:cxnSp>
         <p:nvCxnSpPr>
-          <p:cNvPr id="77" name="Connector 76"/>
+          <p:cNvPr id="80" name="Connector 79"/>
           <p:cNvCxnSpPr/>
           <p:nvPr/>
         </p:nvCxnSpPr>
@@ -31603,7 +31720,7 @@
       </p:cxnSp>
       <p:cxnSp>
         <p:nvCxnSpPr>
-          <p:cNvPr id="78" name="Connector 77"/>
+          <p:cNvPr id="81" name="Connector 80"/>
           <p:cNvCxnSpPr/>
           <p:nvPr/>
         </p:nvCxnSpPr>
@@ -31638,7 +31755,7 @@
       </p:cxnSp>
       <p:sp>
         <p:nvSpPr>
-          <p:cNvPr id="79" name="Rounded Rectangle 78"/>
+          <p:cNvPr id="82" name="Rounded Rectangle 81"/>
           <p:cNvSpPr/>
           <p:nvPr/>
         </p:nvSpPr>
@@ -31684,7 +31801,7 @@
       </p:sp>
       <p:sp>
         <p:nvSpPr>
-          <p:cNvPr id="80" name="Oval 79"/>
+          <p:cNvPr id="83" name="Oval 82"/>
           <p:cNvSpPr/>
           <p:nvPr/>
         </p:nvSpPr>
@@ -31728,7 +31845,7 @@
       </p:sp>
       <p:cxnSp>
         <p:nvCxnSpPr>
-          <p:cNvPr id="81" name="Connector 80"/>
+          <p:cNvPr id="84" name="Connector 83"/>
           <p:cNvCxnSpPr/>
           <p:nvPr/>
         </p:nvCxnSpPr>
@@ -31763,7 +31880,7 @@
       </p:cxnSp>
       <p:cxnSp>
         <p:nvCxnSpPr>
-          <p:cNvPr id="82" name="Connector 81"/>
+          <p:cNvPr id="85" name="Connector 84"/>
           <p:cNvCxnSpPr/>
           <p:nvPr/>
         </p:nvCxnSpPr>
@@ -31798,7 +31915,7 @@
       </p:cxnSp>
       <p:sp>
         <p:nvSpPr>
-          <p:cNvPr id="83" name="Rounded Rectangle 82"/>
+          <p:cNvPr id="86" name="Rounded Rectangle 85"/>
           <p:cNvSpPr/>
           <p:nvPr/>
         </p:nvSpPr>
@@ -31844,7 +31961,7 @@
       </p:sp>
       <p:sp>
         <p:nvSpPr>
-          <p:cNvPr id="84" name="Oval 83"/>
+          <p:cNvPr id="87" name="Oval 86"/>
           <p:cNvSpPr/>
           <p:nvPr/>
         </p:nvSpPr>
@@ -31888,7 +32005,7 @@
       </p:sp>
       <p:cxnSp>
         <p:nvCxnSpPr>
-          <p:cNvPr id="85" name="Connector 84"/>
+          <p:cNvPr id="88" name="Connector 87"/>
           <p:cNvCxnSpPr/>
           <p:nvPr/>
         </p:nvCxnSpPr>
@@ -31923,7 +32040,7 @@
       </p:cxnSp>
       <p:cxnSp>
         <p:nvCxnSpPr>
-          <p:cNvPr id="86" name="Connector 85"/>
+          <p:cNvPr id="89" name="Connector 88"/>
           <p:cNvCxnSpPr/>
           <p:nvPr/>
         </p:nvCxnSpPr>
@@ -31958,7 +32075,7 @@
       </p:cxnSp>
       <p:sp>
         <p:nvSpPr>
-          <p:cNvPr id="87" name="Rounded Rectangle 86"/>
+          <p:cNvPr id="90" name="Rounded Rectangle 89"/>
           <p:cNvSpPr/>
           <p:nvPr/>
         </p:nvSpPr>
@@ -32002,7 +32119,7 @@
       </p:sp>
       <p:sp>
         <p:nvSpPr>
-          <p:cNvPr id="88" name="TextBox 87"/>
+          <p:cNvPr id="91" name="TextBox 90"/>
           <p:cNvSpPr txBox="1"/>
           <p:nvPr/>
         </p:nvSpPr>
@@ -37330,7 +37447,7 @@
         <p:spPr>
           <a:xfrm>
             <a:off x="635000" y="2113280"/>
-            <a:ext cx="5130800" cy="215900"/>
+            <a:ext cx="6400800" cy="215900"/>
           </a:xfrm>
           <a:prstGeom prst="rect">
             <a:avLst/>
@@ -37355,7 +37472,7 @@
                 </a:solidFill>
                 <a:latin typeface="Poppins"/>
               </a:rPr>
-              <a:t>LE CONTEXTE</a:t>
+              <a:t>LE CONTEXTE — UN MARCHÉ PORTEUR</a:t>
             </a:r>
           </a:p>
         </p:txBody>
@@ -37368,7 +37485,7 @@
         </p:nvSpPr>
         <p:spPr>
           <a:xfrm>
-            <a:off x="660400" y="2438400"/>
+            <a:off x="660400" y="2413000"/>
             <a:ext cx="3403600" cy="1320800"/>
           </a:xfrm>
           <a:prstGeom prst="roundRect">
@@ -37414,7 +37531,7 @@
         </p:nvSpPr>
         <p:spPr>
           <a:xfrm>
-            <a:off x="660400" y="2438400"/>
+            <a:off x="660400" y="2413000"/>
             <a:ext cx="3403600" cy="50800"/>
           </a:xfrm>
           <a:prstGeom prst="roundRect">
@@ -37458,8 +37575,8 @@
         </p:nvSpPr>
         <p:spPr>
           <a:xfrm>
-            <a:off x="914400" y="2620264"/>
-            <a:ext cx="2921000" cy="438150"/>
+            <a:off x="914400" y="2537968"/>
+            <a:ext cx="2921000" cy="561340"/>
           </a:xfrm>
           <a:prstGeom prst="rect">
             <a:avLst/>
@@ -37474,17 +37591,17 @@
           <a:p>
             <a:pPr algn="l">
               <a:lnSpc>
-                <a:spcPts val="2530"/>
+                <a:spcPts val="3380"/>
               </a:lnSpc>
             </a:pPr>
             <a:r>
-              <a:rPr sz="2300" b="0" i="0">
+              <a:rPr sz="2600" b="0" i="0">
                 <a:solidFill>
                   <a:srgbClr val="1AAB70"/>
                 </a:solidFill>
                 <a:latin typeface="Alfa Slab One"/>
               </a:rPr>
-              <a:t>70 %</a:t>
+              <a:t>11,5 M</a:t>
             </a:r>
           </a:p>
         </p:txBody>
@@ -37497,8 +37614,8 @@
         </p:nvSpPr>
         <p:spPr>
           <a:xfrm>
-            <a:off x="914400" y="3152648"/>
-            <a:ext cx="2971800" cy="447040"/>
+            <a:off x="914400" y="3050032"/>
+            <a:ext cx="2971800" cy="248285"/>
           </a:xfrm>
           <a:prstGeom prst="rect">
             <a:avLst/>
@@ -37513,46 +37630,69 @@
           <a:p>
             <a:pPr algn="l">
               <a:lnSpc>
-                <a:spcPts val="1539"/>
+                <a:spcPts val="1495"/>
               </a:lnSpc>
             </a:pPr>
             <a:r>
-              <a:rPr sz="1100" b="0" i="0">
+              <a:rPr sz="1150" b="1" i="0">
                 <a:solidFill>
-                  <a:srgbClr val="0A1A01"/>
+                  <a:srgbClr val="1F5E3A"/>
                 </a:solidFill>
                 <a:latin typeface="Poppins"/>
               </a:rPr>
-              <a:t>de la population sénégalaise</a:t>
-            </a:r>
-          </a:p>
+              <a:t>utilisateurs internet</a:t>
+            </a:r>
+          </a:p>
+        </p:txBody>
+      </p:sp>
+      <p:sp>
+        <p:nvSpPr>
+          <p:cNvPr id="17" name="TextBox 16"/>
+          <p:cNvSpPr txBox="1"/>
+          <p:nvPr/>
+        </p:nvSpPr>
+        <p:spPr>
+          <a:xfrm>
+            <a:off x="914400" y="3308706"/>
+            <a:ext cx="2971800" cy="204470"/>
+          </a:xfrm>
+          <a:prstGeom prst="rect">
+            <a:avLst/>
+          </a:prstGeom>
+          <a:noFill/>
+        </p:spPr>
+        <p:txBody>
+          <a:bodyPr wrap="none" lIns="0" rIns="0" tIns="0" bIns="0" anchor="t">
+            <a:spAutoFit/>
+          </a:bodyPr>
+          <a:lstStyle/>
           <a:p>
             <a:pPr algn="l">
               <a:lnSpc>
-                <a:spcPts val="1539"/>
+                <a:spcPts val="1242"/>
               </a:lnSpc>
             </a:pPr>
             <a:r>
-              <a:rPr sz="1100" b="0" i="0">
+              <a:rPr sz="919" b="0" i="0">
                 <a:solidFill>
-                  <a:srgbClr val="0A1A01"/>
+                  <a:srgbClr val="42612D"/>
                 </a:solidFill>
                 <a:latin typeface="Poppins"/>
               </a:rPr>
-              <a:t>vit de l'agriculture</a:t>
-            </a:r>
-          </a:p>
-        </p:txBody>
-      </p:sp>
-      <p:sp>
-        <p:nvSpPr>
-          <p:cNvPr id="17" name="Rounded Rectangle 16"/>
-          <p:cNvSpPr/>
-          <p:nvPr/>
-        </p:nvSpPr>
-        <p:spPr>
-          <a:xfrm>
-            <a:off x="4318000" y="2438400"/>
+              <a:t>60,6 % de pénétration, fin 2025</a:t>
+            </a:r>
+          </a:p>
+        </p:txBody>
+      </p:sp>
+      <p:sp>
+        <p:nvSpPr>
+          <p:cNvPr id="18" name="Rounded Rectangle 17"/>
+          <p:cNvSpPr/>
+          <p:nvPr/>
+        </p:nvSpPr>
+        <p:spPr>
+          <a:xfrm>
+            <a:off x="4318000" y="2413000"/>
             <a:ext cx="3403600" cy="1320800"/>
           </a:xfrm>
           <a:prstGeom prst="roundRect">
@@ -37592,13 +37732,13 @@
       </p:sp>
       <p:sp>
         <p:nvSpPr>
-          <p:cNvPr id="18" name="Rounded Rectangle 17"/>
-          <p:cNvSpPr/>
-          <p:nvPr/>
-        </p:nvSpPr>
-        <p:spPr>
-          <a:xfrm>
-            <a:off x="4318000" y="2438400"/>
+          <p:cNvPr id="19" name="Rounded Rectangle 18"/>
+          <p:cNvSpPr/>
+          <p:nvPr/>
+        </p:nvSpPr>
+        <p:spPr>
+          <a:xfrm>
+            <a:off x="4318000" y="2413000"/>
             <a:ext cx="3403600" cy="50800"/>
           </a:xfrm>
           <a:prstGeom prst="roundRect">
@@ -37636,14 +37776,14 @@
       </p:sp>
       <p:sp>
         <p:nvSpPr>
-          <p:cNvPr id="19" name="TextBox 18"/>
+          <p:cNvPr id="20" name="TextBox 19"/>
           <p:cNvSpPr txBox="1"/>
           <p:nvPr/>
         </p:nvSpPr>
         <p:spPr>
           <a:xfrm>
-            <a:off x="4572000" y="2620264"/>
-            <a:ext cx="2921000" cy="438150"/>
+            <a:off x="4572000" y="2537968"/>
+            <a:ext cx="2921000" cy="561340"/>
           </a:xfrm>
           <a:prstGeom prst="rect">
             <a:avLst/>
@@ -37658,31 +37798,31 @@
           <a:p>
             <a:pPr algn="l">
               <a:lnSpc>
-                <a:spcPts val="2530"/>
+                <a:spcPts val="3380"/>
               </a:lnSpc>
             </a:pPr>
             <a:r>
-              <a:rPr sz="2300" b="0" i="0">
+              <a:rPr sz="2600" b="0" i="0">
                 <a:solidFill>
                   <a:srgbClr val="1F5E3A"/>
                 </a:solidFill>
                 <a:latin typeface="Alfa Slab One"/>
               </a:rPr>
-              <a:t>+ 9 M</a:t>
-            </a:r>
-          </a:p>
-        </p:txBody>
-      </p:sp>
-      <p:sp>
-        <p:nvSpPr>
-          <p:cNvPr id="20" name="TextBox 19"/>
+              <a:t>5,42 M</a:t>
+            </a:r>
+          </a:p>
+        </p:txBody>
+      </p:sp>
+      <p:sp>
+        <p:nvSpPr>
+          <p:cNvPr id="21" name="TextBox 20"/>
           <p:cNvSpPr txBox="1"/>
           <p:nvPr/>
         </p:nvSpPr>
         <p:spPr>
           <a:xfrm>
-            <a:off x="4572000" y="3152648"/>
-            <a:ext cx="2971800" cy="447040"/>
+            <a:off x="4572000" y="3050032"/>
+            <a:ext cx="2971800" cy="248285"/>
           </a:xfrm>
           <a:prstGeom prst="rect">
             <a:avLst/>
@@ -37697,46 +37837,69 @@
           <a:p>
             <a:pPr algn="l">
               <a:lnSpc>
-                <a:spcPts val="1539"/>
+                <a:spcPts val="1495"/>
               </a:lnSpc>
             </a:pPr>
             <a:r>
-              <a:rPr sz="1100" b="0" i="0">
+              <a:rPr sz="1150" b="1" i="0">
                 <a:solidFill>
-                  <a:srgbClr val="0A1A01"/>
+                  <a:srgbClr val="1F5E3A"/>
                 </a:solidFill>
                 <a:latin typeface="Poppins"/>
               </a:rPr>
-              <a:t>d'utilisateurs actifs</a:t>
-            </a:r>
-          </a:p>
+              <a:t>identités sur les réseaux</a:t>
+            </a:r>
+          </a:p>
+        </p:txBody>
+      </p:sp>
+      <p:sp>
+        <p:nvSpPr>
+          <p:cNvPr id="22" name="TextBox 21"/>
+          <p:cNvSpPr txBox="1"/>
+          <p:nvPr/>
+        </p:nvSpPr>
+        <p:spPr>
+          <a:xfrm>
+            <a:off x="4572000" y="3308706"/>
+            <a:ext cx="2971800" cy="204470"/>
+          </a:xfrm>
+          <a:prstGeom prst="rect">
+            <a:avLst/>
+          </a:prstGeom>
+          <a:noFill/>
+        </p:spPr>
+        <p:txBody>
+          <a:bodyPr wrap="none" lIns="0" rIns="0" tIns="0" bIns="0" anchor="t">
+            <a:spAutoFit/>
+          </a:bodyPr>
+          <a:lstStyle/>
           <a:p>
             <a:pPr algn="l">
               <a:lnSpc>
-                <a:spcPts val="1539"/>
+                <a:spcPts val="1242"/>
               </a:lnSpc>
             </a:pPr>
             <a:r>
-              <a:rPr sz="1100" b="0" i="0">
+              <a:rPr sz="919" b="0" i="0">
                 <a:solidFill>
-                  <a:srgbClr val="0A1A01"/>
+                  <a:srgbClr val="42612D"/>
                 </a:solidFill>
                 <a:latin typeface="Poppins"/>
               </a:rPr>
-              <a:t>sur les réseaux sociaux</a:t>
-            </a:r>
-          </a:p>
-        </p:txBody>
-      </p:sp>
-      <p:sp>
-        <p:nvSpPr>
-          <p:cNvPr id="21" name="Rounded Rectangle 20"/>
-          <p:cNvSpPr/>
-          <p:nvPr/>
-        </p:nvSpPr>
-        <p:spPr>
-          <a:xfrm>
-            <a:off x="7975600" y="2438400"/>
+              <a:t>28,5 % de la population, fin 2025</a:t>
+            </a:r>
+          </a:p>
+        </p:txBody>
+      </p:sp>
+      <p:sp>
+        <p:nvSpPr>
+          <p:cNvPr id="23" name="Rounded Rectangle 22"/>
+          <p:cNvSpPr/>
+          <p:nvPr/>
+        </p:nvSpPr>
+        <p:spPr>
+          <a:xfrm>
+            <a:off x="7975600" y="2413000"/>
             <a:ext cx="3403600" cy="1320800"/>
           </a:xfrm>
           <a:prstGeom prst="roundRect">
@@ -37776,13 +37939,13 @@
       </p:sp>
       <p:sp>
         <p:nvSpPr>
-          <p:cNvPr id="22" name="Rounded Rectangle 21"/>
-          <p:cNvSpPr/>
-          <p:nvPr/>
-        </p:nvSpPr>
-        <p:spPr>
-          <a:xfrm>
-            <a:off x="7975600" y="2438400"/>
+          <p:cNvPr id="24" name="Rounded Rectangle 23"/>
+          <p:cNvSpPr/>
+          <p:nvPr/>
+        </p:nvSpPr>
+        <p:spPr>
+          <a:xfrm>
+            <a:off x="7975600" y="2413000"/>
             <a:ext cx="3403600" cy="50800"/>
           </a:xfrm>
           <a:prstGeom prst="roundRect">
@@ -37820,14 +37983,14 @@
       </p:sp>
       <p:sp>
         <p:nvSpPr>
-          <p:cNvPr id="23" name="TextBox 22"/>
+          <p:cNvPr id="25" name="TextBox 24"/>
           <p:cNvSpPr txBox="1"/>
           <p:nvPr/>
         </p:nvSpPr>
         <p:spPr>
           <a:xfrm>
-            <a:off x="8229600" y="2620264"/>
-            <a:ext cx="2921000" cy="438150"/>
+            <a:off x="8229600" y="2537968"/>
+            <a:ext cx="2921000" cy="561340"/>
           </a:xfrm>
           <a:prstGeom prst="rect">
             <a:avLst/>
@@ -37842,31 +38005,31 @@
           <a:p>
             <a:pPr algn="l">
               <a:lnSpc>
-                <a:spcPts val="2530"/>
+                <a:spcPts val="3380"/>
               </a:lnSpc>
             </a:pPr>
             <a:r>
-              <a:rPr sz="2300" b="0" i="0">
+              <a:rPr sz="2600" b="0" i="0">
                 <a:solidFill>
                   <a:srgbClr val="42612D"/>
                 </a:solidFill>
                 <a:latin typeface="Alfa Slab One"/>
               </a:rPr>
-              <a:t>Consommer local</a:t>
-            </a:r>
-          </a:p>
-        </p:txBody>
-      </p:sp>
-      <p:sp>
-        <p:nvSpPr>
-          <p:cNvPr id="24" name="TextBox 23"/>
+              <a:t>63 %</a:t>
+            </a:r>
+          </a:p>
+        </p:txBody>
+      </p:sp>
+      <p:sp>
+        <p:nvSpPr>
+          <p:cNvPr id="26" name="TextBox 25"/>
           <p:cNvSpPr txBox="1"/>
           <p:nvPr/>
         </p:nvSpPr>
         <p:spPr>
           <a:xfrm>
-            <a:off x="8229600" y="3152648"/>
-            <a:ext cx="2971800" cy="447040"/>
+            <a:off x="8229600" y="3050032"/>
+            <a:ext cx="2971800" cy="248285"/>
           </a:xfrm>
           <a:prstGeom prst="rect">
             <a:avLst/>
@@ -37881,46 +38044,154 @@
           <a:p>
             <a:pPr algn="l">
               <a:lnSpc>
-                <a:spcPts val="1539"/>
+                <a:spcPts val="1495"/>
               </a:lnSpc>
             </a:pPr>
             <a:r>
-              <a:rPr sz="1100" b="0" i="0">
+              <a:rPr sz="1150" b="1" i="0">
                 <a:solidFill>
-                  <a:srgbClr val="0A1A01"/>
+                  <a:srgbClr val="1F5E3A"/>
                 </a:solidFill>
                 <a:latin typeface="Poppins"/>
               </a:rPr>
-              <a:t>une dynamique nationale</a:t>
-            </a:r>
-          </a:p>
+              <a:t>des PMI industrielles</a:t>
+            </a:r>
+          </a:p>
+        </p:txBody>
+      </p:sp>
+      <p:sp>
+        <p:nvSpPr>
+          <p:cNvPr id="27" name="TextBox 26"/>
+          <p:cNvSpPr txBox="1"/>
+          <p:nvPr/>
+        </p:nvSpPr>
+        <p:spPr>
+          <a:xfrm>
+            <a:off x="8229600" y="3308706"/>
+            <a:ext cx="2971800" cy="204470"/>
+          </a:xfrm>
+          <a:prstGeom prst="rect">
+            <a:avLst/>
+          </a:prstGeom>
+          <a:noFill/>
+        </p:spPr>
+        <p:txBody>
+          <a:bodyPr wrap="none" lIns="0" rIns="0" tIns="0" bIns="0" anchor="t">
+            <a:spAutoFit/>
+          </a:bodyPr>
+          <a:lstStyle/>
           <a:p>
             <a:pPr algn="l">
               <a:lnSpc>
-                <a:spcPts val="1539"/>
+                <a:spcPts val="1242"/>
               </a:lnSpc>
             </a:pPr>
             <a:r>
-              <a:rPr sz="1100" b="0" i="0">
+              <a:rPr sz="919" b="0" i="0">
                 <a:solidFill>
-                  <a:srgbClr val="0A1A01"/>
+                  <a:srgbClr val="42612D"/>
                 </a:solidFill>
                 <a:latin typeface="Poppins"/>
               </a:rPr>
-              <a:t>qui porte les produits du terroir</a:t>
-            </a:r>
-          </a:p>
-        </p:txBody>
-      </p:sp>
-      <p:sp>
-        <p:nvSpPr>
-          <p:cNvPr id="25" name="TextBox 24"/>
+              <a:t>évoluent dans l'agroalimentaire</a:t>
+            </a:r>
+          </a:p>
+        </p:txBody>
+      </p:sp>
+      <p:sp>
+        <p:nvSpPr>
+          <p:cNvPr id="28" name="Rounded Rectangle 27"/>
+          <p:cNvSpPr/>
+          <p:nvPr/>
+        </p:nvSpPr>
+        <p:spPr>
+          <a:xfrm>
+            <a:off x="660400" y="3860800"/>
+            <a:ext cx="10871200" cy="406400"/>
+          </a:xfrm>
+          <a:prstGeom prst="roundRect">
+            <a:avLst>
+              <a:gd name="adj" fmla="val 25000"/>
+            </a:avLst>
+          </a:prstGeom>
+          <a:solidFill>
+            <a:srgbClr val="1AAB70">
+              <a:alpha val="13000"/>
+            </a:srgbClr>
+          </a:solidFill>
+          <a:ln>
+            <a:noFill/>
+          </a:ln>
+          <a:effectLst/>
+        </p:spPr>
+        <p:style>
+          <a:lnRef idx="1">
+            <a:schemeClr val="accent1"/>
+          </a:lnRef>
+          <a:fillRef idx="3">
+            <a:schemeClr val="accent1"/>
+          </a:fillRef>
+          <a:effectRef idx="2">
+            <a:schemeClr val="accent1"/>
+          </a:effectRef>
+          <a:fontRef idx="minor">
+            <a:schemeClr val="lt1"/>
+          </a:fontRef>
+        </p:style>
+        <p:txBody>
+          <a:bodyPr rtlCol="0" anchor="ctr"/>
+          <a:lstStyle/>
+          <a:p/>
+        </p:txBody>
+      </p:sp>
+      <p:sp>
+        <p:nvSpPr>
+          <p:cNvPr id="29" name="TextBox 28"/>
           <p:cNvSpPr txBox="1"/>
           <p:nvPr/>
         </p:nvSpPr>
         <p:spPr>
           <a:xfrm>
-            <a:off x="635000" y="4018280"/>
+            <a:off x="635000" y="3964432"/>
+            <a:ext cx="10922000" cy="248285"/>
+          </a:xfrm>
+          <a:prstGeom prst="rect">
+            <a:avLst/>
+          </a:prstGeom>
+          <a:noFill/>
+        </p:spPr>
+        <p:txBody>
+          <a:bodyPr wrap="none" lIns="0" rIns="0" tIns="0" bIns="0" anchor="t">
+            <a:spAutoFit/>
+          </a:bodyPr>
+          <a:lstStyle/>
+          <a:p>
+            <a:pPr algn="ctr">
+              <a:lnSpc>
+                <a:spcPts val="1495"/>
+              </a:lnSpc>
+            </a:pPr>
+            <a:r>
+              <a:rPr sz="1150" b="1" i="0">
+                <a:solidFill>
+                  <a:srgbClr val="1F5E3A"/>
+                </a:solidFill>
+                <a:latin typeface="Poppins"/>
+              </a:rPr>
+              <a:t>Les Sénégalais passent en moyenne 2 h 24 par jour sur les réseaux sociaux.</a:t>
+            </a:r>
+          </a:p>
+        </p:txBody>
+      </p:sp>
+      <p:sp>
+        <p:nvSpPr>
+          <p:cNvPr id="30" name="TextBox 29"/>
+          <p:cNvSpPr txBox="1"/>
+          <p:nvPr/>
+        </p:nvSpPr>
+        <p:spPr>
+          <a:xfrm>
+            <a:off x="635000" y="4348480"/>
             <a:ext cx="5130800" cy="215900"/>
           </a:xfrm>
           <a:prstGeom prst="rect">
@@ -37953,18 +38224,18 @@
       </p:sp>
       <p:sp>
         <p:nvSpPr>
-          <p:cNvPr id="26" name="Rounded Rectangle 25"/>
-          <p:cNvSpPr/>
-          <p:nvPr/>
-        </p:nvSpPr>
-        <p:spPr>
-          <a:xfrm>
-            <a:off x="660400" y="4343400"/>
-            <a:ext cx="3403600" cy="1219200"/>
+          <p:cNvPr id="31" name="Rounded Rectangle 30"/>
+          <p:cNvSpPr/>
+          <p:nvPr/>
+        </p:nvSpPr>
+        <p:spPr>
+          <a:xfrm>
+            <a:off x="660400" y="4648200"/>
+            <a:ext cx="3403600" cy="1041400"/>
           </a:xfrm>
           <a:prstGeom prst="roundRect">
             <a:avLst>
-              <a:gd name="adj" fmla="val 9375"/>
+              <a:gd name="adj" fmla="val 10975"/>
             </a:avLst>
           </a:prstGeom>
           <a:solidFill>
@@ -37999,14 +38270,14 @@
       </p:sp>
       <p:sp>
         <p:nvSpPr>
-          <p:cNvPr id="27" name="Rounded Rectangle 26"/>
-          <p:cNvSpPr/>
-          <p:nvPr/>
-        </p:nvSpPr>
-        <p:spPr>
-          <a:xfrm>
-            <a:off x="660400" y="4343400"/>
-            <a:ext cx="50800" cy="1219200"/>
+          <p:cNvPr id="32" name="Rounded Rectangle 31"/>
+          <p:cNvSpPr/>
+          <p:nvPr/>
+        </p:nvSpPr>
+        <p:spPr>
+          <a:xfrm>
+            <a:off x="660400" y="4648200"/>
+            <a:ext cx="50800" cy="1041400"/>
           </a:xfrm>
           <a:prstGeom prst="roundRect">
             <a:avLst>
@@ -38043,13 +38314,13 @@
       </p:sp>
       <p:sp>
         <p:nvSpPr>
-          <p:cNvPr id="28" name="Oval 27"/>
-          <p:cNvSpPr/>
-          <p:nvPr/>
-        </p:nvSpPr>
-        <p:spPr>
-          <a:xfrm>
-            <a:off x="939800" y="4572000"/>
+          <p:cNvPr id="33" name="Oval 32"/>
+          <p:cNvSpPr/>
+          <p:nvPr/>
+        </p:nvSpPr>
+        <p:spPr>
+          <a:xfrm>
+            <a:off x="939800" y="4838700"/>
             <a:ext cx="304800" cy="304800"/>
           </a:xfrm>
           <a:prstGeom prst="ellipse">
@@ -38087,13 +38358,13 @@
       </p:sp>
       <p:sp>
         <p:nvSpPr>
-          <p:cNvPr id="29" name="TextBox 28"/>
+          <p:cNvPr id="34" name="TextBox 33"/>
           <p:cNvSpPr txBox="1"/>
           <p:nvPr/>
         </p:nvSpPr>
         <p:spPr>
           <a:xfrm>
-            <a:off x="914400" y="4625340"/>
+            <a:off x="914400" y="4892040"/>
             <a:ext cx="355600" cy="215900"/>
           </a:xfrm>
           <a:prstGeom prst="rect">
@@ -38126,14 +38397,14 @@
       </p:sp>
       <p:sp>
         <p:nvSpPr>
-          <p:cNvPr id="30" name="TextBox 29"/>
+          <p:cNvPr id="35" name="TextBox 34"/>
           <p:cNvSpPr txBox="1"/>
           <p:nvPr/>
         </p:nvSpPr>
         <p:spPr>
           <a:xfrm>
-            <a:off x="1346200" y="4594352"/>
-            <a:ext cx="2590800" cy="302260"/>
+            <a:off x="1346200" y="4862068"/>
+            <a:ext cx="2590800" cy="291465"/>
           </a:xfrm>
           <a:prstGeom prst="rect">
             <a:avLst/>
@@ -38148,11 +38419,11 @@
           <a:p>
             <a:pPr algn="l">
               <a:lnSpc>
-                <a:spcPts val="1820"/>
+                <a:spcPts val="1755"/>
               </a:lnSpc>
             </a:pPr>
             <a:r>
-              <a:rPr sz="1400" b="1" i="0">
+              <a:rPr sz="1350" b="1" i="0">
                 <a:solidFill>
                   <a:srgbClr val="1F5E3A"/>
                 </a:solidFill>
@@ -38165,14 +38436,14 @@
       </p:sp>
       <p:sp>
         <p:nvSpPr>
-          <p:cNvPr id="31" name="TextBox 30"/>
+          <p:cNvPr id="36" name="TextBox 35"/>
           <p:cNvSpPr txBox="1"/>
           <p:nvPr/>
         </p:nvSpPr>
         <p:spPr>
           <a:xfrm>
-            <a:off x="914400" y="5058664"/>
-            <a:ext cx="2971800" cy="240030"/>
+            <a:off x="914400" y="5275174"/>
+            <a:ext cx="2971800" cy="233172"/>
           </a:xfrm>
           <a:prstGeom prst="rect">
             <a:avLst/>
@@ -38187,11 +38458,11 @@
           <a:p>
             <a:pPr algn="l">
               <a:lnSpc>
-                <a:spcPts val="1470"/>
+                <a:spcPts val="1427"/>
               </a:lnSpc>
             </a:pPr>
             <a:r>
-              <a:rPr sz="1050" b="0" i="0">
+              <a:rPr sz="1019" b="0" i="0">
                 <a:solidFill>
                   <a:srgbClr val="0A1A01"/>
                 </a:solidFill>
@@ -38204,18 +38475,18 @@
       </p:sp>
       <p:sp>
         <p:nvSpPr>
-          <p:cNvPr id="32" name="Rounded Rectangle 31"/>
-          <p:cNvSpPr/>
-          <p:nvPr/>
-        </p:nvSpPr>
-        <p:spPr>
-          <a:xfrm>
-            <a:off x="4318000" y="4343400"/>
-            <a:ext cx="3403600" cy="1219200"/>
+          <p:cNvPr id="37" name="Rounded Rectangle 36"/>
+          <p:cNvSpPr/>
+          <p:nvPr/>
+        </p:nvSpPr>
+        <p:spPr>
+          <a:xfrm>
+            <a:off x="4318000" y="4648200"/>
+            <a:ext cx="3403600" cy="1041400"/>
           </a:xfrm>
           <a:prstGeom prst="roundRect">
             <a:avLst>
-              <a:gd name="adj" fmla="val 9375"/>
+              <a:gd name="adj" fmla="val 10975"/>
             </a:avLst>
           </a:prstGeom>
           <a:solidFill>
@@ -38250,14 +38521,14 @@
       </p:sp>
       <p:sp>
         <p:nvSpPr>
-          <p:cNvPr id="33" name="Rounded Rectangle 32"/>
-          <p:cNvSpPr/>
-          <p:nvPr/>
-        </p:nvSpPr>
-        <p:spPr>
-          <a:xfrm>
-            <a:off x="4318000" y="4343400"/>
-            <a:ext cx="50800" cy="1219200"/>
+          <p:cNvPr id="38" name="Rounded Rectangle 37"/>
+          <p:cNvSpPr/>
+          <p:nvPr/>
+        </p:nvSpPr>
+        <p:spPr>
+          <a:xfrm>
+            <a:off x="4318000" y="4648200"/>
+            <a:ext cx="50800" cy="1041400"/>
           </a:xfrm>
           <a:prstGeom prst="roundRect">
             <a:avLst>
@@ -38294,13 +38565,13 @@
       </p:sp>
       <p:sp>
         <p:nvSpPr>
-          <p:cNvPr id="34" name="Oval 33"/>
-          <p:cNvSpPr/>
-          <p:nvPr/>
-        </p:nvSpPr>
-        <p:spPr>
-          <a:xfrm>
-            <a:off x="4597400" y="4572000"/>
+          <p:cNvPr id="39" name="Oval 38"/>
+          <p:cNvSpPr/>
+          <p:nvPr/>
+        </p:nvSpPr>
+        <p:spPr>
+          <a:xfrm>
+            <a:off x="4597400" y="4838700"/>
             <a:ext cx="304800" cy="304800"/>
           </a:xfrm>
           <a:prstGeom prst="ellipse">
@@ -38338,13 +38609,13 @@
       </p:sp>
       <p:sp>
         <p:nvSpPr>
-          <p:cNvPr id="35" name="TextBox 34"/>
+          <p:cNvPr id="40" name="TextBox 39"/>
           <p:cNvSpPr txBox="1"/>
           <p:nvPr/>
         </p:nvSpPr>
         <p:spPr>
           <a:xfrm>
-            <a:off x="4572000" y="4625340"/>
+            <a:off x="4572000" y="4892040"/>
             <a:ext cx="355600" cy="215900"/>
           </a:xfrm>
           <a:prstGeom prst="rect">
@@ -38377,14 +38648,14 @@
       </p:sp>
       <p:sp>
         <p:nvSpPr>
-          <p:cNvPr id="36" name="TextBox 35"/>
+          <p:cNvPr id="41" name="TextBox 40"/>
           <p:cNvSpPr txBox="1"/>
           <p:nvPr/>
         </p:nvSpPr>
         <p:spPr>
           <a:xfrm>
-            <a:off x="5003800" y="4594352"/>
-            <a:ext cx="2590800" cy="302260"/>
+            <a:off x="5003800" y="4862068"/>
+            <a:ext cx="2590800" cy="291465"/>
           </a:xfrm>
           <a:prstGeom prst="rect">
             <a:avLst/>
@@ -38399,11 +38670,11 @@
           <a:p>
             <a:pPr algn="l">
               <a:lnSpc>
-                <a:spcPts val="1820"/>
+                <a:spcPts val="1755"/>
               </a:lnSpc>
             </a:pPr>
             <a:r>
-              <a:rPr sz="1400" b="1" i="0">
+              <a:rPr sz="1350" b="1" i="0">
                 <a:solidFill>
                   <a:srgbClr val="1F5E3A"/>
                 </a:solidFill>
@@ -38416,14 +38687,14 @@
       </p:sp>
       <p:sp>
         <p:nvSpPr>
-          <p:cNvPr id="37" name="TextBox 36"/>
+          <p:cNvPr id="42" name="TextBox 41"/>
           <p:cNvSpPr txBox="1"/>
           <p:nvPr/>
         </p:nvSpPr>
         <p:spPr>
           <a:xfrm>
-            <a:off x="4572000" y="5058664"/>
-            <a:ext cx="2971800" cy="240030"/>
+            <a:off x="4572000" y="5275174"/>
+            <a:ext cx="2971800" cy="233172"/>
           </a:xfrm>
           <a:prstGeom prst="rect">
             <a:avLst/>
@@ -38438,11 +38709,11 @@
           <a:p>
             <a:pPr algn="l">
               <a:lnSpc>
-                <a:spcPts val="1470"/>
+                <a:spcPts val="1427"/>
               </a:lnSpc>
             </a:pPr>
             <a:r>
-              <a:rPr sz="1050" b="0" i="0">
+              <a:rPr sz="1019" b="0" i="0">
                 <a:solidFill>
                   <a:srgbClr val="0A1A01"/>
                 </a:solidFill>
@@ -38455,18 +38726,18 @@
       </p:sp>
       <p:sp>
         <p:nvSpPr>
-          <p:cNvPr id="38" name="Rounded Rectangle 37"/>
-          <p:cNvSpPr/>
-          <p:nvPr/>
-        </p:nvSpPr>
-        <p:spPr>
-          <a:xfrm>
-            <a:off x="7975600" y="4343400"/>
-            <a:ext cx="3403600" cy="1219200"/>
+          <p:cNvPr id="43" name="Rounded Rectangle 42"/>
+          <p:cNvSpPr/>
+          <p:nvPr/>
+        </p:nvSpPr>
+        <p:spPr>
+          <a:xfrm>
+            <a:off x="7975600" y="4648200"/>
+            <a:ext cx="3403600" cy="1041400"/>
           </a:xfrm>
           <a:prstGeom prst="roundRect">
             <a:avLst>
-              <a:gd name="adj" fmla="val 9375"/>
+              <a:gd name="adj" fmla="val 10975"/>
             </a:avLst>
           </a:prstGeom>
           <a:solidFill>
@@ -38501,14 +38772,14 @@
       </p:sp>
       <p:sp>
         <p:nvSpPr>
-          <p:cNvPr id="39" name="Rounded Rectangle 38"/>
-          <p:cNvSpPr/>
-          <p:nvPr/>
-        </p:nvSpPr>
-        <p:spPr>
-          <a:xfrm>
-            <a:off x="7975600" y="4343400"/>
-            <a:ext cx="50800" cy="1219200"/>
+          <p:cNvPr id="44" name="Rounded Rectangle 43"/>
+          <p:cNvSpPr/>
+          <p:nvPr/>
+        </p:nvSpPr>
+        <p:spPr>
+          <a:xfrm>
+            <a:off x="7975600" y="4648200"/>
+            <a:ext cx="50800" cy="1041400"/>
           </a:xfrm>
           <a:prstGeom prst="roundRect">
             <a:avLst>
@@ -38545,13 +38816,13 @@
       </p:sp>
       <p:sp>
         <p:nvSpPr>
-          <p:cNvPr id="40" name="Oval 39"/>
-          <p:cNvSpPr/>
-          <p:nvPr/>
-        </p:nvSpPr>
-        <p:spPr>
-          <a:xfrm>
-            <a:off x="8255000" y="4572000"/>
+          <p:cNvPr id="45" name="Oval 44"/>
+          <p:cNvSpPr/>
+          <p:nvPr/>
+        </p:nvSpPr>
+        <p:spPr>
+          <a:xfrm>
+            <a:off x="8255000" y="4838700"/>
             <a:ext cx="304800" cy="304800"/>
           </a:xfrm>
           <a:prstGeom prst="ellipse">
@@ -38589,13 +38860,13 @@
       </p:sp>
       <p:sp>
         <p:nvSpPr>
-          <p:cNvPr id="41" name="TextBox 40"/>
+          <p:cNvPr id="46" name="TextBox 45"/>
           <p:cNvSpPr txBox="1"/>
           <p:nvPr/>
         </p:nvSpPr>
         <p:spPr>
           <a:xfrm>
-            <a:off x="8229600" y="4625340"/>
+            <a:off x="8229600" y="4892040"/>
             <a:ext cx="355600" cy="215900"/>
           </a:xfrm>
           <a:prstGeom prst="rect">
@@ -38628,14 +38899,14 @@
       </p:sp>
       <p:sp>
         <p:nvSpPr>
-          <p:cNvPr id="42" name="TextBox 41"/>
+          <p:cNvPr id="47" name="TextBox 46"/>
           <p:cNvSpPr txBox="1"/>
           <p:nvPr/>
         </p:nvSpPr>
         <p:spPr>
           <a:xfrm>
-            <a:off x="8661400" y="4594352"/>
-            <a:ext cx="2590800" cy="302260"/>
+            <a:off x="8661400" y="4862068"/>
+            <a:ext cx="2590800" cy="291465"/>
           </a:xfrm>
           <a:prstGeom prst="rect">
             <a:avLst/>
@@ -38650,11 +38921,11 @@
           <a:p>
             <a:pPr algn="l">
               <a:lnSpc>
-                <a:spcPts val="1820"/>
+                <a:spcPts val="1755"/>
               </a:lnSpc>
             </a:pPr>
             <a:r>
-              <a:rPr sz="1400" b="1" i="0">
+              <a:rPr sz="1350" b="1" i="0">
                 <a:solidFill>
                   <a:srgbClr val="1F5E3A"/>
                 </a:solidFill>
@@ -38667,14 +38938,14 @@
       </p:sp>
       <p:sp>
         <p:nvSpPr>
-          <p:cNvPr id="43" name="TextBox 42"/>
+          <p:cNvPr id="48" name="TextBox 47"/>
           <p:cNvSpPr txBox="1"/>
           <p:nvPr/>
         </p:nvSpPr>
         <p:spPr>
           <a:xfrm>
-            <a:off x="8229600" y="5058664"/>
-            <a:ext cx="2971800" cy="240030"/>
+            <a:off x="8229600" y="5275174"/>
+            <a:ext cx="2971800" cy="233172"/>
           </a:xfrm>
           <a:prstGeom prst="rect">
             <a:avLst/>
@@ -38689,11 +38960,11 @@
           <a:p>
             <a:pPr algn="l">
               <a:lnSpc>
-                <a:spcPts val="1470"/>
+                <a:spcPts val="1427"/>
               </a:lnSpc>
             </a:pPr>
             <a:r>
-              <a:rPr sz="1050" b="0" i="0">
+              <a:rPr sz="1019" b="0" i="0">
                 <a:solidFill>
                   <a:srgbClr val="0A1A01"/>
                 </a:solidFill>
@@ -38706,18 +38977,18 @@
       </p:sp>
       <p:sp>
         <p:nvSpPr>
-          <p:cNvPr id="44" name="Rounded Rectangle 43"/>
-          <p:cNvSpPr/>
-          <p:nvPr/>
-        </p:nvSpPr>
-        <p:spPr>
-          <a:xfrm>
-            <a:off x="660400" y="5740400"/>
-            <a:ext cx="10871200" cy="508000"/>
+          <p:cNvPr id="49" name="Rounded Rectangle 48"/>
+          <p:cNvSpPr/>
+          <p:nvPr/>
+        </p:nvSpPr>
+        <p:spPr>
+          <a:xfrm>
+            <a:off x="660400" y="5842000"/>
+            <a:ext cx="10871200" cy="406400"/>
           </a:xfrm>
           <a:prstGeom prst="roundRect">
             <a:avLst>
-              <a:gd name="adj" fmla="val 22500"/>
+              <a:gd name="adj" fmla="val 25000"/>
             </a:avLst>
           </a:prstGeom>
           <a:solidFill>
@@ -38750,14 +39021,14 @@
       </p:sp>
       <p:sp>
         <p:nvSpPr>
-          <p:cNvPr id="45" name="TextBox 44"/>
+          <p:cNvPr id="50" name="TextBox 49"/>
           <p:cNvSpPr txBox="1"/>
           <p:nvPr/>
         </p:nvSpPr>
         <p:spPr>
           <a:xfrm>
-            <a:off x="635000" y="5867400"/>
-            <a:ext cx="10922000" cy="269875"/>
+            <a:off x="635000" y="5945632"/>
+            <a:ext cx="10922000" cy="248285"/>
           </a:xfrm>
           <a:prstGeom prst="rect">
             <a:avLst/>
@@ -38772,17 +39043,17 @@
           <a:p>
             <a:pPr algn="ctr">
               <a:lnSpc>
-                <a:spcPts val="1625"/>
+                <a:spcPts val="1495"/>
               </a:lnSpc>
             </a:pPr>
             <a:r>
-              <a:rPr sz="1250" b="1" i="0">
+              <a:rPr sz="1150" b="1" i="0">
                 <a:solidFill>
                   <a:srgbClr val="FFFFFF"/>
                 </a:solidFill>
                 <a:latin typeface="Poppins"/>
               </a:rPr>
-              <a:t>Des produits de qualité restent invisibles, pendant que les marques importées occupent le terrain digital.</a:t>
+              <a:t>Des produits de qualité restent invisibles pendant que les marques importées occupent le terrain.</a:t>
             </a:r>
           </a:p>
         </p:txBody>
@@ -45610,11 +45881,11 @@
         <p:spPr>
           <a:xfrm>
             <a:off x="660400" y="2082800"/>
-            <a:ext cx="5334000" cy="2006600"/>
+            <a:ext cx="5334000" cy="2108200"/>
           </a:xfrm>
           <a:prstGeom prst="roundRect">
             <a:avLst>
-              <a:gd name="adj" fmla="val 5696"/>
+              <a:gd name="adj" fmla="val 5421"/>
             </a:avLst>
           </a:prstGeom>
           <a:solidFill>
@@ -45782,8 +46053,8 @@
         </p:nvSpPr>
         <p:spPr>
           <a:xfrm>
-            <a:off x="1143000" y="2619248"/>
-            <a:ext cx="1574800" cy="237490"/>
+            <a:off x="1143000" y="2620264"/>
+            <a:ext cx="4368800" cy="226695"/>
           </a:xfrm>
           <a:prstGeom prst="rect">
             <a:avLst/>
@@ -45798,11 +46069,271 @@
           <a:p>
             <a:pPr algn="l">
               <a:lnSpc>
-                <a:spcPts val="1430"/>
+                <a:spcPts val="1365"/>
               </a:lnSpc>
             </a:pPr>
             <a:r>
-              <a:rPr sz="1100" b="1" i="0">
+              <a:rPr sz="1050" b="1" i="0">
+                <a:solidFill>
+                  <a:srgbClr val="1F5E3A"/>
+                </a:solidFill>
+                <a:latin typeface="Poppins"/>
+              </a:rPr>
+              <a:t>DataReportal / Kepios</a:t>
+            </a:r>
+          </a:p>
+        </p:txBody>
+      </p:sp>
+      <p:sp>
+        <p:nvSpPr>
+          <p:cNvPr id="17" name="TextBox 16"/>
+          <p:cNvSpPr txBox="1"/>
+          <p:nvPr/>
+        </p:nvSpPr>
+        <p:spPr>
+          <a:xfrm>
+            <a:off x="1143000" y="2840431"/>
+            <a:ext cx="4572000" cy="330708"/>
+          </a:xfrm>
+          <a:prstGeom prst="rect">
+            <a:avLst/>
+          </a:prstGeom>
+          <a:noFill/>
+        </p:spPr>
+        <p:txBody>
+          <a:bodyPr wrap="none" lIns="0" rIns="0" tIns="0" bIns="0" anchor="t">
+            <a:spAutoFit/>
+          </a:bodyPr>
+          <a:lstStyle/>
+          <a:p>
+            <a:pPr algn="l">
+              <a:lnSpc>
+                <a:spcPts val="1134"/>
+              </a:lnSpc>
+            </a:pPr>
+            <a:r>
+              <a:rPr sz="840" b="0" i="0">
+                <a:solidFill>
+                  <a:srgbClr val="42612D"/>
+                </a:solidFill>
+                <a:latin typeface="Poppins"/>
+              </a:rPr>
+              <a:t>Digital 2025 Senegal (fin 2025) — 11,5 M d'utilisateurs internet, 5,42 M d'identités</a:t>
+            </a:r>
+          </a:p>
+          <a:p>
+            <a:pPr algn="l">
+              <a:lnSpc>
+                <a:spcPts val="1134"/>
+              </a:lnSpc>
+            </a:pPr>
+            <a:r>
+              <a:rPr sz="840" b="0" i="0">
+                <a:solidFill>
+                  <a:srgbClr val="42612D"/>
+                </a:solidFill>
+                <a:latin typeface="Poppins"/>
+              </a:rPr>
+              <a:t>sociales, 2 h 24 d'usage/jour.</a:t>
+            </a:r>
+          </a:p>
+        </p:txBody>
+      </p:sp>
+      <p:sp>
+        <p:nvSpPr>
+          <p:cNvPr id="18" name="Rounded Rectangle 17"/>
+          <p:cNvSpPr/>
+          <p:nvPr/>
+        </p:nvSpPr>
+        <p:spPr>
+          <a:xfrm>
+            <a:off x="939800" y="3276600"/>
+            <a:ext cx="76200" cy="76200"/>
+          </a:xfrm>
+          <a:prstGeom prst="roundRect">
+            <a:avLst>
+              <a:gd name="adj" fmla="val 50000"/>
+            </a:avLst>
+          </a:prstGeom>
+          <a:solidFill>
+            <a:srgbClr val="1AAB70"/>
+          </a:solidFill>
+          <a:ln>
+            <a:noFill/>
+          </a:ln>
+          <a:effectLst/>
+        </p:spPr>
+        <p:style>
+          <a:lnRef idx="1">
+            <a:schemeClr val="accent1"/>
+          </a:lnRef>
+          <a:fillRef idx="3">
+            <a:schemeClr val="accent1"/>
+          </a:fillRef>
+          <a:effectRef idx="2">
+            <a:schemeClr val="accent1"/>
+          </a:effectRef>
+          <a:fontRef idx="minor">
+            <a:schemeClr val="lt1"/>
+          </a:fontRef>
+        </p:style>
+        <p:txBody>
+          <a:bodyPr rtlCol="0" anchor="ctr"/>
+          <a:lstStyle/>
+          <a:p/>
+        </p:txBody>
+      </p:sp>
+      <p:sp>
+        <p:nvSpPr>
+          <p:cNvPr id="19" name="TextBox 18"/>
+          <p:cNvSpPr txBox="1"/>
+          <p:nvPr/>
+        </p:nvSpPr>
+        <p:spPr>
+          <a:xfrm>
+            <a:off x="1143000" y="3179064"/>
+            <a:ext cx="4368800" cy="226695"/>
+          </a:xfrm>
+          <a:prstGeom prst="rect">
+            <a:avLst/>
+          </a:prstGeom>
+          <a:noFill/>
+        </p:spPr>
+        <p:txBody>
+          <a:bodyPr wrap="none" lIns="0" rIns="0" tIns="0" bIns="0" anchor="t">
+            <a:spAutoFit/>
+          </a:bodyPr>
+          <a:lstStyle/>
+          <a:p>
+            <a:pPr algn="l">
+              <a:lnSpc>
+                <a:spcPts val="1365"/>
+              </a:lnSpc>
+            </a:pPr>
+            <a:r>
+              <a:rPr sz="1050" b="1" i="0">
+                <a:solidFill>
+                  <a:srgbClr val="1F5E3A"/>
+                </a:solidFill>
+                <a:latin typeface="Poppins"/>
+              </a:rPr>
+              <a:t>Ministère du Développement industriel</a:t>
+            </a:r>
+          </a:p>
+        </p:txBody>
+      </p:sp>
+      <p:sp>
+        <p:nvSpPr>
+          <p:cNvPr id="20" name="TextBox 19"/>
+          <p:cNvSpPr txBox="1"/>
+          <p:nvPr/>
+        </p:nvSpPr>
+        <p:spPr>
+          <a:xfrm>
+            <a:off x="1143000" y="3399231"/>
+            <a:ext cx="4572000" cy="186690"/>
+          </a:xfrm>
+          <a:prstGeom prst="rect">
+            <a:avLst/>
+          </a:prstGeom>
+          <a:noFill/>
+        </p:spPr>
+        <p:txBody>
+          <a:bodyPr wrap="none" lIns="0" rIns="0" tIns="0" bIns="0" anchor="t">
+            <a:spAutoFit/>
+          </a:bodyPr>
+          <a:lstStyle/>
+          <a:p>
+            <a:pPr algn="l">
+              <a:lnSpc>
+                <a:spcPts val="1134"/>
+              </a:lnSpc>
+            </a:pPr>
+            <a:r>
+              <a:rPr sz="840" b="0" i="0">
+                <a:solidFill>
+                  <a:srgbClr val="42612D"/>
+                </a:solidFill>
+                <a:latin typeface="Poppins"/>
+              </a:rPr>
+              <a:t>Données 2022 — 63 % des PMI industrielles évoluent dans l'agroalimentaire.</a:t>
+            </a:r>
+          </a:p>
+        </p:txBody>
+      </p:sp>
+      <p:sp>
+        <p:nvSpPr>
+          <p:cNvPr id="21" name="Rounded Rectangle 20"/>
+          <p:cNvSpPr/>
+          <p:nvPr/>
+        </p:nvSpPr>
+        <p:spPr>
+          <a:xfrm>
+            <a:off x="939800" y="3835400"/>
+            <a:ext cx="76200" cy="76200"/>
+          </a:xfrm>
+          <a:prstGeom prst="roundRect">
+            <a:avLst>
+              <a:gd name="adj" fmla="val 50000"/>
+            </a:avLst>
+          </a:prstGeom>
+          <a:solidFill>
+            <a:srgbClr val="1AAB70"/>
+          </a:solidFill>
+          <a:ln>
+            <a:noFill/>
+          </a:ln>
+          <a:effectLst/>
+        </p:spPr>
+        <p:style>
+          <a:lnRef idx="1">
+            <a:schemeClr val="accent1"/>
+          </a:lnRef>
+          <a:fillRef idx="3">
+            <a:schemeClr val="accent1"/>
+          </a:fillRef>
+          <a:effectRef idx="2">
+            <a:schemeClr val="accent1"/>
+          </a:effectRef>
+          <a:fontRef idx="minor">
+            <a:schemeClr val="lt1"/>
+          </a:fontRef>
+        </p:style>
+        <p:txBody>
+          <a:bodyPr rtlCol="0" anchor="ctr"/>
+          <a:lstStyle/>
+          <a:p/>
+        </p:txBody>
+      </p:sp>
+      <p:sp>
+        <p:nvSpPr>
+          <p:cNvPr id="22" name="TextBox 21"/>
+          <p:cNvSpPr txBox="1"/>
+          <p:nvPr/>
+        </p:nvSpPr>
+        <p:spPr>
+          <a:xfrm>
+            <a:off x="1143000" y="3737864"/>
+            <a:ext cx="4368800" cy="226695"/>
+          </a:xfrm>
+          <a:prstGeom prst="rect">
+            <a:avLst/>
+          </a:prstGeom>
+          <a:noFill/>
+        </p:spPr>
+        <p:txBody>
+          <a:bodyPr wrap="none" lIns="0" rIns="0" tIns="0" bIns="0" anchor="t">
+            <a:spAutoFit/>
+          </a:bodyPr>
+          <a:lstStyle/>
+          <a:p>
+            <a:pPr algn="l">
+              <a:lnSpc>
+                <a:spcPts val="1365"/>
+              </a:lnSpc>
+            </a:pPr>
+            <a:r>
+              <a:rPr sz="1050" b="1" i="0">
                 <a:solidFill>
                   <a:srgbClr val="1F5E3A"/>
                 </a:solidFill>
@@ -45815,14 +46346,14 @@
       </p:sp>
       <p:sp>
         <p:nvSpPr>
-          <p:cNvPr id="17" name="TextBox 16"/>
+          <p:cNvPr id="23" name="TextBox 22"/>
           <p:cNvSpPr txBox="1"/>
           <p:nvPr/>
         </p:nvSpPr>
         <p:spPr>
           <a:xfrm>
-            <a:off x="1143000" y="2826918"/>
-            <a:ext cx="4572000" cy="346456"/>
+            <a:off x="1143000" y="3958031"/>
+            <a:ext cx="4572000" cy="186690"/>
           </a:xfrm>
           <a:prstGeom prst="rect">
             <a:avLst/>
@@ -45837,295 +46368,35 @@
           <a:p>
             <a:pPr algn="l">
               <a:lnSpc>
-                <a:spcPts val="1188"/>
+                <a:spcPts val="1134"/>
               </a:lnSpc>
             </a:pPr>
             <a:r>
-              <a:rPr sz="880" b="0" i="0">
+              <a:rPr sz="840" b="0" i="0">
                 <a:solidFill>
                   <a:srgbClr val="42612D"/>
                 </a:solidFill>
                 <a:latin typeface="Poppins"/>
               </a:rPr>
-              <a:t>Agence Nationale de la Statistique et de la Démographie — données agricoles</a:t>
-            </a:r>
-          </a:p>
-          <a:p>
-            <a:pPr algn="l">
-              <a:lnSpc>
-                <a:spcPts val="1188"/>
-              </a:lnSpc>
-            </a:pPr>
-            <a:r>
-              <a:rPr sz="880" b="0" i="0">
-                <a:solidFill>
-                  <a:srgbClr val="42612D"/>
-                </a:solidFill>
-                <a:latin typeface="Poppins"/>
-              </a:rPr>
-              <a:t>du Sénégal.</a:t>
-            </a:r>
-          </a:p>
-        </p:txBody>
-      </p:sp>
-      <p:sp>
-        <p:nvSpPr>
-          <p:cNvPr id="18" name="Rounded Rectangle 17"/>
-          <p:cNvSpPr/>
-          <p:nvPr/>
-        </p:nvSpPr>
-        <p:spPr>
-          <a:xfrm>
-            <a:off x="939800" y="3200400"/>
-            <a:ext cx="76200" cy="76200"/>
+              <a:t>Agence Nationale de la Statistique et de la Démographie.</a:t>
+            </a:r>
+          </a:p>
+        </p:txBody>
+      </p:sp>
+      <p:sp>
+        <p:nvSpPr>
+          <p:cNvPr id="24" name="Rounded Rectangle 23"/>
+          <p:cNvSpPr/>
+          <p:nvPr/>
+        </p:nvSpPr>
+        <p:spPr>
+          <a:xfrm>
+            <a:off x="6197600" y="2082800"/>
+            <a:ext cx="5334000" cy="2108200"/>
           </a:xfrm>
           <a:prstGeom prst="roundRect">
             <a:avLst>
-              <a:gd name="adj" fmla="val 50000"/>
-            </a:avLst>
-          </a:prstGeom>
-          <a:solidFill>
-            <a:srgbClr val="1AAB70"/>
-          </a:solidFill>
-          <a:ln>
-            <a:noFill/>
-          </a:ln>
-          <a:effectLst/>
-        </p:spPr>
-        <p:style>
-          <a:lnRef idx="1">
-            <a:schemeClr val="accent1"/>
-          </a:lnRef>
-          <a:fillRef idx="3">
-            <a:schemeClr val="accent1"/>
-          </a:fillRef>
-          <a:effectRef idx="2">
-            <a:schemeClr val="accent1"/>
-          </a:effectRef>
-          <a:fontRef idx="minor">
-            <a:schemeClr val="lt1"/>
-          </a:fontRef>
-        </p:style>
-        <p:txBody>
-          <a:bodyPr rtlCol="0" anchor="ctr"/>
-          <a:lstStyle/>
-          <a:p/>
-        </p:txBody>
-      </p:sp>
-      <p:sp>
-        <p:nvSpPr>
-          <p:cNvPr id="19" name="TextBox 18"/>
-          <p:cNvSpPr txBox="1"/>
-          <p:nvPr/>
-        </p:nvSpPr>
-        <p:spPr>
-          <a:xfrm>
-            <a:off x="1143000" y="3101848"/>
-            <a:ext cx="1574800" cy="237490"/>
-          </a:xfrm>
-          <a:prstGeom prst="rect">
-            <a:avLst/>
-          </a:prstGeom>
-          <a:noFill/>
-        </p:spPr>
-        <p:txBody>
-          <a:bodyPr wrap="none" lIns="0" rIns="0" tIns="0" bIns="0" anchor="t">
-            <a:spAutoFit/>
-          </a:bodyPr>
-          <a:lstStyle/>
-          <a:p>
-            <a:pPr algn="l">
-              <a:lnSpc>
-                <a:spcPts val="1430"/>
-              </a:lnSpc>
-            </a:pPr>
-            <a:r>
-              <a:rPr sz="1100" b="1" i="0">
-                <a:solidFill>
-                  <a:srgbClr val="1F5E3A"/>
-                </a:solidFill>
-                <a:latin typeface="Poppins"/>
-              </a:rPr>
-              <a:t>DataReportal</a:t>
-            </a:r>
-          </a:p>
-        </p:txBody>
-      </p:sp>
-      <p:sp>
-        <p:nvSpPr>
-          <p:cNvPr id="20" name="TextBox 19"/>
-          <p:cNvSpPr txBox="1"/>
-          <p:nvPr/>
-        </p:nvSpPr>
-        <p:spPr>
-          <a:xfrm>
-            <a:off x="1143000" y="3309518"/>
-            <a:ext cx="4572000" cy="195580"/>
-          </a:xfrm>
-          <a:prstGeom prst="rect">
-            <a:avLst/>
-          </a:prstGeom>
-          <a:noFill/>
-        </p:spPr>
-        <p:txBody>
-          <a:bodyPr wrap="none" lIns="0" rIns="0" tIns="0" bIns="0" anchor="t">
-            <a:spAutoFit/>
-          </a:bodyPr>
-          <a:lstStyle/>
-          <a:p>
-            <a:pPr algn="l">
-              <a:lnSpc>
-                <a:spcPts val="1188"/>
-              </a:lnSpc>
-            </a:pPr>
-            <a:r>
-              <a:rPr sz="880" b="0" i="0">
-                <a:solidFill>
-                  <a:srgbClr val="42612D"/>
-                </a:solidFill>
-                <a:latin typeface="Poppins"/>
-              </a:rPr>
-              <a:t>Digital 2025 Senegal — usages des réseaux sociaux.</a:t>
-            </a:r>
-          </a:p>
-        </p:txBody>
-      </p:sp>
-      <p:sp>
-        <p:nvSpPr>
-          <p:cNvPr id="21" name="Rounded Rectangle 20"/>
-          <p:cNvSpPr/>
-          <p:nvPr/>
-        </p:nvSpPr>
-        <p:spPr>
-          <a:xfrm>
-            <a:off x="939800" y="3683000"/>
-            <a:ext cx="76200" cy="76200"/>
-          </a:xfrm>
-          <a:prstGeom prst="roundRect">
-            <a:avLst>
-              <a:gd name="adj" fmla="val 50000"/>
-            </a:avLst>
-          </a:prstGeom>
-          <a:solidFill>
-            <a:srgbClr val="1AAB70"/>
-          </a:solidFill>
-          <a:ln>
-            <a:noFill/>
-          </a:ln>
-          <a:effectLst/>
-        </p:spPr>
-        <p:style>
-          <a:lnRef idx="1">
-            <a:schemeClr val="accent1"/>
-          </a:lnRef>
-          <a:fillRef idx="3">
-            <a:schemeClr val="accent1"/>
-          </a:fillRef>
-          <a:effectRef idx="2">
-            <a:schemeClr val="accent1"/>
-          </a:effectRef>
-          <a:fontRef idx="minor">
-            <a:schemeClr val="lt1"/>
-          </a:fontRef>
-        </p:style>
-        <p:txBody>
-          <a:bodyPr rtlCol="0" anchor="ctr"/>
-          <a:lstStyle/>
-          <a:p/>
-        </p:txBody>
-      </p:sp>
-      <p:sp>
-        <p:nvSpPr>
-          <p:cNvPr id="22" name="TextBox 21"/>
-          <p:cNvSpPr txBox="1"/>
-          <p:nvPr/>
-        </p:nvSpPr>
-        <p:spPr>
-          <a:xfrm>
-            <a:off x="1143000" y="3584448"/>
-            <a:ext cx="1574800" cy="237490"/>
-          </a:xfrm>
-          <a:prstGeom prst="rect">
-            <a:avLst/>
-          </a:prstGeom>
-          <a:noFill/>
-        </p:spPr>
-        <p:txBody>
-          <a:bodyPr wrap="none" lIns="0" rIns="0" tIns="0" bIns="0" anchor="t">
-            <a:spAutoFit/>
-          </a:bodyPr>
-          <a:lstStyle/>
-          <a:p>
-            <a:pPr algn="l">
-              <a:lnSpc>
-                <a:spcPts val="1430"/>
-              </a:lnSpc>
-            </a:pPr>
-            <a:r>
-              <a:rPr sz="1100" b="1" i="0">
-                <a:solidFill>
-                  <a:srgbClr val="1F5E3A"/>
-                </a:solidFill>
-                <a:latin typeface="Poppins"/>
-              </a:rPr>
-              <a:t>FAO</a:t>
-            </a:r>
-          </a:p>
-        </p:txBody>
-      </p:sp>
-      <p:sp>
-        <p:nvSpPr>
-          <p:cNvPr id="23" name="TextBox 22"/>
-          <p:cNvSpPr txBox="1"/>
-          <p:nvPr/>
-        </p:nvSpPr>
-        <p:spPr>
-          <a:xfrm>
-            <a:off x="1143000" y="3792118"/>
-            <a:ext cx="4572000" cy="195580"/>
-          </a:xfrm>
-          <a:prstGeom prst="rect">
-            <a:avLst/>
-          </a:prstGeom>
-          <a:noFill/>
-        </p:spPr>
-        <p:txBody>
-          <a:bodyPr wrap="none" lIns="0" rIns="0" tIns="0" bIns="0" anchor="t">
-            <a:spAutoFit/>
-          </a:bodyPr>
-          <a:lstStyle/>
-          <a:p>
-            <a:pPr algn="l">
-              <a:lnSpc>
-                <a:spcPts val="1188"/>
-              </a:lnSpc>
-            </a:pPr>
-            <a:r>
-              <a:rPr sz="880" b="0" i="0">
-                <a:solidFill>
-                  <a:srgbClr val="42612D"/>
-                </a:solidFill>
-                <a:latin typeface="Poppins"/>
-              </a:rPr>
-              <a:t>Profils des filières agroalimentaires ouest-africaines.</a:t>
-            </a:r>
-          </a:p>
-        </p:txBody>
-      </p:sp>
-      <p:sp>
-        <p:nvSpPr>
-          <p:cNvPr id="24" name="Rounded Rectangle 23"/>
-          <p:cNvSpPr/>
-          <p:nvPr/>
-        </p:nvSpPr>
-        <p:spPr>
-          <a:xfrm>
-            <a:off x="6197600" y="2082800"/>
-            <a:ext cx="5334000" cy="2006600"/>
-          </a:xfrm>
-          <a:prstGeom prst="roundRect">
-            <a:avLst>
-              <a:gd name="adj" fmla="val 5696"/>
+              <a:gd name="adj" fmla="val 5421"/>
             </a:avLst>
           </a:prstGeom>
           <a:solidFill>
@@ -46387,7 +46658,7 @@
         </p:nvSpPr>
         <p:spPr>
           <a:xfrm>
-            <a:off x="6477000" y="3200400"/>
+            <a:off x="6477000" y="3276600"/>
             <a:ext cx="76200" cy="76200"/>
           </a:xfrm>
           <a:prstGeom prst="roundRect">
@@ -46431,7 +46702,7 @@
         </p:nvSpPr>
         <p:spPr>
           <a:xfrm>
-            <a:off x="6680200" y="3101848"/>
+            <a:off x="6680200" y="3178048"/>
             <a:ext cx="1574800" cy="237490"/>
           </a:xfrm>
           <a:prstGeom prst="rect">
@@ -46470,7 +46741,7 @@
         </p:nvSpPr>
         <p:spPr>
           <a:xfrm>
-            <a:off x="6680200" y="3309518"/>
+            <a:off x="6680200" y="3385718"/>
             <a:ext cx="4572000" cy="195580"/>
           </a:xfrm>
           <a:prstGeom prst="rect">
@@ -46509,7 +46780,7 @@
         </p:nvSpPr>
         <p:spPr>
           <a:xfrm>
-            <a:off x="6477000" y="3683000"/>
+            <a:off x="6477000" y="3835400"/>
             <a:ext cx="76200" cy="76200"/>
           </a:xfrm>
           <a:prstGeom prst="roundRect">
@@ -46553,7 +46824,7 @@
         </p:nvSpPr>
         <p:spPr>
           <a:xfrm>
-            <a:off x="6680200" y="3584448"/>
+            <a:off x="6680200" y="3736848"/>
             <a:ext cx="1574800" cy="237490"/>
           </a:xfrm>
           <a:prstGeom prst="rect">
@@ -46592,7 +46863,7 @@
         </p:nvSpPr>
         <p:spPr>
           <a:xfrm>
-            <a:off x="6680200" y="3792118"/>
+            <a:off x="6680200" y="3944518"/>
             <a:ext cx="4572000" cy="195580"/>
           </a:xfrm>
           <a:prstGeom prst="rect">
@@ -46631,12 +46902,12 @@
         </p:nvSpPr>
         <p:spPr>
           <a:xfrm>
-            <a:off x="660400" y="4292600"/>
-            <a:ext cx="5334000" cy="1727200"/>
+            <a:off x="660400" y="4394200"/>
+            <a:ext cx="5334000" cy="1651000"/>
           </a:xfrm>
           <a:prstGeom prst="roundRect">
             <a:avLst>
-              <a:gd name="adj" fmla="val 6617"/>
+              <a:gd name="adj" fmla="val 6923"/>
             </a:avLst>
           </a:prstGeom>
           <a:solidFill>
@@ -46677,7 +46948,7 @@
         </p:nvSpPr>
         <p:spPr>
           <a:xfrm>
-            <a:off x="660400" y="4292600"/>
+            <a:off x="660400" y="4394200"/>
             <a:ext cx="5334000" cy="50800"/>
           </a:xfrm>
           <a:prstGeom prst="roundRect">
@@ -46721,7 +46992,7 @@
         </p:nvSpPr>
         <p:spPr>
           <a:xfrm>
-            <a:off x="914400" y="4501896"/>
+            <a:off x="914400" y="4578096"/>
             <a:ext cx="4368800" cy="205105"/>
           </a:xfrm>
           <a:prstGeom prst="rect">
@@ -46760,7 +47031,7 @@
         </p:nvSpPr>
         <p:spPr>
           <a:xfrm>
-            <a:off x="939800" y="4927600"/>
+            <a:off x="939800" y="5003800"/>
             <a:ext cx="76200" cy="76200"/>
           </a:xfrm>
           <a:prstGeom prst="roundRect">
@@ -46804,7 +47075,7 @@
         </p:nvSpPr>
         <p:spPr>
           <a:xfrm>
-            <a:off x="1143000" y="4830064"/>
+            <a:off x="1143000" y="4906264"/>
             <a:ext cx="1955800" cy="226695"/>
           </a:xfrm>
           <a:prstGeom prst="rect">
@@ -46843,8 +47114,8 @@
         </p:nvSpPr>
         <p:spPr>
           <a:xfrm>
-            <a:off x="3073400" y="4846218"/>
-            <a:ext cx="2692400" cy="189992"/>
+            <a:off x="3022600" y="4923231"/>
+            <a:ext cx="2768600" cy="181356"/>
           </a:xfrm>
           <a:prstGeom prst="rect">
             <a:avLst/>
@@ -46859,17 +47130,17 @@
           <a:p>
             <a:pPr algn="l">
               <a:lnSpc>
-                <a:spcPts val="1144"/>
+                <a:spcPts val="1092"/>
               </a:lnSpc>
             </a:pPr>
             <a:r>
-              <a:rPr sz="880" b="0" i="0">
+              <a:rPr sz="840" b="0" i="0">
                 <a:solidFill>
                   <a:srgbClr val="42612D"/>
                 </a:solidFill>
                 <a:latin typeface="Poppins"/>
               </a:rPr>
-              <a:t>Offres et positionnement — site officiel.</a:t>
+              <a:t>250 000 – 600 000 FCFA/mois — site officiel.</a:t>
             </a:r>
           </a:p>
         </p:txBody>
@@ -46882,7 +47153,7 @@
         </p:nvSpPr>
         <p:spPr>
           <a:xfrm>
-            <a:off x="939800" y="5334000"/>
+            <a:off x="939800" y="5384800"/>
             <a:ext cx="76200" cy="76200"/>
           </a:xfrm>
           <a:prstGeom prst="roundRect">
@@ -46926,7 +47197,7 @@
         </p:nvSpPr>
         <p:spPr>
           <a:xfrm>
-            <a:off x="1143000" y="5236464"/>
+            <a:off x="1143000" y="5287264"/>
             <a:ext cx="1955800" cy="226695"/>
           </a:xfrm>
           <a:prstGeom prst="rect">
@@ -46965,8 +47236,8 @@
         </p:nvSpPr>
         <p:spPr>
           <a:xfrm>
-            <a:off x="3073400" y="5252618"/>
-            <a:ext cx="2692400" cy="189992"/>
+            <a:off x="3022600" y="5304231"/>
+            <a:ext cx="2768600" cy="181356"/>
           </a:xfrm>
           <a:prstGeom prst="rect">
             <a:avLst/>
@@ -46981,17 +47252,17 @@
           <a:p>
             <a:pPr algn="l">
               <a:lnSpc>
-                <a:spcPts val="1144"/>
+                <a:spcPts val="1092"/>
               </a:lnSpc>
             </a:pPr>
             <a:r>
-              <a:rPr sz="880" b="0" i="0">
+              <a:rPr sz="840" b="0" i="0">
                 <a:solidFill>
                   <a:srgbClr val="42612D"/>
                 </a:solidFill>
                 <a:latin typeface="Poppins"/>
               </a:rPr>
-              <a:t>Grille tarifaire et prestations — site officiel.</a:t>
+              <a:t>Dès 130 000 FCFA/mois — site officiel.</a:t>
             </a:r>
           </a:p>
         </p:txBody>
@@ -47004,7 +47275,7 @@
         </p:nvSpPr>
         <p:spPr>
           <a:xfrm>
-            <a:off x="939800" y="5740400"/>
+            <a:off x="939800" y="5765800"/>
             <a:ext cx="76200" cy="76200"/>
           </a:xfrm>
           <a:prstGeom prst="roundRect">
@@ -47048,7 +47319,7 @@
         </p:nvSpPr>
         <p:spPr>
           <a:xfrm>
-            <a:off x="1143000" y="5642864"/>
+            <a:off x="1143000" y="5668264"/>
             <a:ext cx="1955800" cy="226695"/>
           </a:xfrm>
           <a:prstGeom prst="rect">
@@ -47074,7 +47345,7 @@
                 </a:solidFill>
                 <a:latin typeface="Poppins"/>
               </a:rPr>
-              <a:t>Freelances CM</a:t>
+              <a:t>CM freelance</a:t>
             </a:r>
           </a:p>
         </p:txBody>
@@ -47087,8 +47358,8 @@
         </p:nvSpPr>
         <p:spPr>
           <a:xfrm>
-            <a:off x="3073400" y="5659018"/>
-            <a:ext cx="2692400" cy="189992"/>
+            <a:off x="3022600" y="5685231"/>
+            <a:ext cx="2768600" cy="181356"/>
           </a:xfrm>
           <a:prstGeom prst="rect">
             <a:avLst/>
@@ -47103,17 +47374,17 @@
           <a:p>
             <a:pPr algn="l">
               <a:lnSpc>
-                <a:spcPts val="1144"/>
+                <a:spcPts val="1092"/>
               </a:lnSpc>
             </a:pPr>
             <a:r>
-              <a:rPr sz="880" b="0" i="0">
+              <a:rPr sz="840" b="0" i="0">
                 <a:solidFill>
                   <a:srgbClr val="42612D"/>
                 </a:solidFill>
                 <a:latin typeface="Poppins"/>
               </a:rPr>
-              <a:t>Relevé de tarifs pratiqués au Sénégal, 2025.</a:t>
+              <a:t>50 000 – 150 000 FCFA/mois — relevé 2025.</a:t>
             </a:r>
           </a:p>
         </p:txBody>
@@ -47126,12 +47397,12 @@
         </p:nvSpPr>
         <p:spPr>
           <a:xfrm>
-            <a:off x="6197600" y="4292600"/>
-            <a:ext cx="5334000" cy="1727200"/>
+            <a:off x="6197600" y="4394200"/>
+            <a:ext cx="5334000" cy="1651000"/>
           </a:xfrm>
           <a:prstGeom prst="roundRect">
             <a:avLst>
-              <a:gd name="adj" fmla="val 6617"/>
+              <a:gd name="adj" fmla="val 6923"/>
             </a:avLst>
           </a:prstGeom>
           <a:solidFill>
@@ -47170,7 +47441,7 @@
         </p:nvSpPr>
         <p:spPr>
           <a:xfrm>
-            <a:off x="6451600" y="4501896"/>
+            <a:off x="6451600" y="4578096"/>
             <a:ext cx="4368800" cy="205105"/>
           </a:xfrm>
           <a:prstGeom prst="rect">
@@ -47209,7 +47480,7 @@
         </p:nvSpPr>
         <p:spPr>
           <a:xfrm>
-            <a:off x="6477000" y="4940300"/>
+            <a:off x="6477000" y="5016500"/>
             <a:ext cx="76200" cy="76200"/>
           </a:xfrm>
           <a:prstGeom prst="roundRect">
@@ -47253,7 +47524,7 @@
         </p:nvSpPr>
         <p:spPr>
           <a:xfrm>
-            <a:off x="6680200" y="4856480"/>
+            <a:off x="6680200" y="4932680"/>
             <a:ext cx="2336800" cy="215900"/>
           </a:xfrm>
           <a:prstGeom prst="rect">
@@ -47292,7 +47563,7 @@
         </p:nvSpPr>
         <p:spPr>
           <a:xfrm>
-            <a:off x="8966200" y="4940300"/>
+            <a:off x="8966200" y="5016500"/>
             <a:ext cx="76200" cy="76200"/>
           </a:xfrm>
           <a:prstGeom prst="roundRect">
@@ -47336,7 +47607,7 @@
         </p:nvSpPr>
         <p:spPr>
           <a:xfrm>
-            <a:off x="9169400" y="4856480"/>
+            <a:off x="9169400" y="4932680"/>
             <a:ext cx="2336800" cy="215900"/>
           </a:xfrm>
           <a:prstGeom prst="rect">
@@ -47375,7 +47646,7 @@
         </p:nvSpPr>
         <p:spPr>
           <a:xfrm>
-            <a:off x="6477000" y="5295900"/>
+            <a:off x="6477000" y="5359400"/>
             <a:ext cx="76200" cy="76200"/>
           </a:xfrm>
           <a:prstGeom prst="roundRect">
@@ -47419,7 +47690,7 @@
         </p:nvSpPr>
         <p:spPr>
           <a:xfrm>
-            <a:off x="6680200" y="5212080"/>
+            <a:off x="6680200" y="5275580"/>
             <a:ext cx="2336800" cy="215900"/>
           </a:xfrm>
           <a:prstGeom prst="rect">
@@ -47458,7 +47729,7 @@
         </p:nvSpPr>
         <p:spPr>
           <a:xfrm>
-            <a:off x="8966200" y="5295900"/>
+            <a:off x="8966200" y="5359400"/>
             <a:ext cx="76200" cy="76200"/>
           </a:xfrm>
           <a:prstGeom prst="roundRect">
@@ -47502,7 +47773,7 @@
         </p:nvSpPr>
         <p:spPr>
           <a:xfrm>
-            <a:off x="9169400" y="5212080"/>
+            <a:off x="9169400" y="5275580"/>
             <a:ext cx="2336800" cy="215900"/>
           </a:xfrm>
           <a:prstGeom prst="rect">
@@ -47541,7 +47812,7 @@
         </p:nvSpPr>
         <p:spPr>
           <a:xfrm>
-            <a:off x="6477000" y="5651500"/>
+            <a:off x="6477000" y="5702300"/>
             <a:ext cx="76200" cy="76200"/>
           </a:xfrm>
           <a:prstGeom prst="roundRect">
@@ -47585,7 +47856,7 @@
         </p:nvSpPr>
         <p:spPr>
           <a:xfrm>
-            <a:off x="6680200" y="5567680"/>
+            <a:off x="6680200" y="5618480"/>
             <a:ext cx="2336800" cy="215900"/>
           </a:xfrm>
           <a:prstGeom prst="rect">
@@ -47624,7 +47895,7 @@
         </p:nvSpPr>
         <p:spPr>
           <a:xfrm>
-            <a:off x="8966200" y="5651500"/>
+            <a:off x="8966200" y="5702300"/>
             <a:ext cx="76200" cy="76200"/>
           </a:xfrm>
           <a:prstGeom prst="roundRect">
@@ -47668,7 +47939,7 @@
         </p:nvSpPr>
         <p:spPr>
           <a:xfrm>
-            <a:off x="9169400" y="5567680"/>
+            <a:off x="9169400" y="5618480"/>
             <a:ext cx="2336800" cy="215900"/>
           </a:xfrm>
           <a:prstGeom prst="rect">

</xml_diff>

<commit_message>
Page marche cible: suppression des descriptions, ajout d'icones vectorielles par cible
Co-authored-by: arena-agent <297053741+arena-agent@users.noreply.github.com>
</commit_message>
<xml_diff>
--- a/Pitch_Deck_Sadiya_Digital_Agri.pptx
+++ b/Pitch_Deck_Sadiya_Digital_Agri.pptx
@@ -50985,12 +50985,12 @@
         </p:nvSpPr>
         <p:spPr>
           <a:xfrm>
-            <a:off x="660400" y="1981200"/>
-            <a:ext cx="2946400" cy="1219200"/>
+            <a:off x="660400" y="2133600"/>
+            <a:ext cx="2946400" cy="914400"/>
           </a:xfrm>
           <a:prstGeom prst="roundRect">
             <a:avLst>
-              <a:gd name="adj" fmla="val 10416"/>
+              <a:gd name="adj" fmla="val 13888"/>
             </a:avLst>
           </a:prstGeom>
           <a:solidFill>
@@ -51031,13 +51031,92 @@
         </p:nvSpPr>
         <p:spPr>
           <a:xfrm>
-            <a:off x="863600" y="2159000"/>
-            <a:ext cx="254000" cy="254000"/>
+            <a:off x="863600" y="2387600"/>
+            <a:ext cx="431800" cy="431800"/>
           </a:xfrm>
           <a:prstGeom prst="ellipse">
             <a:avLst/>
           </a:prstGeom>
           <a:solidFill>
+            <a:srgbClr val="1AAB70"/>
+          </a:solidFill>
+          <a:ln>
+            <a:noFill/>
+          </a:ln>
+          <a:effectLst/>
+        </p:spPr>
+        <p:style>
+          <a:lnRef idx="1">
+            <a:schemeClr val="accent1"/>
+          </a:lnRef>
+          <a:fillRef idx="3">
+            <a:schemeClr val="accent1"/>
+          </a:fillRef>
+          <a:effectRef idx="2">
+            <a:schemeClr val="accent1"/>
+          </a:effectRef>
+          <a:fontRef idx="minor">
+            <a:schemeClr val="lt1"/>
+          </a:fontRef>
+        </p:style>
+        <p:txBody>
+          <a:bodyPr rtlCol="0" anchor="ctr"/>
+          <a:lstStyle/>
+          <a:p>
+            <a:pPr algn="ctr"/>
+          </a:p>
+        </p:txBody>
+      </p:sp>
+      <p:cxnSp>
+        <p:nvCxnSpPr>
+          <p:cNvPr id="14" name="Connector 13"/>
+          <p:cNvCxnSpPr/>
+          <p:nvPr/>
+        </p:nvCxnSpPr>
+        <p:spPr>
+          <a:xfrm flipV="1">
+            <a:off x="1079500" y="2578100"/>
+            <a:ext cx="0" cy="177800"/>
+          </a:xfrm>
+          <a:prstGeom prst="line">
+            <a:avLst/>
+          </a:prstGeom>
+          <a:ln w="22860">
+            <a:solidFill>
+              <a:srgbClr val="1F5E3A"/>
+            </a:solidFill>
+          </a:ln>
+        </p:spPr>
+        <p:style>
+          <a:lnRef idx="2">
+            <a:schemeClr val="accent1"/>
+          </a:lnRef>
+          <a:fillRef idx="0">
+            <a:schemeClr val="accent1"/>
+          </a:fillRef>
+          <a:effectRef idx="1">
+            <a:schemeClr val="accent1"/>
+          </a:effectRef>
+          <a:fontRef idx="minor">
+            <a:schemeClr val="tx1"/>
+          </a:fontRef>
+        </p:style>
+      </p:cxnSp>
+      <p:sp>
+        <p:nvSpPr>
+          <p:cNvPr id="15" name="Oval 14"/>
+          <p:cNvSpPr/>
+          <p:nvPr/>
+        </p:nvSpPr>
+        <p:spPr>
+          <a:xfrm>
+            <a:off x="939800" y="2565400"/>
+            <a:ext cx="152400" cy="114300"/>
+          </a:xfrm>
+          <a:prstGeom prst="ellipse">
+            <a:avLst/>
+          </a:prstGeom>
+          <a:solidFill>
             <a:srgbClr val="1F5E3A"/>
           </a:solidFill>
           <a:ln>
@@ -51069,53 +51148,102 @@
       </p:sp>
       <p:sp>
         <p:nvSpPr>
-          <p:cNvPr id="14" name="TextBox 13"/>
+          <p:cNvPr id="16" name="Oval 15"/>
+          <p:cNvSpPr/>
+          <p:nvPr/>
+        </p:nvSpPr>
+        <p:spPr>
+          <a:xfrm>
+            <a:off x="1066800" y="2501900"/>
+            <a:ext cx="152400" cy="114300"/>
+          </a:xfrm>
+          <a:prstGeom prst="ellipse">
+            <a:avLst/>
+          </a:prstGeom>
+          <a:solidFill>
+            <a:srgbClr val="1F5E3A"/>
+          </a:solidFill>
+          <a:ln>
+            <a:noFill/>
+          </a:ln>
+          <a:effectLst/>
+        </p:spPr>
+        <p:style>
+          <a:lnRef idx="1">
+            <a:schemeClr val="accent1"/>
+          </a:lnRef>
+          <a:fillRef idx="3">
+            <a:schemeClr val="accent1"/>
+          </a:fillRef>
+          <a:effectRef idx="2">
+            <a:schemeClr val="accent1"/>
+          </a:effectRef>
+          <a:fontRef idx="minor">
+            <a:schemeClr val="lt1"/>
+          </a:fontRef>
+        </p:style>
+        <p:txBody>
+          <a:bodyPr rtlCol="0" anchor="ctr"/>
+          <a:lstStyle/>
+          <a:p>
+            <a:pPr algn="ctr"/>
+          </a:p>
+        </p:txBody>
+      </p:sp>
+      <p:sp>
+        <p:nvSpPr>
+          <p:cNvPr id="17" name="Rounded Rectangle 16"/>
+          <p:cNvSpPr/>
+          <p:nvPr/>
+        </p:nvSpPr>
+        <p:spPr>
+          <a:xfrm>
+            <a:off x="952500" y="2743200"/>
+            <a:ext cx="254000" cy="38100"/>
+          </a:xfrm>
+          <a:prstGeom prst="roundRect">
+            <a:avLst>
+              <a:gd name="adj" fmla="val 50000"/>
+            </a:avLst>
+          </a:prstGeom>
+          <a:solidFill>
+            <a:srgbClr val="1F5E3A"/>
+          </a:solidFill>
+          <a:ln>
+            <a:noFill/>
+          </a:ln>
+          <a:effectLst/>
+        </p:spPr>
+        <p:style>
+          <a:lnRef idx="1">
+            <a:schemeClr val="accent1"/>
+          </a:lnRef>
+          <a:fillRef idx="3">
+            <a:schemeClr val="accent1"/>
+          </a:fillRef>
+          <a:effectRef idx="2">
+            <a:schemeClr val="accent1"/>
+          </a:effectRef>
+          <a:fontRef idx="minor">
+            <a:schemeClr val="lt1"/>
+          </a:fontRef>
+        </p:style>
+        <p:txBody>
+          <a:bodyPr rtlCol="0" anchor="ctr"/>
+          <a:lstStyle/>
+          <a:p/>
+        </p:txBody>
+      </p:sp>
+      <p:sp>
+        <p:nvSpPr>
+          <p:cNvPr id="18" name="TextBox 17"/>
           <p:cNvSpPr txBox="1"/>
           <p:nvPr/>
         </p:nvSpPr>
         <p:spPr>
           <a:xfrm>
-            <a:off x="838200" y="2201799"/>
-            <a:ext cx="304800" cy="183515"/>
-          </a:xfrm>
-          <a:prstGeom prst="rect">
-            <a:avLst/>
-          </a:prstGeom>
-          <a:noFill/>
-        </p:spPr>
-        <p:txBody>
-          <a:bodyPr wrap="none" lIns="0" rIns="0" tIns="0" bIns="0" anchor="t">
-            <a:spAutoFit/>
-          </a:bodyPr>
-          <a:lstStyle/>
-          <a:p>
-            <a:pPr algn="ctr">
-              <a:lnSpc>
-                <a:spcPts val="1105"/>
-              </a:lnSpc>
-            </a:pPr>
-            <a:r>
-              <a:rPr sz="850" b="1" i="0">
-                <a:solidFill>
-                  <a:srgbClr val="FFFFFF"/>
-                </a:solidFill>
-                <a:latin typeface="Poppins"/>
-              </a:rPr>
-              <a:t>01</a:t>
-            </a:r>
-          </a:p>
-        </p:txBody>
-      </p:sp>
-      <p:sp>
-        <p:nvSpPr>
-          <p:cNvPr id="15" name="TextBox 14"/>
-          <p:cNvSpPr txBox="1"/>
-          <p:nvPr/>
-        </p:nvSpPr>
-        <p:spPr>
-          <a:xfrm>
-            <a:off x="1181100" y="2171700"/>
-            <a:ext cx="2298700" cy="269875"/>
+            <a:off x="1397000" y="2463800"/>
+            <a:ext cx="2057400" cy="269875"/>
           </a:xfrm>
           <a:prstGeom prst="rect">
             <a:avLst/>
@@ -51147,73 +51275,18 @@
       </p:sp>
       <p:sp>
         <p:nvSpPr>
-          <p:cNvPr id="16" name="TextBox 15"/>
-          <p:cNvSpPr txBox="1"/>
-          <p:nvPr/>
-        </p:nvSpPr>
-        <p:spPr>
-          <a:xfrm>
-            <a:off x="838200" y="2595880"/>
-            <a:ext cx="2590800" cy="419100"/>
-          </a:xfrm>
-          <a:prstGeom prst="rect">
-            <a:avLst/>
-          </a:prstGeom>
-          <a:noFill/>
-        </p:spPr>
-        <p:txBody>
-          <a:bodyPr wrap="none" lIns="0" rIns="0" tIns="0" bIns="0" anchor="t">
-            <a:spAutoFit/>
-          </a:bodyPr>
-          <a:lstStyle/>
-          <a:p>
-            <a:pPr algn="l">
-              <a:lnSpc>
-                <a:spcPts val="1450"/>
-              </a:lnSpc>
-            </a:pPr>
-            <a:r>
-              <a:rPr sz="1000" b="0" i="0">
-                <a:solidFill>
-                  <a:srgbClr val="0A1A01"/>
-                </a:solidFill>
-                <a:latin typeface="Poppins"/>
-              </a:rPr>
-              <a:t>Exploitations agricoles</a:t>
-            </a:r>
-          </a:p>
-          <a:p>
-            <a:pPr algn="l">
-              <a:lnSpc>
-                <a:spcPts val="1450"/>
-              </a:lnSpc>
-            </a:pPr>
-            <a:r>
-              <a:rPr sz="1000" b="0" i="0">
-                <a:solidFill>
-                  <a:srgbClr val="0A1A01"/>
-                </a:solidFill>
-                <a:latin typeface="Poppins"/>
-              </a:rPr>
-              <a:t>&amp; entreprises de production</a:t>
-            </a:r>
-          </a:p>
-        </p:txBody>
-      </p:sp>
-      <p:sp>
-        <p:nvSpPr>
-          <p:cNvPr id="17" name="Rounded Rectangle 16"/>
-          <p:cNvSpPr/>
-          <p:nvPr/>
-        </p:nvSpPr>
-        <p:spPr>
-          <a:xfrm>
-            <a:off x="8585200" y="1981200"/>
-            <a:ext cx="2946400" cy="1219200"/>
+          <p:cNvPr id="19" name="Rounded Rectangle 18"/>
+          <p:cNvSpPr/>
+          <p:nvPr/>
+        </p:nvSpPr>
+        <p:spPr>
+          <a:xfrm>
+            <a:off x="8585200" y="2133600"/>
+            <a:ext cx="2946400" cy="914400"/>
           </a:xfrm>
           <a:prstGeom prst="roundRect">
             <a:avLst>
-              <a:gd name="adj" fmla="val 10416"/>
+              <a:gd name="adj" fmla="val 13888"/>
             </a:avLst>
           </a:prstGeom>
           <a:solidFill>
@@ -51248,19 +51321,84 @@
       </p:sp>
       <p:sp>
         <p:nvSpPr>
-          <p:cNvPr id="18" name="Oval 17"/>
-          <p:cNvSpPr/>
-          <p:nvPr/>
-        </p:nvSpPr>
-        <p:spPr>
-          <a:xfrm>
-            <a:off x="8788400" y="2159000"/>
-            <a:ext cx="254000" cy="254000"/>
+          <p:cNvPr id="20" name="Oval 19"/>
+          <p:cNvSpPr/>
+          <p:nvPr/>
+        </p:nvSpPr>
+        <p:spPr>
+          <a:xfrm>
+            <a:off x="8788400" y="2387600"/>
+            <a:ext cx="431800" cy="431800"/>
           </a:xfrm>
           <a:prstGeom prst="ellipse">
             <a:avLst/>
           </a:prstGeom>
           <a:solidFill>
+            <a:srgbClr val="1AAB70"/>
+          </a:solidFill>
+          <a:ln>
+            <a:noFill/>
+          </a:ln>
+          <a:effectLst/>
+        </p:spPr>
+        <p:style>
+          <a:lnRef idx="1">
+            <a:schemeClr val="accent1"/>
+          </a:lnRef>
+          <a:fillRef idx="3">
+            <a:schemeClr val="accent1"/>
+          </a:fillRef>
+          <a:effectRef idx="2">
+            <a:schemeClr val="accent1"/>
+          </a:effectRef>
+          <a:fontRef idx="minor">
+            <a:schemeClr val="lt1"/>
+          </a:fontRef>
+        </p:style>
+        <p:txBody>
+          <a:bodyPr rtlCol="0" anchor="ctr"/>
+          <a:lstStyle/>
+          <a:p>
+            <a:pPr algn="ctr"/>
+          </a:p>
+        </p:txBody>
+      </p:sp>
+      <p:sp>
+        <p:nvSpPr>
+          <p:cNvPr id="21" name="Freeform 20"/>
+          <p:cNvSpPr/>
+          <p:nvPr/>
+        </p:nvSpPr>
+        <p:spPr>
+          <a:xfrm>
+            <a:off x="8890000" y="2578100"/>
+            <a:ext cx="228600" cy="190500"/>
+          </a:xfrm>
+          <a:custGeom>
+            <a:avLst/>
+            <a:gdLst/>
+            <a:ahLst/>
+            <a:cxnLst/>
+            <a:rect l="l" t="t" r="r" b="b"/>
+            <a:pathLst>
+              <a:path w="228600" h="190500">
+                <a:moveTo>
+                  <a:pt x="0" y="0"/>
+                </a:moveTo>
+                <a:lnTo>
+                  <a:pt x="228600" y="0"/>
+                </a:lnTo>
+                <a:lnTo>
+                  <a:pt x="203200" y="190500"/>
+                </a:lnTo>
+                <a:lnTo>
+                  <a:pt x="25400" y="190500"/>
+                </a:lnTo>
+                <a:close/>
+              </a:path>
+            </a:pathLst>
+          </a:custGeom>
+          <a:solidFill>
             <a:srgbClr val="1F5E3A"/>
           </a:solidFill>
           <a:ln>
@@ -51292,53 +51430,100 @@
       </p:sp>
       <p:sp>
         <p:nvSpPr>
-          <p:cNvPr id="19" name="TextBox 18"/>
+          <p:cNvPr id="22" name="Oval 21"/>
+          <p:cNvSpPr/>
+          <p:nvPr/>
+        </p:nvSpPr>
+        <p:spPr>
+          <a:xfrm>
+            <a:off x="8940800" y="2476500"/>
+            <a:ext cx="127000" cy="139700"/>
+          </a:xfrm>
+          <a:prstGeom prst="ellipse">
+            <a:avLst/>
+          </a:prstGeom>
+          <a:noFill/>
+          <a:ln w="22860">
+            <a:solidFill>
+              <a:srgbClr val="1F5E3A"/>
+            </a:solidFill>
+          </a:ln>
+          <a:effectLst/>
+        </p:spPr>
+        <p:style>
+          <a:lnRef idx="1">
+            <a:schemeClr val="accent1"/>
+          </a:lnRef>
+          <a:fillRef idx="3">
+            <a:schemeClr val="accent1"/>
+          </a:fillRef>
+          <a:effectRef idx="2">
+            <a:schemeClr val="accent1"/>
+          </a:effectRef>
+          <a:fontRef idx="minor">
+            <a:schemeClr val="lt1"/>
+          </a:fontRef>
+        </p:style>
+        <p:txBody>
+          <a:bodyPr rtlCol="0" anchor="ctr"/>
+          <a:lstStyle/>
+          <a:p>
+            <a:pPr algn="ctr"/>
+          </a:p>
+        </p:txBody>
+      </p:sp>
+      <p:sp>
+        <p:nvSpPr>
+          <p:cNvPr id="23" name="Rectangle 22"/>
+          <p:cNvSpPr/>
+          <p:nvPr/>
+        </p:nvSpPr>
+        <p:spPr>
+          <a:xfrm>
+            <a:off x="8940800" y="2552700"/>
+            <a:ext cx="127000" cy="63500"/>
+          </a:xfrm>
+          <a:prstGeom prst="rect">
+            <a:avLst/>
+          </a:prstGeom>
+          <a:solidFill>
+            <a:srgbClr val="FFFFFF"/>
+          </a:solidFill>
+          <a:ln>
+            <a:noFill/>
+          </a:ln>
+          <a:effectLst/>
+        </p:spPr>
+        <p:style>
+          <a:lnRef idx="1">
+            <a:schemeClr val="accent1"/>
+          </a:lnRef>
+          <a:fillRef idx="3">
+            <a:schemeClr val="accent1"/>
+          </a:fillRef>
+          <a:effectRef idx="2">
+            <a:schemeClr val="accent1"/>
+          </a:effectRef>
+          <a:fontRef idx="minor">
+            <a:schemeClr val="lt1"/>
+          </a:fontRef>
+        </p:style>
+        <p:txBody>
+          <a:bodyPr rtlCol="0" anchor="ctr"/>
+          <a:lstStyle/>
+          <a:p/>
+        </p:txBody>
+      </p:sp>
+      <p:sp>
+        <p:nvSpPr>
+          <p:cNvPr id="24" name="TextBox 23"/>
           <p:cNvSpPr txBox="1"/>
           <p:nvPr/>
         </p:nvSpPr>
         <p:spPr>
           <a:xfrm>
-            <a:off x="8763000" y="2201799"/>
-            <a:ext cx="304800" cy="183515"/>
-          </a:xfrm>
-          <a:prstGeom prst="rect">
-            <a:avLst/>
-          </a:prstGeom>
-          <a:noFill/>
-        </p:spPr>
-        <p:txBody>
-          <a:bodyPr wrap="none" lIns="0" rIns="0" tIns="0" bIns="0" anchor="t">
-            <a:spAutoFit/>
-          </a:bodyPr>
-          <a:lstStyle/>
-          <a:p>
-            <a:pPr algn="ctr">
-              <a:lnSpc>
-                <a:spcPts val="1105"/>
-              </a:lnSpc>
-            </a:pPr>
-            <a:r>
-              <a:rPr sz="850" b="1" i="0">
-                <a:solidFill>
-                  <a:srgbClr val="FFFFFF"/>
-                </a:solidFill>
-                <a:latin typeface="Poppins"/>
-              </a:rPr>
-              <a:t>05</a:t>
-            </a:r>
-          </a:p>
-        </p:txBody>
-      </p:sp>
-      <p:sp>
-        <p:nvSpPr>
-          <p:cNvPr id="20" name="TextBox 19"/>
-          <p:cNvSpPr txBox="1"/>
-          <p:nvPr/>
-        </p:nvSpPr>
-        <p:spPr>
-          <a:xfrm>
-            <a:off x="9105900" y="2171700"/>
-            <a:ext cx="2298700" cy="269875"/>
+            <a:off x="9321800" y="2463800"/>
+            <a:ext cx="2057400" cy="269875"/>
           </a:xfrm>
           <a:prstGeom prst="rect">
             <a:avLst/>
@@ -51370,73 +51555,18 @@
       </p:sp>
       <p:sp>
         <p:nvSpPr>
-          <p:cNvPr id="21" name="TextBox 20"/>
-          <p:cNvSpPr txBox="1"/>
-          <p:nvPr/>
-        </p:nvSpPr>
-        <p:spPr>
-          <a:xfrm>
-            <a:off x="8763000" y="2595880"/>
-            <a:ext cx="2590800" cy="419100"/>
-          </a:xfrm>
-          <a:prstGeom prst="rect">
-            <a:avLst/>
-          </a:prstGeom>
-          <a:noFill/>
-        </p:spPr>
-        <p:txBody>
-          <a:bodyPr wrap="none" lIns="0" rIns="0" tIns="0" bIns="0" anchor="t">
-            <a:spAutoFit/>
-          </a:bodyPr>
-          <a:lstStyle/>
-          <a:p>
-            <a:pPr algn="l">
-              <a:lnSpc>
-                <a:spcPts val="1450"/>
-              </a:lnSpc>
-            </a:pPr>
-            <a:r>
-              <a:rPr sz="1000" b="0" i="0">
-                <a:solidFill>
-                  <a:srgbClr val="0A1A01"/>
-                </a:solidFill>
-                <a:latin typeface="Poppins"/>
-              </a:rPr>
-              <a:t>Hôtels, restaurants,</a:t>
-            </a:r>
-          </a:p>
-          <a:p>
-            <a:pPr algn="l">
-              <a:lnSpc>
-                <a:spcPts val="1450"/>
-              </a:lnSpc>
-            </a:pPr>
-            <a:r>
-              <a:rPr sz="1000" b="0" i="0">
-                <a:solidFill>
-                  <a:srgbClr val="0A1A01"/>
-                </a:solidFill>
-                <a:latin typeface="Poppins"/>
-              </a:rPr>
-              <a:t>commerces &amp; enseignes</a:t>
-            </a:r>
-          </a:p>
-        </p:txBody>
-      </p:sp>
-      <p:sp>
-        <p:nvSpPr>
-          <p:cNvPr id="22" name="Rounded Rectangle 21"/>
-          <p:cNvSpPr/>
-          <p:nvPr/>
-        </p:nvSpPr>
-        <p:spPr>
-          <a:xfrm>
-            <a:off x="787400" y="4216400"/>
-            <a:ext cx="2870200" cy="1219200"/>
+          <p:cNvPr id="25" name="Rounded Rectangle 24"/>
+          <p:cNvSpPr/>
+          <p:nvPr/>
+        </p:nvSpPr>
+        <p:spPr>
+          <a:xfrm>
+            <a:off x="787400" y="4318000"/>
+            <a:ext cx="2870200" cy="914400"/>
           </a:xfrm>
           <a:prstGeom prst="roundRect">
             <a:avLst>
-              <a:gd name="adj" fmla="val 10416"/>
+              <a:gd name="adj" fmla="val 13888"/>
             </a:avLst>
           </a:prstGeom>
           <a:solidFill>
@@ -51471,19 +51601,65 @@
       </p:sp>
       <p:sp>
         <p:nvSpPr>
-          <p:cNvPr id="23" name="Oval 22"/>
-          <p:cNvSpPr/>
-          <p:nvPr/>
-        </p:nvSpPr>
-        <p:spPr>
-          <a:xfrm>
-            <a:off x="990600" y="4394200"/>
-            <a:ext cx="254000" cy="254000"/>
+          <p:cNvPr id="26" name="Oval 25"/>
+          <p:cNvSpPr/>
+          <p:nvPr/>
+        </p:nvSpPr>
+        <p:spPr>
+          <a:xfrm>
+            <a:off x="990600" y="4572000"/>
+            <a:ext cx="431800" cy="431800"/>
           </a:xfrm>
           <a:prstGeom prst="ellipse">
             <a:avLst/>
           </a:prstGeom>
           <a:solidFill>
+            <a:srgbClr val="1AAB70"/>
+          </a:solidFill>
+          <a:ln>
+            <a:noFill/>
+          </a:ln>
+          <a:effectLst/>
+        </p:spPr>
+        <p:style>
+          <a:lnRef idx="1">
+            <a:schemeClr val="accent1"/>
+          </a:lnRef>
+          <a:fillRef idx="3">
+            <a:schemeClr val="accent1"/>
+          </a:fillRef>
+          <a:effectRef idx="2">
+            <a:schemeClr val="accent1"/>
+          </a:effectRef>
+          <a:fontRef idx="minor">
+            <a:schemeClr val="lt1"/>
+          </a:fontRef>
+        </p:style>
+        <p:txBody>
+          <a:bodyPr rtlCol="0" anchor="ctr"/>
+          <a:lstStyle/>
+          <a:p>
+            <a:pPr algn="ctr"/>
+          </a:p>
+        </p:txBody>
+      </p:sp>
+      <p:sp>
+        <p:nvSpPr>
+          <p:cNvPr id="27" name="Rounded Rectangle 26"/>
+          <p:cNvSpPr/>
+          <p:nvPr/>
+        </p:nvSpPr>
+        <p:spPr>
+          <a:xfrm>
+            <a:off x="1066800" y="4787900"/>
+            <a:ext cx="279400" cy="177800"/>
+          </a:xfrm>
+          <a:prstGeom prst="roundRect">
+            <a:avLst>
+              <a:gd name="adj" fmla="val 10714"/>
+            </a:avLst>
+          </a:prstGeom>
+          <a:solidFill>
             <a:srgbClr val="1F5E3A"/>
           </a:solidFill>
           <a:ln>
@@ -51508,6 +51684,110 @@
         <p:txBody>
           <a:bodyPr rtlCol="0" anchor="ctr"/>
           <a:lstStyle/>
+          <a:p/>
+        </p:txBody>
+      </p:sp>
+      <p:sp>
+        <p:nvSpPr>
+          <p:cNvPr id="28" name="Rounded Rectangle 27"/>
+          <p:cNvSpPr/>
+          <p:nvPr/>
+        </p:nvSpPr>
+        <p:spPr>
+          <a:xfrm>
+            <a:off x="1104900" y="4686300"/>
+            <a:ext cx="63500" cy="101600"/>
+          </a:xfrm>
+          <a:prstGeom prst="roundRect">
+            <a:avLst>
+              <a:gd name="adj" fmla="val 20000"/>
+            </a:avLst>
+          </a:prstGeom>
+          <a:solidFill>
+            <a:srgbClr val="1F5E3A"/>
+          </a:solidFill>
+          <a:ln>
+            <a:noFill/>
+          </a:ln>
+          <a:effectLst/>
+        </p:spPr>
+        <p:style>
+          <a:lnRef idx="1">
+            <a:schemeClr val="accent1"/>
+          </a:lnRef>
+          <a:fillRef idx="3">
+            <a:schemeClr val="accent1"/>
+          </a:fillRef>
+          <a:effectRef idx="2">
+            <a:schemeClr val="accent1"/>
+          </a:effectRef>
+          <a:fontRef idx="minor">
+            <a:schemeClr val="lt1"/>
+          </a:fontRef>
+        </p:style>
+        <p:txBody>
+          <a:bodyPr rtlCol="0" anchor="ctr"/>
+          <a:lstStyle/>
+          <a:p/>
+        </p:txBody>
+      </p:sp>
+      <p:sp>
+        <p:nvSpPr>
+          <p:cNvPr id="29" name="Freeform 28"/>
+          <p:cNvSpPr/>
+          <p:nvPr/>
+        </p:nvSpPr>
+        <p:spPr>
+          <a:xfrm>
+            <a:off x="1193800" y="4787900"/>
+            <a:ext cx="76200" cy="76200"/>
+          </a:xfrm>
+          <a:custGeom>
+            <a:avLst/>
+            <a:gdLst/>
+            <a:ahLst/>
+            <a:cxnLst/>
+            <a:rect l="l" t="t" r="r" b="b"/>
+            <a:pathLst>
+              <a:path w="76200" h="76200">
+                <a:moveTo>
+                  <a:pt x="0" y="76200"/>
+                </a:moveTo>
+                <a:lnTo>
+                  <a:pt x="76200" y="0"/>
+                </a:lnTo>
+                <a:lnTo>
+                  <a:pt x="76200" y="76200"/>
+                </a:lnTo>
+                <a:close/>
+              </a:path>
+            </a:pathLst>
+          </a:custGeom>
+          <a:solidFill>
+            <a:srgbClr val="FFFFFF"/>
+          </a:solidFill>
+          <a:ln>
+            <a:noFill/>
+          </a:ln>
+          <a:effectLst/>
+        </p:spPr>
+        <p:style>
+          <a:lnRef idx="1">
+            <a:schemeClr val="accent1"/>
+          </a:lnRef>
+          <a:fillRef idx="3">
+            <a:schemeClr val="accent1"/>
+          </a:fillRef>
+          <a:effectRef idx="2">
+            <a:schemeClr val="accent1"/>
+          </a:effectRef>
+          <a:fontRef idx="minor">
+            <a:schemeClr val="lt1"/>
+          </a:fontRef>
+        </p:style>
+        <p:txBody>
+          <a:bodyPr rtlCol="0" anchor="ctr"/>
+          <a:lstStyle/>
           <a:p>
             <a:pPr algn="ctr"/>
           </a:p>
@@ -51515,53 +51795,76 @@
       </p:sp>
       <p:sp>
         <p:nvSpPr>
-          <p:cNvPr id="24" name="TextBox 23"/>
+          <p:cNvPr id="30" name="Freeform 29"/>
+          <p:cNvSpPr/>
+          <p:nvPr/>
+        </p:nvSpPr>
+        <p:spPr>
+          <a:xfrm>
+            <a:off x="1270000" y="4787900"/>
+            <a:ext cx="76200" cy="76200"/>
+          </a:xfrm>
+          <a:custGeom>
+            <a:avLst/>
+            <a:gdLst/>
+            <a:ahLst/>
+            <a:cxnLst/>
+            <a:rect l="l" t="t" r="r" b="b"/>
+            <a:pathLst>
+              <a:path w="76200" h="76200">
+                <a:moveTo>
+                  <a:pt x="0" y="76200"/>
+                </a:moveTo>
+                <a:lnTo>
+                  <a:pt x="76200" y="0"/>
+                </a:lnTo>
+                <a:lnTo>
+                  <a:pt x="76200" y="76200"/>
+                </a:lnTo>
+                <a:close/>
+              </a:path>
+            </a:pathLst>
+          </a:custGeom>
+          <a:solidFill>
+            <a:srgbClr val="FFFFFF"/>
+          </a:solidFill>
+          <a:ln>
+            <a:noFill/>
+          </a:ln>
+          <a:effectLst/>
+        </p:spPr>
+        <p:style>
+          <a:lnRef idx="1">
+            <a:schemeClr val="accent1"/>
+          </a:lnRef>
+          <a:fillRef idx="3">
+            <a:schemeClr val="accent1"/>
+          </a:fillRef>
+          <a:effectRef idx="2">
+            <a:schemeClr val="accent1"/>
+          </a:effectRef>
+          <a:fontRef idx="minor">
+            <a:schemeClr val="lt1"/>
+          </a:fontRef>
+        </p:style>
+        <p:txBody>
+          <a:bodyPr rtlCol="0" anchor="ctr"/>
+          <a:lstStyle/>
+          <a:p>
+            <a:pPr algn="ctr"/>
+          </a:p>
+        </p:txBody>
+      </p:sp>
+      <p:sp>
+        <p:nvSpPr>
+          <p:cNvPr id="31" name="TextBox 30"/>
           <p:cNvSpPr txBox="1"/>
           <p:nvPr/>
         </p:nvSpPr>
         <p:spPr>
           <a:xfrm>
-            <a:off x="965200" y="4436999"/>
-            <a:ext cx="304800" cy="183515"/>
-          </a:xfrm>
-          <a:prstGeom prst="rect">
-            <a:avLst/>
-          </a:prstGeom>
-          <a:noFill/>
-        </p:spPr>
-        <p:txBody>
-          <a:bodyPr wrap="none" lIns="0" rIns="0" tIns="0" bIns="0" anchor="t">
-            <a:spAutoFit/>
-          </a:bodyPr>
-          <a:lstStyle/>
-          <a:p>
-            <a:pPr algn="ctr">
-              <a:lnSpc>
-                <a:spcPts val="1105"/>
-              </a:lnSpc>
-            </a:pPr>
-            <a:r>
-              <a:rPr sz="850" b="1" i="0">
-                <a:solidFill>
-                  <a:srgbClr val="FFFFFF"/>
-                </a:solidFill>
-                <a:latin typeface="Poppins"/>
-              </a:rPr>
-              <a:t>02</a:t>
-            </a:r>
-          </a:p>
-        </p:txBody>
-      </p:sp>
-      <p:sp>
-        <p:nvSpPr>
-          <p:cNvPr id="25" name="TextBox 24"/>
-          <p:cNvSpPr txBox="1"/>
-          <p:nvPr/>
-        </p:nvSpPr>
-        <p:spPr>
-          <a:xfrm>
-            <a:off x="1308100" y="4406900"/>
-            <a:ext cx="2222500" cy="269875"/>
+            <a:off x="1524000" y="4648200"/>
+            <a:ext cx="1981200" cy="269875"/>
           </a:xfrm>
           <a:prstGeom prst="rect">
             <a:avLst/>
@@ -51593,73 +51896,18 @@
       </p:sp>
       <p:sp>
         <p:nvSpPr>
-          <p:cNvPr id="26" name="TextBox 25"/>
-          <p:cNvSpPr txBox="1"/>
-          <p:nvPr/>
-        </p:nvSpPr>
-        <p:spPr>
-          <a:xfrm>
-            <a:off x="965200" y="4831080"/>
-            <a:ext cx="2514600" cy="419100"/>
-          </a:xfrm>
-          <a:prstGeom prst="rect">
-            <a:avLst/>
-          </a:prstGeom>
-          <a:noFill/>
-        </p:spPr>
-        <p:txBody>
-          <a:bodyPr wrap="none" lIns="0" rIns="0" tIns="0" bIns="0" anchor="t">
-            <a:spAutoFit/>
-          </a:bodyPr>
-          <a:lstStyle/>
-          <a:p>
-            <a:pPr algn="l">
-              <a:lnSpc>
-                <a:spcPts val="1450"/>
-              </a:lnSpc>
-            </a:pPr>
-            <a:r>
-              <a:rPr sz="1000" b="0" i="0">
-                <a:solidFill>
-                  <a:srgbClr val="0A1A01"/>
-                </a:solidFill>
-                <a:latin typeface="Poppins"/>
-              </a:rPr>
-              <a:t>PME et entreprises</a:t>
-            </a:r>
-          </a:p>
-          <a:p>
-            <a:pPr algn="l">
-              <a:lnSpc>
-                <a:spcPts val="1450"/>
-              </a:lnSpc>
-            </a:pPr>
-            <a:r>
-              <a:rPr sz="1000" b="0" i="0">
-                <a:solidFill>
-                  <a:srgbClr val="0A1A01"/>
-                </a:solidFill>
-                <a:latin typeface="Poppins"/>
-              </a:rPr>
-              <a:t>de transformation</a:t>
-            </a:r>
-          </a:p>
-        </p:txBody>
-      </p:sp>
-      <p:sp>
-        <p:nvSpPr>
-          <p:cNvPr id="27" name="Rounded Rectangle 26"/>
-          <p:cNvSpPr/>
-          <p:nvPr/>
-        </p:nvSpPr>
-        <p:spPr>
-          <a:xfrm>
-            <a:off x="4648200" y="4521200"/>
-            <a:ext cx="2895600" cy="1219200"/>
+          <p:cNvPr id="32" name="Rounded Rectangle 31"/>
+          <p:cNvSpPr/>
+          <p:nvPr/>
+        </p:nvSpPr>
+        <p:spPr>
+          <a:xfrm>
+            <a:off x="4648200" y="4597400"/>
+            <a:ext cx="2895600" cy="914400"/>
           </a:xfrm>
           <a:prstGeom prst="roundRect">
             <a:avLst>
-              <a:gd name="adj" fmla="val 10416"/>
+              <a:gd name="adj" fmla="val 13888"/>
             </a:avLst>
           </a:prstGeom>
           <a:solidFill>
@@ -51694,19 +51942,63 @@
       </p:sp>
       <p:sp>
         <p:nvSpPr>
-          <p:cNvPr id="28" name="Oval 27"/>
-          <p:cNvSpPr/>
-          <p:nvPr/>
-        </p:nvSpPr>
-        <p:spPr>
-          <a:xfrm>
-            <a:off x="4851400" y="4699000"/>
-            <a:ext cx="254000" cy="254000"/>
+          <p:cNvPr id="33" name="Oval 32"/>
+          <p:cNvSpPr/>
+          <p:nvPr/>
+        </p:nvSpPr>
+        <p:spPr>
+          <a:xfrm>
+            <a:off x="4851400" y="4851400"/>
+            <a:ext cx="431800" cy="431800"/>
           </a:xfrm>
           <a:prstGeom prst="ellipse">
             <a:avLst/>
           </a:prstGeom>
           <a:solidFill>
+            <a:srgbClr val="1AAB70"/>
+          </a:solidFill>
+          <a:ln>
+            <a:noFill/>
+          </a:ln>
+          <a:effectLst/>
+        </p:spPr>
+        <p:style>
+          <a:lnRef idx="1">
+            <a:schemeClr val="accent1"/>
+          </a:lnRef>
+          <a:fillRef idx="3">
+            <a:schemeClr val="accent1"/>
+          </a:fillRef>
+          <a:effectRef idx="2">
+            <a:schemeClr val="accent1"/>
+          </a:effectRef>
+          <a:fontRef idx="minor">
+            <a:schemeClr val="lt1"/>
+          </a:fontRef>
+        </p:style>
+        <p:txBody>
+          <a:bodyPr rtlCol="0" anchor="ctr"/>
+          <a:lstStyle/>
+          <a:p>
+            <a:pPr algn="ctr"/>
+          </a:p>
+        </p:txBody>
+      </p:sp>
+      <p:sp>
+        <p:nvSpPr>
+          <p:cNvPr id="34" name="Oval 33"/>
+          <p:cNvSpPr/>
+          <p:nvPr/>
+        </p:nvSpPr>
+        <p:spPr>
+          <a:xfrm>
+            <a:off x="4927600" y="4978400"/>
+            <a:ext cx="114300" cy="114300"/>
+          </a:xfrm>
+          <a:prstGeom prst="ellipse">
+            <a:avLst/>
+          </a:prstGeom>
+          <a:solidFill>
             <a:srgbClr val="1F5E3A"/>
           </a:solidFill>
           <a:ln>
@@ -51738,53 +52030,146 @@
       </p:sp>
       <p:sp>
         <p:nvSpPr>
-          <p:cNvPr id="29" name="TextBox 28"/>
+          <p:cNvPr id="35" name="Oval 34"/>
+          <p:cNvSpPr/>
+          <p:nvPr/>
+        </p:nvSpPr>
+        <p:spPr>
+          <a:xfrm>
+            <a:off x="5035550" y="4978400"/>
+            <a:ext cx="139700" cy="139700"/>
+          </a:xfrm>
+          <a:prstGeom prst="ellipse">
+            <a:avLst/>
+          </a:prstGeom>
+          <a:solidFill>
+            <a:srgbClr val="1F5E3A"/>
+          </a:solidFill>
+          <a:ln>
+            <a:noFill/>
+          </a:ln>
+          <a:effectLst/>
+        </p:spPr>
+        <p:style>
+          <a:lnRef idx="1">
+            <a:schemeClr val="accent1"/>
+          </a:lnRef>
+          <a:fillRef idx="3">
+            <a:schemeClr val="accent1"/>
+          </a:fillRef>
+          <a:effectRef idx="2">
+            <a:schemeClr val="accent1"/>
+          </a:effectRef>
+          <a:fontRef idx="minor">
+            <a:schemeClr val="lt1"/>
+          </a:fontRef>
+        </p:style>
+        <p:txBody>
+          <a:bodyPr rtlCol="0" anchor="ctr"/>
+          <a:lstStyle/>
+          <a:p>
+            <a:pPr algn="ctr"/>
+          </a:p>
+        </p:txBody>
+      </p:sp>
+      <p:sp>
+        <p:nvSpPr>
+          <p:cNvPr id="36" name="Oval 35"/>
+          <p:cNvSpPr/>
+          <p:nvPr/>
+        </p:nvSpPr>
+        <p:spPr>
+          <a:xfrm>
+            <a:off x="5143500" y="4978400"/>
+            <a:ext cx="114300" cy="114300"/>
+          </a:xfrm>
+          <a:prstGeom prst="ellipse">
+            <a:avLst/>
+          </a:prstGeom>
+          <a:solidFill>
+            <a:srgbClr val="1F5E3A"/>
+          </a:solidFill>
+          <a:ln>
+            <a:noFill/>
+          </a:ln>
+          <a:effectLst/>
+        </p:spPr>
+        <p:style>
+          <a:lnRef idx="1">
+            <a:schemeClr val="accent1"/>
+          </a:lnRef>
+          <a:fillRef idx="3">
+            <a:schemeClr val="accent1"/>
+          </a:fillRef>
+          <a:effectRef idx="2">
+            <a:schemeClr val="accent1"/>
+          </a:effectRef>
+          <a:fontRef idx="minor">
+            <a:schemeClr val="lt1"/>
+          </a:fontRef>
+        </p:style>
+        <p:txBody>
+          <a:bodyPr rtlCol="0" anchor="ctr"/>
+          <a:lstStyle/>
+          <a:p>
+            <a:pPr algn="ctr"/>
+          </a:p>
+        </p:txBody>
+      </p:sp>
+      <p:sp>
+        <p:nvSpPr>
+          <p:cNvPr id="37" name="Rounded Rectangle 36"/>
+          <p:cNvSpPr/>
+          <p:nvPr/>
+        </p:nvSpPr>
+        <p:spPr>
+          <a:xfrm>
+            <a:off x="4902200" y="5130800"/>
+            <a:ext cx="330200" cy="114300"/>
+          </a:xfrm>
+          <a:prstGeom prst="roundRect">
+            <a:avLst>
+              <a:gd name="adj" fmla="val 50000"/>
+            </a:avLst>
+          </a:prstGeom>
+          <a:solidFill>
+            <a:srgbClr val="1F5E3A"/>
+          </a:solidFill>
+          <a:ln>
+            <a:noFill/>
+          </a:ln>
+          <a:effectLst/>
+        </p:spPr>
+        <p:style>
+          <a:lnRef idx="1">
+            <a:schemeClr val="accent1"/>
+          </a:lnRef>
+          <a:fillRef idx="3">
+            <a:schemeClr val="accent1"/>
+          </a:fillRef>
+          <a:effectRef idx="2">
+            <a:schemeClr val="accent1"/>
+          </a:effectRef>
+          <a:fontRef idx="minor">
+            <a:schemeClr val="lt1"/>
+          </a:fontRef>
+        </p:style>
+        <p:txBody>
+          <a:bodyPr rtlCol="0" anchor="ctr"/>
+          <a:lstStyle/>
+          <a:p/>
+        </p:txBody>
+      </p:sp>
+      <p:sp>
+        <p:nvSpPr>
+          <p:cNvPr id="38" name="TextBox 37"/>
           <p:cNvSpPr txBox="1"/>
           <p:nvPr/>
         </p:nvSpPr>
         <p:spPr>
           <a:xfrm>
-            <a:off x="4826000" y="4741799"/>
-            <a:ext cx="304800" cy="183515"/>
-          </a:xfrm>
-          <a:prstGeom prst="rect">
-            <a:avLst/>
-          </a:prstGeom>
-          <a:noFill/>
-        </p:spPr>
-        <p:txBody>
-          <a:bodyPr wrap="none" lIns="0" rIns="0" tIns="0" bIns="0" anchor="t">
-            <a:spAutoFit/>
-          </a:bodyPr>
-          <a:lstStyle/>
-          <a:p>
-            <a:pPr algn="ctr">
-              <a:lnSpc>
-                <a:spcPts val="1105"/>
-              </a:lnSpc>
-            </a:pPr>
-            <a:r>
-              <a:rPr sz="850" b="1" i="0">
-                <a:solidFill>
-                  <a:srgbClr val="FFFFFF"/>
-                </a:solidFill>
-                <a:latin typeface="Poppins"/>
-              </a:rPr>
-              <a:t>03</a:t>
-            </a:r>
-          </a:p>
-        </p:txBody>
-      </p:sp>
-      <p:sp>
-        <p:nvSpPr>
-          <p:cNvPr id="30" name="TextBox 29"/>
-          <p:cNvSpPr txBox="1"/>
-          <p:nvPr/>
-        </p:nvSpPr>
-        <p:spPr>
-          <a:xfrm>
-            <a:off x="5168900" y="4711700"/>
-            <a:ext cx="2247900" cy="269875"/>
+            <a:off x="5384800" y="4927600"/>
+            <a:ext cx="2006600" cy="269875"/>
           </a:xfrm>
           <a:prstGeom prst="rect">
             <a:avLst/>
@@ -51816,73 +52201,18 @@
       </p:sp>
       <p:sp>
         <p:nvSpPr>
-          <p:cNvPr id="31" name="TextBox 30"/>
-          <p:cNvSpPr txBox="1"/>
-          <p:nvPr/>
-        </p:nvSpPr>
-        <p:spPr>
-          <a:xfrm>
-            <a:off x="4826000" y="5135880"/>
-            <a:ext cx="2540000" cy="419100"/>
-          </a:xfrm>
-          <a:prstGeom prst="rect">
-            <a:avLst/>
-          </a:prstGeom>
-          <a:noFill/>
-        </p:spPr>
-        <p:txBody>
-          <a:bodyPr wrap="none" lIns="0" rIns="0" tIns="0" bIns="0" anchor="t">
-            <a:spAutoFit/>
-          </a:bodyPr>
-          <a:lstStyle/>
-          <a:p>
-            <a:pPr algn="l">
-              <a:lnSpc>
-                <a:spcPts val="1450"/>
-              </a:lnSpc>
-            </a:pPr>
-            <a:r>
-              <a:rPr sz="1000" b="0" i="0">
-                <a:solidFill>
-                  <a:srgbClr val="0A1A01"/>
-                </a:solidFill>
-                <a:latin typeface="Poppins"/>
-              </a:rPr>
-              <a:t>Structures collectives</a:t>
-            </a:r>
-          </a:p>
-          <a:p>
-            <a:pPr algn="l">
-              <a:lnSpc>
-                <a:spcPts val="1450"/>
-              </a:lnSpc>
-            </a:pPr>
-            <a:r>
-              <a:rPr sz="1000" b="0" i="0">
-                <a:solidFill>
-                  <a:srgbClr val="0A1A01"/>
-                </a:solidFill>
-                <a:latin typeface="Poppins"/>
-              </a:rPr>
-              <a:t>à professionnaliser</a:t>
-            </a:r>
-          </a:p>
-        </p:txBody>
-      </p:sp>
-      <p:sp>
-        <p:nvSpPr>
-          <p:cNvPr id="32" name="Rounded Rectangle 31"/>
-          <p:cNvSpPr/>
-          <p:nvPr/>
-        </p:nvSpPr>
-        <p:spPr>
-          <a:xfrm>
-            <a:off x="8534400" y="4216400"/>
-            <a:ext cx="2946400" cy="1219200"/>
+          <p:cNvPr id="39" name="Rounded Rectangle 38"/>
+          <p:cNvSpPr/>
+          <p:nvPr/>
+        </p:nvSpPr>
+        <p:spPr>
+          <a:xfrm>
+            <a:off x="8534400" y="4318000"/>
+            <a:ext cx="2946400" cy="914400"/>
           </a:xfrm>
           <a:prstGeom prst="roundRect">
             <a:avLst>
-              <a:gd name="adj" fmla="val 10416"/>
+              <a:gd name="adj" fmla="val 13888"/>
             </a:avLst>
           </a:prstGeom>
           <a:solidFill>
@@ -51917,19 +52247,65 @@
       </p:sp>
       <p:sp>
         <p:nvSpPr>
-          <p:cNvPr id="33" name="Oval 32"/>
-          <p:cNvSpPr/>
-          <p:nvPr/>
-        </p:nvSpPr>
-        <p:spPr>
-          <a:xfrm>
-            <a:off x="8737600" y="4394200"/>
-            <a:ext cx="254000" cy="254000"/>
+          <p:cNvPr id="40" name="Oval 39"/>
+          <p:cNvSpPr/>
+          <p:nvPr/>
+        </p:nvSpPr>
+        <p:spPr>
+          <a:xfrm>
+            <a:off x="8737600" y="4572000"/>
+            <a:ext cx="431800" cy="431800"/>
           </a:xfrm>
           <a:prstGeom prst="ellipse">
             <a:avLst/>
           </a:prstGeom>
           <a:solidFill>
+            <a:srgbClr val="1AAB70"/>
+          </a:solidFill>
+          <a:ln>
+            <a:noFill/>
+          </a:ln>
+          <a:effectLst/>
+        </p:spPr>
+        <p:style>
+          <a:lnRef idx="1">
+            <a:schemeClr val="accent1"/>
+          </a:lnRef>
+          <a:fillRef idx="3">
+            <a:schemeClr val="accent1"/>
+          </a:fillRef>
+          <a:effectRef idx="2">
+            <a:schemeClr val="accent1"/>
+          </a:effectRef>
+          <a:fontRef idx="minor">
+            <a:schemeClr val="lt1"/>
+          </a:fontRef>
+        </p:style>
+        <p:txBody>
+          <a:bodyPr rtlCol="0" anchor="ctr"/>
+          <a:lstStyle/>
+          <a:p>
+            <a:pPr algn="ctr"/>
+          </a:p>
+        </p:txBody>
+      </p:sp>
+      <p:sp>
+        <p:nvSpPr>
+          <p:cNvPr id="41" name="Rounded Rectangle 40"/>
+          <p:cNvSpPr/>
+          <p:nvPr/>
+        </p:nvSpPr>
+        <p:spPr>
+          <a:xfrm>
+            <a:off x="8801100" y="4749800"/>
+            <a:ext cx="177800" cy="139700"/>
+          </a:xfrm>
+          <a:prstGeom prst="roundRect">
+            <a:avLst>
+              <a:gd name="adj" fmla="val 13636"/>
+            </a:avLst>
+          </a:prstGeom>
+          <a:solidFill>
             <a:srgbClr val="1F5E3A"/>
           </a:solidFill>
           <a:ln>
@@ -51954,6 +52330,72 @@
         <p:txBody>
           <a:bodyPr rtlCol="0" anchor="ctr"/>
           <a:lstStyle/>
+          <a:p/>
+        </p:txBody>
+      </p:sp>
+      <p:sp>
+        <p:nvSpPr>
+          <p:cNvPr id="42" name="Freeform 41"/>
+          <p:cNvSpPr/>
+          <p:nvPr/>
+        </p:nvSpPr>
+        <p:spPr>
+          <a:xfrm>
+            <a:off x="8978900" y="4800600"/>
+            <a:ext cx="127000" cy="88900"/>
+          </a:xfrm>
+          <a:custGeom>
+            <a:avLst/>
+            <a:gdLst/>
+            <a:ahLst/>
+            <a:cxnLst/>
+            <a:rect l="l" t="t" r="r" b="b"/>
+            <a:pathLst>
+              <a:path w="127000" h="88900">
+                <a:moveTo>
+                  <a:pt x="0" y="0"/>
+                </a:moveTo>
+                <a:lnTo>
+                  <a:pt x="76200" y="0"/>
+                </a:lnTo>
+                <a:lnTo>
+                  <a:pt x="127000" y="50800"/>
+                </a:lnTo>
+                <a:lnTo>
+                  <a:pt x="127000" y="88900"/>
+                </a:lnTo>
+                <a:lnTo>
+                  <a:pt x="0" y="88900"/>
+                </a:lnTo>
+                <a:close/>
+              </a:path>
+            </a:pathLst>
+          </a:custGeom>
+          <a:solidFill>
+            <a:srgbClr val="1F5E3A"/>
+          </a:solidFill>
+          <a:ln>
+            <a:noFill/>
+          </a:ln>
+          <a:effectLst/>
+        </p:spPr>
+        <p:style>
+          <a:lnRef idx="1">
+            <a:schemeClr val="accent1"/>
+          </a:lnRef>
+          <a:fillRef idx="3">
+            <a:schemeClr val="accent1"/>
+          </a:fillRef>
+          <a:effectRef idx="2">
+            <a:schemeClr val="accent1"/>
+          </a:effectRef>
+          <a:fontRef idx="minor">
+            <a:schemeClr val="lt1"/>
+          </a:fontRef>
+        </p:style>
+        <p:txBody>
+          <a:bodyPr rtlCol="0" anchor="ctr"/>
+          <a:lstStyle/>
           <a:p>
             <a:pPr algn="ctr"/>
           </a:p>
@@ -51961,53 +52403,102 @@
       </p:sp>
       <p:sp>
         <p:nvSpPr>
-          <p:cNvPr id="34" name="TextBox 33"/>
+          <p:cNvPr id="43" name="Oval 42"/>
+          <p:cNvSpPr/>
+          <p:nvPr/>
+        </p:nvSpPr>
+        <p:spPr>
+          <a:xfrm>
+            <a:off x="8839200" y="4876800"/>
+            <a:ext cx="88900" cy="88900"/>
+          </a:xfrm>
+          <a:prstGeom prst="ellipse">
+            <a:avLst/>
+          </a:prstGeom>
+          <a:solidFill>
+            <a:srgbClr val="1F5E3A"/>
+          </a:solidFill>
+          <a:ln>
+            <a:noFill/>
+          </a:ln>
+          <a:effectLst/>
+        </p:spPr>
+        <p:style>
+          <a:lnRef idx="1">
+            <a:schemeClr val="accent1"/>
+          </a:lnRef>
+          <a:fillRef idx="3">
+            <a:schemeClr val="accent1"/>
+          </a:fillRef>
+          <a:effectRef idx="2">
+            <a:schemeClr val="accent1"/>
+          </a:effectRef>
+          <a:fontRef idx="minor">
+            <a:schemeClr val="lt1"/>
+          </a:fontRef>
+        </p:style>
+        <p:txBody>
+          <a:bodyPr rtlCol="0" anchor="ctr"/>
+          <a:lstStyle/>
+          <a:p>
+            <a:pPr algn="ctr"/>
+          </a:p>
+        </p:txBody>
+      </p:sp>
+      <p:sp>
+        <p:nvSpPr>
+          <p:cNvPr id="44" name="Oval 43"/>
+          <p:cNvSpPr/>
+          <p:nvPr/>
+        </p:nvSpPr>
+        <p:spPr>
+          <a:xfrm>
+            <a:off x="8991600" y="4876800"/>
+            <a:ext cx="88900" cy="88900"/>
+          </a:xfrm>
+          <a:prstGeom prst="ellipse">
+            <a:avLst/>
+          </a:prstGeom>
+          <a:solidFill>
+            <a:srgbClr val="1F5E3A"/>
+          </a:solidFill>
+          <a:ln>
+            <a:noFill/>
+          </a:ln>
+          <a:effectLst/>
+        </p:spPr>
+        <p:style>
+          <a:lnRef idx="1">
+            <a:schemeClr val="accent1"/>
+          </a:lnRef>
+          <a:fillRef idx="3">
+            <a:schemeClr val="accent1"/>
+          </a:fillRef>
+          <a:effectRef idx="2">
+            <a:schemeClr val="accent1"/>
+          </a:effectRef>
+          <a:fontRef idx="minor">
+            <a:schemeClr val="lt1"/>
+          </a:fontRef>
+        </p:style>
+        <p:txBody>
+          <a:bodyPr rtlCol="0" anchor="ctr"/>
+          <a:lstStyle/>
+          <a:p>
+            <a:pPr algn="ctr"/>
+          </a:p>
+        </p:txBody>
+      </p:sp>
+      <p:sp>
+        <p:nvSpPr>
+          <p:cNvPr id="45" name="TextBox 44"/>
           <p:cNvSpPr txBox="1"/>
           <p:nvPr/>
         </p:nvSpPr>
         <p:spPr>
           <a:xfrm>
-            <a:off x="8712200" y="4436999"/>
-            <a:ext cx="304800" cy="183515"/>
-          </a:xfrm>
-          <a:prstGeom prst="rect">
-            <a:avLst/>
-          </a:prstGeom>
-          <a:noFill/>
-        </p:spPr>
-        <p:txBody>
-          <a:bodyPr wrap="none" lIns="0" rIns="0" tIns="0" bIns="0" anchor="t">
-            <a:spAutoFit/>
-          </a:bodyPr>
-          <a:lstStyle/>
-          <a:p>
-            <a:pPr algn="ctr">
-              <a:lnSpc>
-                <a:spcPts val="1105"/>
-              </a:lnSpc>
-            </a:pPr>
-            <a:r>
-              <a:rPr sz="850" b="1" i="0">
-                <a:solidFill>
-                  <a:srgbClr val="FFFFFF"/>
-                </a:solidFill>
-                <a:latin typeface="Poppins"/>
-              </a:rPr>
-              <a:t>04</a:t>
-            </a:r>
-          </a:p>
-        </p:txBody>
-      </p:sp>
-      <p:sp>
-        <p:nvSpPr>
-          <p:cNvPr id="35" name="TextBox 34"/>
-          <p:cNvSpPr txBox="1"/>
-          <p:nvPr/>
-        </p:nvSpPr>
-        <p:spPr>
-          <a:xfrm>
-            <a:off x="9055100" y="4406900"/>
-            <a:ext cx="2298700" cy="269875"/>
+            <a:off x="9271000" y="4648200"/>
+            <a:ext cx="2057400" cy="269875"/>
           </a:xfrm>
           <a:prstGeom prst="rect">
             <a:avLst/>
@@ -52037,71 +52528,16 @@
           </a:p>
         </p:txBody>
       </p:sp>
-      <p:sp>
-        <p:nvSpPr>
-          <p:cNvPr id="36" name="TextBox 35"/>
-          <p:cNvSpPr txBox="1"/>
-          <p:nvPr/>
-        </p:nvSpPr>
-        <p:spPr>
-          <a:xfrm>
-            <a:off x="8712200" y="4831080"/>
-            <a:ext cx="2590800" cy="419100"/>
-          </a:xfrm>
-          <a:prstGeom prst="rect">
-            <a:avLst/>
-          </a:prstGeom>
-          <a:noFill/>
-        </p:spPr>
-        <p:txBody>
-          <a:bodyPr wrap="none" lIns="0" rIns="0" tIns="0" bIns="0" anchor="t">
-            <a:spAutoFit/>
-          </a:bodyPr>
-          <a:lstStyle/>
-          <a:p>
-            <a:pPr algn="l">
-              <a:lnSpc>
-                <a:spcPts val="1450"/>
-              </a:lnSpc>
-            </a:pPr>
-            <a:r>
-              <a:rPr sz="1000" b="0" i="0">
-                <a:solidFill>
-                  <a:srgbClr val="0A1A01"/>
-                </a:solidFill>
-                <a:latin typeface="Poppins"/>
-              </a:rPr>
-              <a:t>Grossistes, distributeurs</a:t>
-            </a:r>
-          </a:p>
-          <a:p>
-            <a:pPr algn="l">
-              <a:lnSpc>
-                <a:spcPts val="1450"/>
-              </a:lnSpc>
-            </a:pPr>
-            <a:r>
-              <a:rPr sz="1000" b="0" i="0">
-                <a:solidFill>
-                  <a:srgbClr val="0A1A01"/>
-                </a:solidFill>
-                <a:latin typeface="Poppins"/>
-              </a:rPr>
-              <a:t>&amp; acteurs de la chaîne</a:t>
-            </a:r>
-          </a:p>
-        </p:txBody>
-      </p:sp>
       <p:cxnSp>
         <p:nvCxnSpPr>
-          <p:cNvPr id="37" name="Connector 36"/>
+          <p:cNvPr id="46" name="Connector 45"/>
           <p:cNvCxnSpPr/>
           <p:nvPr/>
         </p:nvCxnSpPr>
         <p:spPr>
           <a:xfrm flipH="1" flipV="1">
-            <a:off x="3606800" y="2540000"/>
-            <a:ext cx="2489200" cy="736600"/>
+            <a:off x="3606800" y="2590800"/>
+            <a:ext cx="2489200" cy="685800"/>
           </a:xfrm>
           <a:prstGeom prst="line">
             <a:avLst/>
@@ -52130,14 +52566,14 @@
       </p:cxnSp>
       <p:cxnSp>
         <p:nvCxnSpPr>
-          <p:cNvPr id="38" name="Connector 37"/>
+          <p:cNvPr id="47" name="Connector 46"/>
           <p:cNvCxnSpPr/>
           <p:nvPr/>
         </p:nvCxnSpPr>
         <p:spPr>
           <a:xfrm flipV="1">
-            <a:off x="6096000" y="2540000"/>
-            <a:ext cx="2489200" cy="736600"/>
+            <a:off x="6096000" y="2590800"/>
+            <a:ext cx="2489200" cy="685800"/>
           </a:xfrm>
           <a:prstGeom prst="line">
             <a:avLst/>
@@ -52166,14 +52602,14 @@
       </p:cxnSp>
       <p:cxnSp>
         <p:nvCxnSpPr>
-          <p:cNvPr id="39" name="Connector 38"/>
+          <p:cNvPr id="48" name="Connector 47"/>
           <p:cNvCxnSpPr/>
           <p:nvPr/>
         </p:nvCxnSpPr>
         <p:spPr>
           <a:xfrm flipH="1">
             <a:off x="3657600" y="3276600"/>
-            <a:ext cx="2438400" cy="1244600"/>
+            <a:ext cx="2438400" cy="1346200"/>
           </a:xfrm>
           <a:prstGeom prst="line">
             <a:avLst/>
@@ -52202,14 +52638,14 @@
       </p:cxnSp>
       <p:cxnSp>
         <p:nvCxnSpPr>
-          <p:cNvPr id="40" name="Connector 39"/>
+          <p:cNvPr id="49" name="Connector 48"/>
           <p:cNvCxnSpPr/>
           <p:nvPr/>
         </p:nvCxnSpPr>
         <p:spPr>
           <a:xfrm>
             <a:off x="6096000" y="3276600"/>
-            <a:ext cx="0" cy="1244600"/>
+            <a:ext cx="0" cy="1447800"/>
           </a:xfrm>
           <a:prstGeom prst="line">
             <a:avLst/>
@@ -52238,14 +52674,14 @@
       </p:cxnSp>
       <p:cxnSp>
         <p:nvCxnSpPr>
-          <p:cNvPr id="41" name="Connector 40"/>
+          <p:cNvPr id="50" name="Connector 49"/>
           <p:cNvCxnSpPr/>
           <p:nvPr/>
         </p:nvCxnSpPr>
         <p:spPr>
           <a:xfrm>
             <a:off x="6096000" y="3276600"/>
-            <a:ext cx="2438400" cy="1244600"/>
+            <a:ext cx="2438400" cy="1346200"/>
           </a:xfrm>
           <a:prstGeom prst="line">
             <a:avLst/>
@@ -52274,7 +52710,7 @@
       </p:cxnSp>
       <p:sp>
         <p:nvSpPr>
-          <p:cNvPr id="42" name="Rectangle 41"/>
+          <p:cNvPr id="51" name="Rectangle 50"/>
           <p:cNvSpPr/>
           <p:nvPr/>
         </p:nvSpPr>

</xml_diff>

<commit_message>
Page marche cible: photos reelles par cible a la place des icones
Co-authored-by: arena-agent <297053741+arena-agent@users.noreply.github.com>
</commit_message>
<xml_diff>
--- a/Pitch_Deck_Sadiya_Digital_Agri.pptx
+++ b/Pitch_Deck_Sadiya_Digital_Agri.pptx
@@ -50985,12 +50985,12 @@
         </p:nvSpPr>
         <p:spPr>
           <a:xfrm>
-            <a:off x="660400" y="2133600"/>
-            <a:ext cx="2946400" cy="914400"/>
+            <a:off x="660400" y="2032000"/>
+            <a:ext cx="2946400" cy="1066800"/>
           </a:xfrm>
           <a:prstGeom prst="roundRect">
             <a:avLst>
-              <a:gd name="adj" fmla="val 13888"/>
+              <a:gd name="adj" fmla="val 11904"/>
             </a:avLst>
           </a:prstGeom>
           <a:solidFill>
@@ -51023,227 +51023,40 @@
           <a:p/>
         </p:txBody>
       </p:sp>
-      <p:sp>
-        <p:nvSpPr>
-          <p:cNvPr id="13" name="Oval 12"/>
-          <p:cNvSpPr/>
-          <p:nvPr/>
-        </p:nvSpPr>
-        <p:spPr>
-          <a:xfrm>
-            <a:off x="863600" y="2387600"/>
-            <a:ext cx="431800" cy="431800"/>
-          </a:xfrm>
-          <a:prstGeom prst="ellipse">
-            <a:avLst/>
-          </a:prstGeom>
-          <a:solidFill>
-            <a:srgbClr val="1AAB70"/>
-          </a:solidFill>
-          <a:ln>
-            <a:noFill/>
-          </a:ln>
-          <a:effectLst/>
-        </p:spPr>
-        <p:style>
-          <a:lnRef idx="1">
-            <a:schemeClr val="accent1"/>
-          </a:lnRef>
-          <a:fillRef idx="3">
-            <a:schemeClr val="accent1"/>
-          </a:fillRef>
-          <a:effectRef idx="2">
-            <a:schemeClr val="accent1"/>
-          </a:effectRef>
-          <a:fontRef idx="minor">
-            <a:schemeClr val="lt1"/>
-          </a:fontRef>
-        </p:style>
-        <p:txBody>
-          <a:bodyPr rtlCol="0" anchor="ctr"/>
-          <a:lstStyle/>
-          <a:p>
-            <a:pPr algn="ctr"/>
-          </a:p>
-        </p:txBody>
-      </p:sp>
-      <p:cxnSp>
-        <p:nvCxnSpPr>
-          <p:cNvPr id="14" name="Connector 13"/>
-          <p:cNvCxnSpPr/>
-          <p:nvPr/>
-        </p:nvCxnSpPr>
-        <p:spPr>
-          <a:xfrm flipV="1">
-            <a:off x="1079500" y="2578100"/>
-            <a:ext cx="0" cy="177800"/>
-          </a:xfrm>
-          <a:prstGeom prst="line">
-            <a:avLst/>
-          </a:prstGeom>
-          <a:ln w="22860">
-            <a:solidFill>
-              <a:srgbClr val="1F5E3A"/>
-            </a:solidFill>
-          </a:ln>
-        </p:spPr>
-        <p:style>
-          <a:lnRef idx="2">
-            <a:schemeClr val="accent1"/>
-          </a:lnRef>
-          <a:fillRef idx="0">
-            <a:schemeClr val="accent1"/>
-          </a:fillRef>
-          <a:effectRef idx="1">
-            <a:schemeClr val="accent1"/>
-          </a:effectRef>
-          <a:fontRef idx="minor">
-            <a:schemeClr val="tx1"/>
-          </a:fontRef>
-        </p:style>
-      </p:cxnSp>
-      <p:sp>
-        <p:nvSpPr>
-          <p:cNvPr id="15" name="Oval 14"/>
-          <p:cNvSpPr/>
-          <p:nvPr/>
-        </p:nvSpPr>
-        <p:spPr>
-          <a:xfrm>
-            <a:off x="939800" y="2565400"/>
-            <a:ext cx="152400" cy="114300"/>
-          </a:xfrm>
-          <a:prstGeom prst="ellipse">
-            <a:avLst/>
-          </a:prstGeom>
-          <a:solidFill>
-            <a:srgbClr val="1F5E3A"/>
-          </a:solidFill>
-          <a:ln>
-            <a:noFill/>
-          </a:ln>
-          <a:effectLst/>
-        </p:spPr>
-        <p:style>
-          <a:lnRef idx="1">
-            <a:schemeClr val="accent1"/>
-          </a:lnRef>
-          <a:fillRef idx="3">
-            <a:schemeClr val="accent1"/>
-          </a:fillRef>
-          <a:effectRef idx="2">
-            <a:schemeClr val="accent1"/>
-          </a:effectRef>
-          <a:fontRef idx="minor">
-            <a:schemeClr val="lt1"/>
-          </a:fontRef>
-        </p:style>
-        <p:txBody>
-          <a:bodyPr rtlCol="0" anchor="ctr"/>
-          <a:lstStyle/>
-          <a:p>
-            <a:pPr algn="ctr"/>
-          </a:p>
-        </p:txBody>
-      </p:sp>
-      <p:sp>
-        <p:nvSpPr>
-          <p:cNvPr id="16" name="Oval 15"/>
-          <p:cNvSpPr/>
-          <p:nvPr/>
-        </p:nvSpPr>
-        <p:spPr>
-          <a:xfrm>
-            <a:off x="1066800" y="2501900"/>
-            <a:ext cx="152400" cy="114300"/>
-          </a:xfrm>
-          <a:prstGeom prst="ellipse">
-            <a:avLst/>
-          </a:prstGeom>
-          <a:solidFill>
-            <a:srgbClr val="1F5E3A"/>
-          </a:solidFill>
-          <a:ln>
-            <a:noFill/>
-          </a:ln>
-          <a:effectLst/>
-        </p:spPr>
-        <p:style>
-          <a:lnRef idx="1">
-            <a:schemeClr val="accent1"/>
-          </a:lnRef>
-          <a:fillRef idx="3">
-            <a:schemeClr val="accent1"/>
-          </a:fillRef>
-          <a:effectRef idx="2">
-            <a:schemeClr val="accent1"/>
-          </a:effectRef>
-          <a:fontRef idx="minor">
-            <a:schemeClr val="lt1"/>
-          </a:fontRef>
-        </p:style>
-        <p:txBody>
-          <a:bodyPr rtlCol="0" anchor="ctr"/>
-          <a:lstStyle/>
-          <a:p>
-            <a:pPr algn="ctr"/>
-          </a:p>
-        </p:txBody>
-      </p:sp>
-      <p:sp>
-        <p:nvSpPr>
-          <p:cNvPr id="17" name="Rounded Rectangle 16"/>
-          <p:cNvSpPr/>
-          <p:nvPr/>
-        </p:nvSpPr>
-        <p:spPr>
-          <a:xfrm>
-            <a:off x="952500" y="2743200"/>
-            <a:ext cx="254000" cy="38100"/>
-          </a:xfrm>
-          <a:prstGeom prst="roundRect">
-            <a:avLst>
-              <a:gd name="adj" fmla="val 50000"/>
-            </a:avLst>
-          </a:prstGeom>
-          <a:solidFill>
-            <a:srgbClr val="1F5E3A"/>
-          </a:solidFill>
-          <a:ln>
-            <a:noFill/>
-          </a:ln>
-          <a:effectLst/>
-        </p:spPr>
-        <p:style>
-          <a:lnRef idx="1">
-            <a:schemeClr val="accent1"/>
-          </a:lnRef>
-          <a:fillRef idx="3">
-            <a:schemeClr val="accent1"/>
-          </a:fillRef>
-          <a:effectRef idx="2">
-            <a:schemeClr val="accent1"/>
-          </a:effectRef>
-          <a:fontRef idx="minor">
-            <a:schemeClr val="lt1"/>
-          </a:fontRef>
-        </p:style>
-        <p:txBody>
-          <a:bodyPr rtlCol="0" anchor="ctr"/>
-          <a:lstStyle/>
-          <a:p/>
-        </p:txBody>
-      </p:sp>
-      <p:sp>
-        <p:nvSpPr>
-          <p:cNvPr id="18" name="TextBox 17"/>
+      <p:pic>
+        <p:nvPicPr>
+          <p:cNvPr id="13" name="Picture 12" descr="cible_producteur.jpg"/>
+          <p:cNvPicPr>
+            <a:picLocks noChangeAspect="1"/>
+          </p:cNvPicPr>
+          <p:nvPr/>
+        </p:nvPicPr>
+        <p:blipFill>
+          <a:blip r:embed="rId3"/>
+          <a:stretch>
+            <a:fillRect/>
+          </a:stretch>
+        </p:blipFill>
+        <p:spPr>
+          <a:xfrm>
+            <a:off x="812800" y="2184400"/>
+            <a:ext cx="762000" cy="762000"/>
+          </a:xfrm>
+          <a:prstGeom prst="rect">
+            <a:avLst/>
+          </a:prstGeom>
+        </p:spPr>
+      </p:pic>
+      <p:sp>
+        <p:nvSpPr>
+          <p:cNvPr id="14" name="TextBox 13"/>
           <p:cNvSpPr txBox="1"/>
           <p:nvPr/>
         </p:nvSpPr>
         <p:spPr>
           <a:xfrm>
-            <a:off x="1397000" y="2463800"/>
-            <a:ext cx="2057400" cy="269875"/>
+            <a:off x="1701800" y="2438400"/>
+            <a:ext cx="1778000" cy="254000"/>
           </a:xfrm>
           <a:prstGeom prst="rect">
             <a:avLst/>
@@ -51258,7 +51071,7 @@
           <a:p>
             <a:pPr algn="l">
               <a:lnSpc>
-                <a:spcPts val="1625"/>
+                <a:spcPts val="1500"/>
               </a:lnSpc>
             </a:pPr>
             <a:r>
@@ -51275,18 +51088,18 @@
       </p:sp>
       <p:sp>
         <p:nvSpPr>
-          <p:cNvPr id="19" name="Rounded Rectangle 18"/>
-          <p:cNvSpPr/>
-          <p:nvPr/>
-        </p:nvSpPr>
-        <p:spPr>
-          <a:xfrm>
-            <a:off x="8585200" y="2133600"/>
-            <a:ext cx="2946400" cy="914400"/>
+          <p:cNvPr id="15" name="Rounded Rectangle 14"/>
+          <p:cNvSpPr/>
+          <p:nvPr/>
+        </p:nvSpPr>
+        <p:spPr>
+          <a:xfrm>
+            <a:off x="8585200" y="2032000"/>
+            <a:ext cx="2946400" cy="1066800"/>
           </a:xfrm>
           <a:prstGeom prst="roundRect">
             <a:avLst>
-              <a:gd name="adj" fmla="val 13888"/>
+              <a:gd name="adj" fmla="val 11904"/>
             </a:avLst>
           </a:prstGeom>
           <a:solidFill>
@@ -51319,211 +51132,40 @@
           <a:p/>
         </p:txBody>
       </p:sp>
-      <p:sp>
-        <p:nvSpPr>
-          <p:cNvPr id="20" name="Oval 19"/>
-          <p:cNvSpPr/>
-          <p:nvPr/>
-        </p:nvSpPr>
-        <p:spPr>
-          <a:xfrm>
-            <a:off x="8788400" y="2387600"/>
-            <a:ext cx="431800" cy="431800"/>
-          </a:xfrm>
-          <a:prstGeom prst="ellipse">
-            <a:avLst/>
-          </a:prstGeom>
-          <a:solidFill>
-            <a:srgbClr val="1AAB70"/>
-          </a:solidFill>
-          <a:ln>
-            <a:noFill/>
-          </a:ln>
-          <a:effectLst/>
-        </p:spPr>
-        <p:style>
-          <a:lnRef idx="1">
-            <a:schemeClr val="accent1"/>
-          </a:lnRef>
-          <a:fillRef idx="3">
-            <a:schemeClr val="accent1"/>
-          </a:fillRef>
-          <a:effectRef idx="2">
-            <a:schemeClr val="accent1"/>
-          </a:effectRef>
-          <a:fontRef idx="minor">
-            <a:schemeClr val="lt1"/>
-          </a:fontRef>
-        </p:style>
-        <p:txBody>
-          <a:bodyPr rtlCol="0" anchor="ctr"/>
-          <a:lstStyle/>
-          <a:p>
-            <a:pPr algn="ctr"/>
-          </a:p>
-        </p:txBody>
-      </p:sp>
-      <p:sp>
-        <p:nvSpPr>
-          <p:cNvPr id="21" name="Freeform 20"/>
-          <p:cNvSpPr/>
-          <p:nvPr/>
-        </p:nvSpPr>
-        <p:spPr>
-          <a:xfrm>
-            <a:off x="8890000" y="2578100"/>
-            <a:ext cx="228600" cy="190500"/>
-          </a:xfrm>
-          <a:custGeom>
-            <a:avLst/>
-            <a:gdLst/>
-            <a:ahLst/>
-            <a:cxnLst/>
-            <a:rect l="l" t="t" r="r" b="b"/>
-            <a:pathLst>
-              <a:path w="228600" h="190500">
-                <a:moveTo>
-                  <a:pt x="0" y="0"/>
-                </a:moveTo>
-                <a:lnTo>
-                  <a:pt x="228600" y="0"/>
-                </a:lnTo>
-                <a:lnTo>
-                  <a:pt x="203200" y="190500"/>
-                </a:lnTo>
-                <a:lnTo>
-                  <a:pt x="25400" y="190500"/>
-                </a:lnTo>
-                <a:close/>
-              </a:path>
-            </a:pathLst>
-          </a:custGeom>
-          <a:solidFill>
-            <a:srgbClr val="1F5E3A"/>
-          </a:solidFill>
-          <a:ln>
-            <a:noFill/>
-          </a:ln>
-          <a:effectLst/>
-        </p:spPr>
-        <p:style>
-          <a:lnRef idx="1">
-            <a:schemeClr val="accent1"/>
-          </a:lnRef>
-          <a:fillRef idx="3">
-            <a:schemeClr val="accent1"/>
-          </a:fillRef>
-          <a:effectRef idx="2">
-            <a:schemeClr val="accent1"/>
-          </a:effectRef>
-          <a:fontRef idx="minor">
-            <a:schemeClr val="lt1"/>
-          </a:fontRef>
-        </p:style>
-        <p:txBody>
-          <a:bodyPr rtlCol="0" anchor="ctr"/>
-          <a:lstStyle/>
-          <a:p>
-            <a:pPr algn="ctr"/>
-          </a:p>
-        </p:txBody>
-      </p:sp>
-      <p:sp>
-        <p:nvSpPr>
-          <p:cNvPr id="22" name="Oval 21"/>
-          <p:cNvSpPr/>
-          <p:nvPr/>
-        </p:nvSpPr>
-        <p:spPr>
-          <a:xfrm>
-            <a:off x="8940800" y="2476500"/>
-            <a:ext cx="127000" cy="139700"/>
-          </a:xfrm>
-          <a:prstGeom prst="ellipse">
-            <a:avLst/>
-          </a:prstGeom>
-          <a:noFill/>
-          <a:ln w="22860">
-            <a:solidFill>
-              <a:srgbClr val="1F5E3A"/>
-            </a:solidFill>
-          </a:ln>
-          <a:effectLst/>
-        </p:spPr>
-        <p:style>
-          <a:lnRef idx="1">
-            <a:schemeClr val="accent1"/>
-          </a:lnRef>
-          <a:fillRef idx="3">
-            <a:schemeClr val="accent1"/>
-          </a:fillRef>
-          <a:effectRef idx="2">
-            <a:schemeClr val="accent1"/>
-          </a:effectRef>
-          <a:fontRef idx="minor">
-            <a:schemeClr val="lt1"/>
-          </a:fontRef>
-        </p:style>
-        <p:txBody>
-          <a:bodyPr rtlCol="0" anchor="ctr"/>
-          <a:lstStyle/>
-          <a:p>
-            <a:pPr algn="ctr"/>
-          </a:p>
-        </p:txBody>
-      </p:sp>
-      <p:sp>
-        <p:nvSpPr>
-          <p:cNvPr id="23" name="Rectangle 22"/>
-          <p:cNvSpPr/>
-          <p:nvPr/>
-        </p:nvSpPr>
-        <p:spPr>
-          <a:xfrm>
-            <a:off x="8940800" y="2552700"/>
-            <a:ext cx="127000" cy="63500"/>
-          </a:xfrm>
-          <a:prstGeom prst="rect">
-            <a:avLst/>
-          </a:prstGeom>
-          <a:solidFill>
-            <a:srgbClr val="FFFFFF"/>
-          </a:solidFill>
-          <a:ln>
-            <a:noFill/>
-          </a:ln>
-          <a:effectLst/>
-        </p:spPr>
-        <p:style>
-          <a:lnRef idx="1">
-            <a:schemeClr val="accent1"/>
-          </a:lnRef>
-          <a:fillRef idx="3">
-            <a:schemeClr val="accent1"/>
-          </a:fillRef>
-          <a:effectRef idx="2">
-            <a:schemeClr val="accent1"/>
-          </a:effectRef>
-          <a:fontRef idx="minor">
-            <a:schemeClr val="lt1"/>
-          </a:fontRef>
-        </p:style>
-        <p:txBody>
-          <a:bodyPr rtlCol="0" anchor="ctr"/>
-          <a:lstStyle/>
-          <a:p/>
-        </p:txBody>
-      </p:sp>
-      <p:sp>
-        <p:nvSpPr>
-          <p:cNvPr id="24" name="TextBox 23"/>
+      <p:pic>
+        <p:nvPicPr>
+          <p:cNvPr id="16" name="Picture 15" descr="cible_acheteur.jpg"/>
+          <p:cNvPicPr>
+            <a:picLocks noChangeAspect="1"/>
+          </p:cNvPicPr>
+          <p:nvPr/>
+        </p:nvPicPr>
+        <p:blipFill>
+          <a:blip r:embed="rId4"/>
+          <a:stretch>
+            <a:fillRect/>
+          </a:stretch>
+        </p:blipFill>
+        <p:spPr>
+          <a:xfrm>
+            <a:off x="8737600" y="2184400"/>
+            <a:ext cx="762000" cy="762000"/>
+          </a:xfrm>
+          <a:prstGeom prst="rect">
+            <a:avLst/>
+          </a:prstGeom>
+        </p:spPr>
+      </p:pic>
+      <p:sp>
+        <p:nvSpPr>
+          <p:cNvPr id="17" name="TextBox 16"/>
           <p:cNvSpPr txBox="1"/>
           <p:nvPr/>
         </p:nvSpPr>
         <p:spPr>
           <a:xfrm>
-            <a:off x="9321800" y="2463800"/>
-            <a:ext cx="2057400" cy="269875"/>
+            <a:off x="9626600" y="2438400"/>
+            <a:ext cx="1778000" cy="254000"/>
           </a:xfrm>
           <a:prstGeom prst="rect">
             <a:avLst/>
@@ -51538,7 +51180,7 @@
           <a:p>
             <a:pPr algn="l">
               <a:lnSpc>
-                <a:spcPts val="1625"/>
+                <a:spcPts val="1500"/>
               </a:lnSpc>
             </a:pPr>
             <a:r>
@@ -51555,18 +51197,18 @@
       </p:sp>
       <p:sp>
         <p:nvSpPr>
-          <p:cNvPr id="25" name="Rounded Rectangle 24"/>
-          <p:cNvSpPr/>
-          <p:nvPr/>
-        </p:nvSpPr>
-        <p:spPr>
-          <a:xfrm>
-            <a:off x="787400" y="4318000"/>
-            <a:ext cx="2870200" cy="914400"/>
+          <p:cNvPr id="18" name="Rounded Rectangle 17"/>
+          <p:cNvSpPr/>
+          <p:nvPr/>
+        </p:nvSpPr>
+        <p:spPr>
+          <a:xfrm>
+            <a:off x="787400" y="4267200"/>
+            <a:ext cx="2870200" cy="1066800"/>
           </a:xfrm>
           <a:prstGeom prst="roundRect">
             <a:avLst>
-              <a:gd name="adj" fmla="val 13888"/>
+              <a:gd name="adj" fmla="val 11904"/>
             </a:avLst>
           </a:prstGeom>
           <a:solidFill>
@@ -51599,272 +51241,40 @@
           <a:p/>
         </p:txBody>
       </p:sp>
-      <p:sp>
-        <p:nvSpPr>
-          <p:cNvPr id="26" name="Oval 25"/>
-          <p:cNvSpPr/>
-          <p:nvPr/>
-        </p:nvSpPr>
-        <p:spPr>
-          <a:xfrm>
-            <a:off x="990600" y="4572000"/>
-            <a:ext cx="431800" cy="431800"/>
-          </a:xfrm>
-          <a:prstGeom prst="ellipse">
-            <a:avLst/>
-          </a:prstGeom>
-          <a:solidFill>
-            <a:srgbClr val="1AAB70"/>
-          </a:solidFill>
-          <a:ln>
-            <a:noFill/>
-          </a:ln>
-          <a:effectLst/>
-        </p:spPr>
-        <p:style>
-          <a:lnRef idx="1">
-            <a:schemeClr val="accent1"/>
-          </a:lnRef>
-          <a:fillRef idx="3">
-            <a:schemeClr val="accent1"/>
-          </a:fillRef>
-          <a:effectRef idx="2">
-            <a:schemeClr val="accent1"/>
-          </a:effectRef>
-          <a:fontRef idx="minor">
-            <a:schemeClr val="lt1"/>
-          </a:fontRef>
-        </p:style>
-        <p:txBody>
-          <a:bodyPr rtlCol="0" anchor="ctr"/>
-          <a:lstStyle/>
-          <a:p>
-            <a:pPr algn="ctr"/>
-          </a:p>
-        </p:txBody>
-      </p:sp>
-      <p:sp>
-        <p:nvSpPr>
-          <p:cNvPr id="27" name="Rounded Rectangle 26"/>
-          <p:cNvSpPr/>
-          <p:nvPr/>
-        </p:nvSpPr>
-        <p:spPr>
-          <a:xfrm>
-            <a:off x="1066800" y="4787900"/>
-            <a:ext cx="279400" cy="177800"/>
-          </a:xfrm>
-          <a:prstGeom prst="roundRect">
-            <a:avLst>
-              <a:gd name="adj" fmla="val 10714"/>
-            </a:avLst>
-          </a:prstGeom>
-          <a:solidFill>
-            <a:srgbClr val="1F5E3A"/>
-          </a:solidFill>
-          <a:ln>
-            <a:noFill/>
-          </a:ln>
-          <a:effectLst/>
-        </p:spPr>
-        <p:style>
-          <a:lnRef idx="1">
-            <a:schemeClr val="accent1"/>
-          </a:lnRef>
-          <a:fillRef idx="3">
-            <a:schemeClr val="accent1"/>
-          </a:fillRef>
-          <a:effectRef idx="2">
-            <a:schemeClr val="accent1"/>
-          </a:effectRef>
-          <a:fontRef idx="minor">
-            <a:schemeClr val="lt1"/>
-          </a:fontRef>
-        </p:style>
-        <p:txBody>
-          <a:bodyPr rtlCol="0" anchor="ctr"/>
-          <a:lstStyle/>
-          <a:p/>
-        </p:txBody>
-      </p:sp>
-      <p:sp>
-        <p:nvSpPr>
-          <p:cNvPr id="28" name="Rounded Rectangle 27"/>
-          <p:cNvSpPr/>
-          <p:nvPr/>
-        </p:nvSpPr>
-        <p:spPr>
-          <a:xfrm>
-            <a:off x="1104900" y="4686300"/>
-            <a:ext cx="63500" cy="101600"/>
-          </a:xfrm>
-          <a:prstGeom prst="roundRect">
-            <a:avLst>
-              <a:gd name="adj" fmla="val 20000"/>
-            </a:avLst>
-          </a:prstGeom>
-          <a:solidFill>
-            <a:srgbClr val="1F5E3A"/>
-          </a:solidFill>
-          <a:ln>
-            <a:noFill/>
-          </a:ln>
-          <a:effectLst/>
-        </p:spPr>
-        <p:style>
-          <a:lnRef idx="1">
-            <a:schemeClr val="accent1"/>
-          </a:lnRef>
-          <a:fillRef idx="3">
-            <a:schemeClr val="accent1"/>
-          </a:fillRef>
-          <a:effectRef idx="2">
-            <a:schemeClr val="accent1"/>
-          </a:effectRef>
-          <a:fontRef idx="minor">
-            <a:schemeClr val="lt1"/>
-          </a:fontRef>
-        </p:style>
-        <p:txBody>
-          <a:bodyPr rtlCol="0" anchor="ctr"/>
-          <a:lstStyle/>
-          <a:p/>
-        </p:txBody>
-      </p:sp>
-      <p:sp>
-        <p:nvSpPr>
-          <p:cNvPr id="29" name="Freeform 28"/>
-          <p:cNvSpPr/>
-          <p:nvPr/>
-        </p:nvSpPr>
-        <p:spPr>
-          <a:xfrm>
-            <a:off x="1193800" y="4787900"/>
-            <a:ext cx="76200" cy="76200"/>
-          </a:xfrm>
-          <a:custGeom>
-            <a:avLst/>
-            <a:gdLst/>
-            <a:ahLst/>
-            <a:cxnLst/>
-            <a:rect l="l" t="t" r="r" b="b"/>
-            <a:pathLst>
-              <a:path w="76200" h="76200">
-                <a:moveTo>
-                  <a:pt x="0" y="76200"/>
-                </a:moveTo>
-                <a:lnTo>
-                  <a:pt x="76200" y="0"/>
-                </a:lnTo>
-                <a:lnTo>
-                  <a:pt x="76200" y="76200"/>
-                </a:lnTo>
-                <a:close/>
-              </a:path>
-            </a:pathLst>
-          </a:custGeom>
-          <a:solidFill>
-            <a:srgbClr val="FFFFFF"/>
-          </a:solidFill>
-          <a:ln>
-            <a:noFill/>
-          </a:ln>
-          <a:effectLst/>
-        </p:spPr>
-        <p:style>
-          <a:lnRef idx="1">
-            <a:schemeClr val="accent1"/>
-          </a:lnRef>
-          <a:fillRef idx="3">
-            <a:schemeClr val="accent1"/>
-          </a:fillRef>
-          <a:effectRef idx="2">
-            <a:schemeClr val="accent1"/>
-          </a:effectRef>
-          <a:fontRef idx="minor">
-            <a:schemeClr val="lt1"/>
-          </a:fontRef>
-        </p:style>
-        <p:txBody>
-          <a:bodyPr rtlCol="0" anchor="ctr"/>
-          <a:lstStyle/>
-          <a:p>
-            <a:pPr algn="ctr"/>
-          </a:p>
-        </p:txBody>
-      </p:sp>
-      <p:sp>
-        <p:nvSpPr>
-          <p:cNvPr id="30" name="Freeform 29"/>
-          <p:cNvSpPr/>
-          <p:nvPr/>
-        </p:nvSpPr>
-        <p:spPr>
-          <a:xfrm>
-            <a:off x="1270000" y="4787900"/>
-            <a:ext cx="76200" cy="76200"/>
-          </a:xfrm>
-          <a:custGeom>
-            <a:avLst/>
-            <a:gdLst/>
-            <a:ahLst/>
-            <a:cxnLst/>
-            <a:rect l="l" t="t" r="r" b="b"/>
-            <a:pathLst>
-              <a:path w="76200" h="76200">
-                <a:moveTo>
-                  <a:pt x="0" y="76200"/>
-                </a:moveTo>
-                <a:lnTo>
-                  <a:pt x="76200" y="0"/>
-                </a:lnTo>
-                <a:lnTo>
-                  <a:pt x="76200" y="76200"/>
-                </a:lnTo>
-                <a:close/>
-              </a:path>
-            </a:pathLst>
-          </a:custGeom>
-          <a:solidFill>
-            <a:srgbClr val="FFFFFF"/>
-          </a:solidFill>
-          <a:ln>
-            <a:noFill/>
-          </a:ln>
-          <a:effectLst/>
-        </p:spPr>
-        <p:style>
-          <a:lnRef idx="1">
-            <a:schemeClr val="accent1"/>
-          </a:lnRef>
-          <a:fillRef idx="3">
-            <a:schemeClr val="accent1"/>
-          </a:fillRef>
-          <a:effectRef idx="2">
-            <a:schemeClr val="accent1"/>
-          </a:effectRef>
-          <a:fontRef idx="minor">
-            <a:schemeClr val="lt1"/>
-          </a:fontRef>
-        </p:style>
-        <p:txBody>
-          <a:bodyPr rtlCol="0" anchor="ctr"/>
-          <a:lstStyle/>
-          <a:p>
-            <a:pPr algn="ctr"/>
-          </a:p>
-        </p:txBody>
-      </p:sp>
-      <p:sp>
-        <p:nvSpPr>
-          <p:cNvPr id="31" name="TextBox 30"/>
+      <p:pic>
+        <p:nvPicPr>
+          <p:cNvPr id="19" name="Picture 18" descr="cible_transformateur.jpg"/>
+          <p:cNvPicPr>
+            <a:picLocks noChangeAspect="1"/>
+          </p:cNvPicPr>
+          <p:nvPr/>
+        </p:nvPicPr>
+        <p:blipFill>
+          <a:blip r:embed="rId5"/>
+          <a:stretch>
+            <a:fillRect/>
+          </a:stretch>
+        </p:blipFill>
+        <p:spPr>
+          <a:xfrm>
+            <a:off x="939800" y="4419600"/>
+            <a:ext cx="762000" cy="762000"/>
+          </a:xfrm>
+          <a:prstGeom prst="rect">
+            <a:avLst/>
+          </a:prstGeom>
+        </p:spPr>
+      </p:pic>
+      <p:sp>
+        <p:nvSpPr>
+          <p:cNvPr id="20" name="TextBox 19"/>
           <p:cNvSpPr txBox="1"/>
           <p:nvPr/>
         </p:nvSpPr>
         <p:spPr>
           <a:xfrm>
-            <a:off x="1524000" y="4648200"/>
-            <a:ext cx="1981200" cy="269875"/>
+            <a:off x="1828800" y="4673600"/>
+            <a:ext cx="1701800" cy="254000"/>
           </a:xfrm>
           <a:prstGeom prst="rect">
             <a:avLst/>
@@ -51879,7 +51289,7 @@
           <a:p>
             <a:pPr algn="l">
               <a:lnSpc>
-                <a:spcPts val="1625"/>
+                <a:spcPts val="1500"/>
               </a:lnSpc>
             </a:pPr>
             <a:r>
@@ -51896,18 +51306,18 @@
       </p:sp>
       <p:sp>
         <p:nvSpPr>
-          <p:cNvPr id="32" name="Rounded Rectangle 31"/>
-          <p:cNvSpPr/>
-          <p:nvPr/>
-        </p:nvSpPr>
-        <p:spPr>
-          <a:xfrm>
-            <a:off x="4648200" y="4597400"/>
-            <a:ext cx="2895600" cy="914400"/>
+          <p:cNvPr id="21" name="Rounded Rectangle 20"/>
+          <p:cNvSpPr/>
+          <p:nvPr/>
+        </p:nvSpPr>
+        <p:spPr>
+          <a:xfrm>
+            <a:off x="4648200" y="4572000"/>
+            <a:ext cx="2895600" cy="1066800"/>
           </a:xfrm>
           <a:prstGeom prst="roundRect">
             <a:avLst>
-              <a:gd name="adj" fmla="val 13888"/>
+              <a:gd name="adj" fmla="val 11904"/>
             </a:avLst>
           </a:prstGeom>
           <a:solidFill>
@@ -51940,236 +51350,40 @@
           <a:p/>
         </p:txBody>
       </p:sp>
-      <p:sp>
-        <p:nvSpPr>
-          <p:cNvPr id="33" name="Oval 32"/>
-          <p:cNvSpPr/>
-          <p:nvPr/>
-        </p:nvSpPr>
-        <p:spPr>
-          <a:xfrm>
-            <a:off x="4851400" y="4851400"/>
-            <a:ext cx="431800" cy="431800"/>
-          </a:xfrm>
-          <a:prstGeom prst="ellipse">
-            <a:avLst/>
-          </a:prstGeom>
-          <a:solidFill>
-            <a:srgbClr val="1AAB70"/>
-          </a:solidFill>
-          <a:ln>
-            <a:noFill/>
-          </a:ln>
-          <a:effectLst/>
-        </p:spPr>
-        <p:style>
-          <a:lnRef idx="1">
-            <a:schemeClr val="accent1"/>
-          </a:lnRef>
-          <a:fillRef idx="3">
-            <a:schemeClr val="accent1"/>
-          </a:fillRef>
-          <a:effectRef idx="2">
-            <a:schemeClr val="accent1"/>
-          </a:effectRef>
-          <a:fontRef idx="minor">
-            <a:schemeClr val="lt1"/>
-          </a:fontRef>
-        </p:style>
-        <p:txBody>
-          <a:bodyPr rtlCol="0" anchor="ctr"/>
-          <a:lstStyle/>
-          <a:p>
-            <a:pPr algn="ctr"/>
-          </a:p>
-        </p:txBody>
-      </p:sp>
-      <p:sp>
-        <p:nvSpPr>
-          <p:cNvPr id="34" name="Oval 33"/>
-          <p:cNvSpPr/>
-          <p:nvPr/>
-        </p:nvSpPr>
-        <p:spPr>
-          <a:xfrm>
-            <a:off x="4927600" y="4978400"/>
-            <a:ext cx="114300" cy="114300"/>
-          </a:xfrm>
-          <a:prstGeom prst="ellipse">
-            <a:avLst/>
-          </a:prstGeom>
-          <a:solidFill>
-            <a:srgbClr val="1F5E3A"/>
-          </a:solidFill>
-          <a:ln>
-            <a:noFill/>
-          </a:ln>
-          <a:effectLst/>
-        </p:spPr>
-        <p:style>
-          <a:lnRef idx="1">
-            <a:schemeClr val="accent1"/>
-          </a:lnRef>
-          <a:fillRef idx="3">
-            <a:schemeClr val="accent1"/>
-          </a:fillRef>
-          <a:effectRef idx="2">
-            <a:schemeClr val="accent1"/>
-          </a:effectRef>
-          <a:fontRef idx="minor">
-            <a:schemeClr val="lt1"/>
-          </a:fontRef>
-        </p:style>
-        <p:txBody>
-          <a:bodyPr rtlCol="0" anchor="ctr"/>
-          <a:lstStyle/>
-          <a:p>
-            <a:pPr algn="ctr"/>
-          </a:p>
-        </p:txBody>
-      </p:sp>
-      <p:sp>
-        <p:nvSpPr>
-          <p:cNvPr id="35" name="Oval 34"/>
-          <p:cNvSpPr/>
-          <p:nvPr/>
-        </p:nvSpPr>
-        <p:spPr>
-          <a:xfrm>
-            <a:off x="5035550" y="4978400"/>
-            <a:ext cx="139700" cy="139700"/>
-          </a:xfrm>
-          <a:prstGeom prst="ellipse">
-            <a:avLst/>
-          </a:prstGeom>
-          <a:solidFill>
-            <a:srgbClr val="1F5E3A"/>
-          </a:solidFill>
-          <a:ln>
-            <a:noFill/>
-          </a:ln>
-          <a:effectLst/>
-        </p:spPr>
-        <p:style>
-          <a:lnRef idx="1">
-            <a:schemeClr val="accent1"/>
-          </a:lnRef>
-          <a:fillRef idx="3">
-            <a:schemeClr val="accent1"/>
-          </a:fillRef>
-          <a:effectRef idx="2">
-            <a:schemeClr val="accent1"/>
-          </a:effectRef>
-          <a:fontRef idx="minor">
-            <a:schemeClr val="lt1"/>
-          </a:fontRef>
-        </p:style>
-        <p:txBody>
-          <a:bodyPr rtlCol="0" anchor="ctr"/>
-          <a:lstStyle/>
-          <a:p>
-            <a:pPr algn="ctr"/>
-          </a:p>
-        </p:txBody>
-      </p:sp>
-      <p:sp>
-        <p:nvSpPr>
-          <p:cNvPr id="36" name="Oval 35"/>
-          <p:cNvSpPr/>
-          <p:nvPr/>
-        </p:nvSpPr>
-        <p:spPr>
-          <a:xfrm>
-            <a:off x="5143500" y="4978400"/>
-            <a:ext cx="114300" cy="114300"/>
-          </a:xfrm>
-          <a:prstGeom prst="ellipse">
-            <a:avLst/>
-          </a:prstGeom>
-          <a:solidFill>
-            <a:srgbClr val="1F5E3A"/>
-          </a:solidFill>
-          <a:ln>
-            <a:noFill/>
-          </a:ln>
-          <a:effectLst/>
-        </p:spPr>
-        <p:style>
-          <a:lnRef idx="1">
-            <a:schemeClr val="accent1"/>
-          </a:lnRef>
-          <a:fillRef idx="3">
-            <a:schemeClr val="accent1"/>
-          </a:fillRef>
-          <a:effectRef idx="2">
-            <a:schemeClr val="accent1"/>
-          </a:effectRef>
-          <a:fontRef idx="minor">
-            <a:schemeClr val="lt1"/>
-          </a:fontRef>
-        </p:style>
-        <p:txBody>
-          <a:bodyPr rtlCol="0" anchor="ctr"/>
-          <a:lstStyle/>
-          <a:p>
-            <a:pPr algn="ctr"/>
-          </a:p>
-        </p:txBody>
-      </p:sp>
-      <p:sp>
-        <p:nvSpPr>
-          <p:cNvPr id="37" name="Rounded Rectangle 36"/>
-          <p:cNvSpPr/>
-          <p:nvPr/>
-        </p:nvSpPr>
-        <p:spPr>
-          <a:xfrm>
-            <a:off x="4902200" y="5130800"/>
-            <a:ext cx="330200" cy="114300"/>
-          </a:xfrm>
-          <a:prstGeom prst="roundRect">
-            <a:avLst>
-              <a:gd name="adj" fmla="val 50000"/>
-            </a:avLst>
-          </a:prstGeom>
-          <a:solidFill>
-            <a:srgbClr val="1F5E3A"/>
-          </a:solidFill>
-          <a:ln>
-            <a:noFill/>
-          </a:ln>
-          <a:effectLst/>
-        </p:spPr>
-        <p:style>
-          <a:lnRef idx="1">
-            <a:schemeClr val="accent1"/>
-          </a:lnRef>
-          <a:fillRef idx="3">
-            <a:schemeClr val="accent1"/>
-          </a:fillRef>
-          <a:effectRef idx="2">
-            <a:schemeClr val="accent1"/>
-          </a:effectRef>
-          <a:fontRef idx="minor">
-            <a:schemeClr val="lt1"/>
-          </a:fontRef>
-        </p:style>
-        <p:txBody>
-          <a:bodyPr rtlCol="0" anchor="ctr"/>
-          <a:lstStyle/>
-          <a:p/>
-        </p:txBody>
-      </p:sp>
-      <p:sp>
-        <p:nvSpPr>
-          <p:cNvPr id="38" name="TextBox 37"/>
+      <p:pic>
+        <p:nvPicPr>
+          <p:cNvPr id="22" name="Picture 21" descr="cible_gie.jpg"/>
+          <p:cNvPicPr>
+            <a:picLocks noChangeAspect="1"/>
+          </p:cNvPicPr>
+          <p:nvPr/>
+        </p:nvPicPr>
+        <p:blipFill>
+          <a:blip r:embed="rId6"/>
+          <a:stretch>
+            <a:fillRect/>
+          </a:stretch>
+        </p:blipFill>
+        <p:spPr>
+          <a:xfrm>
+            <a:off x="4800600" y="4724400"/>
+            <a:ext cx="762000" cy="762000"/>
+          </a:xfrm>
+          <a:prstGeom prst="rect">
+            <a:avLst/>
+          </a:prstGeom>
+        </p:spPr>
+      </p:pic>
+      <p:sp>
+        <p:nvSpPr>
+          <p:cNvPr id="23" name="TextBox 22"/>
           <p:cNvSpPr txBox="1"/>
           <p:nvPr/>
         </p:nvSpPr>
         <p:spPr>
           <a:xfrm>
-            <a:off x="5384800" y="4927600"/>
-            <a:ext cx="2006600" cy="269875"/>
+            <a:off x="5689600" y="4978400"/>
+            <a:ext cx="1727200" cy="254000"/>
           </a:xfrm>
           <a:prstGeom prst="rect">
             <a:avLst/>
@@ -52184,7 +51398,7 @@
           <a:p>
             <a:pPr algn="l">
               <a:lnSpc>
-                <a:spcPts val="1625"/>
+                <a:spcPts val="1500"/>
               </a:lnSpc>
             </a:pPr>
             <a:r>
@@ -52201,18 +51415,18 @@
       </p:sp>
       <p:sp>
         <p:nvSpPr>
-          <p:cNvPr id="39" name="Rounded Rectangle 38"/>
-          <p:cNvSpPr/>
-          <p:nvPr/>
-        </p:nvSpPr>
-        <p:spPr>
-          <a:xfrm>
-            <a:off x="8534400" y="4318000"/>
-            <a:ext cx="2946400" cy="914400"/>
+          <p:cNvPr id="24" name="Rounded Rectangle 23"/>
+          <p:cNvSpPr/>
+          <p:nvPr/>
+        </p:nvSpPr>
+        <p:spPr>
+          <a:xfrm>
+            <a:off x="8534400" y="4267200"/>
+            <a:ext cx="2946400" cy="1066800"/>
           </a:xfrm>
           <a:prstGeom prst="roundRect">
             <a:avLst>
-              <a:gd name="adj" fmla="val 13888"/>
+              <a:gd name="adj" fmla="val 11904"/>
             </a:avLst>
           </a:prstGeom>
           <a:solidFill>
@@ -52245,260 +51459,40 @@
           <a:p/>
         </p:txBody>
       </p:sp>
-      <p:sp>
-        <p:nvSpPr>
-          <p:cNvPr id="40" name="Oval 39"/>
-          <p:cNvSpPr/>
-          <p:nvPr/>
-        </p:nvSpPr>
-        <p:spPr>
-          <a:xfrm>
-            <a:off x="8737600" y="4572000"/>
-            <a:ext cx="431800" cy="431800"/>
-          </a:xfrm>
-          <a:prstGeom prst="ellipse">
-            <a:avLst/>
-          </a:prstGeom>
-          <a:solidFill>
-            <a:srgbClr val="1AAB70"/>
-          </a:solidFill>
-          <a:ln>
-            <a:noFill/>
-          </a:ln>
-          <a:effectLst/>
-        </p:spPr>
-        <p:style>
-          <a:lnRef idx="1">
-            <a:schemeClr val="accent1"/>
-          </a:lnRef>
-          <a:fillRef idx="3">
-            <a:schemeClr val="accent1"/>
-          </a:fillRef>
-          <a:effectRef idx="2">
-            <a:schemeClr val="accent1"/>
-          </a:effectRef>
-          <a:fontRef idx="minor">
-            <a:schemeClr val="lt1"/>
-          </a:fontRef>
-        </p:style>
-        <p:txBody>
-          <a:bodyPr rtlCol="0" anchor="ctr"/>
-          <a:lstStyle/>
-          <a:p>
-            <a:pPr algn="ctr"/>
-          </a:p>
-        </p:txBody>
-      </p:sp>
-      <p:sp>
-        <p:nvSpPr>
-          <p:cNvPr id="41" name="Rounded Rectangle 40"/>
-          <p:cNvSpPr/>
-          <p:nvPr/>
-        </p:nvSpPr>
-        <p:spPr>
-          <a:xfrm>
-            <a:off x="8801100" y="4749800"/>
-            <a:ext cx="177800" cy="139700"/>
-          </a:xfrm>
-          <a:prstGeom prst="roundRect">
-            <a:avLst>
-              <a:gd name="adj" fmla="val 13636"/>
-            </a:avLst>
-          </a:prstGeom>
-          <a:solidFill>
-            <a:srgbClr val="1F5E3A"/>
-          </a:solidFill>
-          <a:ln>
-            <a:noFill/>
-          </a:ln>
-          <a:effectLst/>
-        </p:spPr>
-        <p:style>
-          <a:lnRef idx="1">
-            <a:schemeClr val="accent1"/>
-          </a:lnRef>
-          <a:fillRef idx="3">
-            <a:schemeClr val="accent1"/>
-          </a:fillRef>
-          <a:effectRef idx="2">
-            <a:schemeClr val="accent1"/>
-          </a:effectRef>
-          <a:fontRef idx="minor">
-            <a:schemeClr val="lt1"/>
-          </a:fontRef>
-        </p:style>
-        <p:txBody>
-          <a:bodyPr rtlCol="0" anchor="ctr"/>
-          <a:lstStyle/>
-          <a:p/>
-        </p:txBody>
-      </p:sp>
-      <p:sp>
-        <p:nvSpPr>
-          <p:cNvPr id="42" name="Freeform 41"/>
-          <p:cNvSpPr/>
-          <p:nvPr/>
-        </p:nvSpPr>
-        <p:spPr>
-          <a:xfrm>
-            <a:off x="8978900" y="4800600"/>
-            <a:ext cx="127000" cy="88900"/>
-          </a:xfrm>
-          <a:custGeom>
-            <a:avLst/>
-            <a:gdLst/>
-            <a:ahLst/>
-            <a:cxnLst/>
-            <a:rect l="l" t="t" r="r" b="b"/>
-            <a:pathLst>
-              <a:path w="127000" h="88900">
-                <a:moveTo>
-                  <a:pt x="0" y="0"/>
-                </a:moveTo>
-                <a:lnTo>
-                  <a:pt x="76200" y="0"/>
-                </a:lnTo>
-                <a:lnTo>
-                  <a:pt x="127000" y="50800"/>
-                </a:lnTo>
-                <a:lnTo>
-                  <a:pt x="127000" y="88900"/>
-                </a:lnTo>
-                <a:lnTo>
-                  <a:pt x="0" y="88900"/>
-                </a:lnTo>
-                <a:close/>
-              </a:path>
-            </a:pathLst>
-          </a:custGeom>
-          <a:solidFill>
-            <a:srgbClr val="1F5E3A"/>
-          </a:solidFill>
-          <a:ln>
-            <a:noFill/>
-          </a:ln>
-          <a:effectLst/>
-        </p:spPr>
-        <p:style>
-          <a:lnRef idx="1">
-            <a:schemeClr val="accent1"/>
-          </a:lnRef>
-          <a:fillRef idx="3">
-            <a:schemeClr val="accent1"/>
-          </a:fillRef>
-          <a:effectRef idx="2">
-            <a:schemeClr val="accent1"/>
-          </a:effectRef>
-          <a:fontRef idx="minor">
-            <a:schemeClr val="lt1"/>
-          </a:fontRef>
-        </p:style>
-        <p:txBody>
-          <a:bodyPr rtlCol="0" anchor="ctr"/>
-          <a:lstStyle/>
-          <a:p>
-            <a:pPr algn="ctr"/>
-          </a:p>
-        </p:txBody>
-      </p:sp>
-      <p:sp>
-        <p:nvSpPr>
-          <p:cNvPr id="43" name="Oval 42"/>
-          <p:cNvSpPr/>
-          <p:nvPr/>
-        </p:nvSpPr>
-        <p:spPr>
-          <a:xfrm>
-            <a:off x="8839200" y="4876800"/>
-            <a:ext cx="88900" cy="88900"/>
-          </a:xfrm>
-          <a:prstGeom prst="ellipse">
-            <a:avLst/>
-          </a:prstGeom>
-          <a:solidFill>
-            <a:srgbClr val="1F5E3A"/>
-          </a:solidFill>
-          <a:ln>
-            <a:noFill/>
-          </a:ln>
-          <a:effectLst/>
-        </p:spPr>
-        <p:style>
-          <a:lnRef idx="1">
-            <a:schemeClr val="accent1"/>
-          </a:lnRef>
-          <a:fillRef idx="3">
-            <a:schemeClr val="accent1"/>
-          </a:fillRef>
-          <a:effectRef idx="2">
-            <a:schemeClr val="accent1"/>
-          </a:effectRef>
-          <a:fontRef idx="minor">
-            <a:schemeClr val="lt1"/>
-          </a:fontRef>
-        </p:style>
-        <p:txBody>
-          <a:bodyPr rtlCol="0" anchor="ctr"/>
-          <a:lstStyle/>
-          <a:p>
-            <a:pPr algn="ctr"/>
-          </a:p>
-        </p:txBody>
-      </p:sp>
-      <p:sp>
-        <p:nvSpPr>
-          <p:cNvPr id="44" name="Oval 43"/>
-          <p:cNvSpPr/>
-          <p:nvPr/>
-        </p:nvSpPr>
-        <p:spPr>
-          <a:xfrm>
-            <a:off x="8991600" y="4876800"/>
-            <a:ext cx="88900" cy="88900"/>
-          </a:xfrm>
-          <a:prstGeom prst="ellipse">
-            <a:avLst/>
-          </a:prstGeom>
-          <a:solidFill>
-            <a:srgbClr val="1F5E3A"/>
-          </a:solidFill>
-          <a:ln>
-            <a:noFill/>
-          </a:ln>
-          <a:effectLst/>
-        </p:spPr>
-        <p:style>
-          <a:lnRef idx="1">
-            <a:schemeClr val="accent1"/>
-          </a:lnRef>
-          <a:fillRef idx="3">
-            <a:schemeClr val="accent1"/>
-          </a:fillRef>
-          <a:effectRef idx="2">
-            <a:schemeClr val="accent1"/>
-          </a:effectRef>
-          <a:fontRef idx="minor">
-            <a:schemeClr val="lt1"/>
-          </a:fontRef>
-        </p:style>
-        <p:txBody>
-          <a:bodyPr rtlCol="0" anchor="ctr"/>
-          <a:lstStyle/>
-          <a:p>
-            <a:pPr algn="ctr"/>
-          </a:p>
-        </p:txBody>
-      </p:sp>
-      <p:sp>
-        <p:nvSpPr>
-          <p:cNvPr id="45" name="TextBox 44"/>
+      <p:pic>
+        <p:nvPicPr>
+          <p:cNvPr id="25" name="Picture 24" descr="cible_distributeur.jpg"/>
+          <p:cNvPicPr>
+            <a:picLocks noChangeAspect="1"/>
+          </p:cNvPicPr>
+          <p:nvPr/>
+        </p:nvPicPr>
+        <p:blipFill>
+          <a:blip r:embed="rId7"/>
+          <a:stretch>
+            <a:fillRect/>
+          </a:stretch>
+        </p:blipFill>
+        <p:spPr>
+          <a:xfrm>
+            <a:off x="8686800" y="4419600"/>
+            <a:ext cx="762000" cy="762000"/>
+          </a:xfrm>
+          <a:prstGeom prst="rect">
+            <a:avLst/>
+          </a:prstGeom>
+        </p:spPr>
+      </p:pic>
+      <p:sp>
+        <p:nvSpPr>
+          <p:cNvPr id="26" name="TextBox 25"/>
           <p:cNvSpPr txBox="1"/>
           <p:nvPr/>
         </p:nvSpPr>
         <p:spPr>
           <a:xfrm>
-            <a:off x="9271000" y="4648200"/>
-            <a:ext cx="2057400" cy="269875"/>
+            <a:off x="9575800" y="4673600"/>
+            <a:ext cx="1778000" cy="254000"/>
           </a:xfrm>
           <a:prstGeom prst="rect">
             <a:avLst/>
@@ -52513,7 +51507,7 @@
           <a:p>
             <a:pPr algn="l">
               <a:lnSpc>
-                <a:spcPts val="1625"/>
+                <a:spcPts val="1500"/>
               </a:lnSpc>
             </a:pPr>
             <a:r>
@@ -52530,14 +51524,14 @@
       </p:sp>
       <p:cxnSp>
         <p:nvCxnSpPr>
-          <p:cNvPr id="46" name="Connector 45"/>
+          <p:cNvPr id="27" name="Connector 26"/>
           <p:cNvCxnSpPr/>
           <p:nvPr/>
         </p:nvCxnSpPr>
         <p:spPr>
           <a:xfrm flipH="1" flipV="1">
-            <a:off x="3606800" y="2590800"/>
-            <a:ext cx="2489200" cy="685800"/>
+            <a:off x="3606800" y="2565400"/>
+            <a:ext cx="2489200" cy="711200"/>
           </a:xfrm>
           <a:prstGeom prst="line">
             <a:avLst/>
@@ -52566,14 +51560,14 @@
       </p:cxnSp>
       <p:cxnSp>
         <p:nvCxnSpPr>
-          <p:cNvPr id="47" name="Connector 46"/>
+          <p:cNvPr id="28" name="Connector 27"/>
           <p:cNvCxnSpPr/>
           <p:nvPr/>
         </p:nvCxnSpPr>
         <p:spPr>
           <a:xfrm flipV="1">
-            <a:off x="6096000" y="2590800"/>
-            <a:ext cx="2489200" cy="685800"/>
+            <a:off x="6096000" y="2565400"/>
+            <a:ext cx="2489200" cy="711200"/>
           </a:xfrm>
           <a:prstGeom prst="line">
             <a:avLst/>
@@ -52602,14 +51596,14 @@
       </p:cxnSp>
       <p:cxnSp>
         <p:nvCxnSpPr>
-          <p:cNvPr id="48" name="Connector 47"/>
+          <p:cNvPr id="29" name="Connector 28"/>
           <p:cNvCxnSpPr/>
           <p:nvPr/>
         </p:nvCxnSpPr>
         <p:spPr>
           <a:xfrm flipH="1">
             <a:off x="3657600" y="3276600"/>
-            <a:ext cx="2438400" cy="1346200"/>
+            <a:ext cx="2438400" cy="1371600"/>
           </a:xfrm>
           <a:prstGeom prst="line">
             <a:avLst/>
@@ -52638,14 +51632,14 @@
       </p:cxnSp>
       <p:cxnSp>
         <p:nvCxnSpPr>
-          <p:cNvPr id="49" name="Connector 48"/>
+          <p:cNvPr id="30" name="Connector 29"/>
           <p:cNvCxnSpPr/>
           <p:nvPr/>
         </p:nvCxnSpPr>
         <p:spPr>
           <a:xfrm>
             <a:off x="6096000" y="3276600"/>
-            <a:ext cx="0" cy="1447800"/>
+            <a:ext cx="0" cy="1473200"/>
           </a:xfrm>
           <a:prstGeom prst="line">
             <a:avLst/>
@@ -52674,14 +51668,14 @@
       </p:cxnSp>
       <p:cxnSp>
         <p:nvCxnSpPr>
-          <p:cNvPr id="50" name="Connector 49"/>
+          <p:cNvPr id="31" name="Connector 30"/>
           <p:cNvCxnSpPr/>
           <p:nvPr/>
         </p:nvCxnSpPr>
         <p:spPr>
           <a:xfrm>
             <a:off x="6096000" y="3276600"/>
-            <a:ext cx="2438400" cy="1346200"/>
+            <a:ext cx="2438400" cy="1371600"/>
           </a:xfrm>
           <a:prstGeom prst="line">
             <a:avLst/>
@@ -52710,7 +51704,7 @@
       </p:cxnSp>
       <p:sp>
         <p:nvSpPr>
-          <p:cNvPr id="51" name="Rectangle 50"/>
+          <p:cNvPr id="32" name="Rectangle 31"/>
           <p:cNvSpPr/>
           <p:nvPr/>
         </p:nvSpPr>

</xml_diff>

<commit_message>
Persona Aminata: photo a la place de l'initiale
Co-authored-by: arena-agent <297053741+arena-agent@users.noreply.github.com>
</commit_message>
<xml_diff>
--- a/Pitch_Deck_Sadiya_Digital_Agri.pptx
+++ b/Pitch_Deck_Sadiya_Digital_Agri.pptx
@@ -53942,92 +53942,33 @@
           <a:p/>
         </p:txBody>
       </p:sp>
-      <p:sp>
-        <p:nvSpPr>
-          <p:cNvPr id="11" name="Oval 10"/>
-          <p:cNvSpPr/>
-          <p:nvPr/>
-        </p:nvSpPr>
-        <p:spPr>
-          <a:xfrm>
-            <a:off x="1219200" y="2616200"/>
-            <a:ext cx="1625600" cy="1625600"/>
-          </a:xfrm>
-          <a:prstGeom prst="ellipse">
-            <a:avLst/>
-          </a:prstGeom>
-          <a:solidFill>
-            <a:srgbClr val="1AAB70"/>
-          </a:solidFill>
-          <a:ln>
-            <a:noFill/>
-          </a:ln>
-          <a:effectLst/>
-        </p:spPr>
-        <p:style>
-          <a:lnRef idx="1">
-            <a:schemeClr val="accent1"/>
-          </a:lnRef>
-          <a:fillRef idx="3">
-            <a:schemeClr val="accent1"/>
-          </a:fillRef>
-          <a:effectRef idx="2">
-            <a:schemeClr val="accent1"/>
-          </a:effectRef>
-          <a:fontRef idx="minor">
-            <a:schemeClr val="lt1"/>
-          </a:fontRef>
-        </p:style>
-        <p:txBody>
-          <a:bodyPr rtlCol="0" anchor="ctr"/>
-          <a:lstStyle/>
-          <a:p>
-            <a:pPr algn="ctr"/>
-          </a:p>
-        </p:txBody>
-      </p:sp>
+      <p:pic>
+        <p:nvPicPr>
+          <p:cNvPr id="11" name="Picture 10" descr="persona_aminata.jpg"/>
+          <p:cNvPicPr>
+            <a:picLocks noChangeAspect="1"/>
+          </p:cNvPicPr>
+          <p:nvPr/>
+        </p:nvPicPr>
+        <p:blipFill>
+          <a:blip r:embed="rId3"/>
+          <a:stretch>
+            <a:fillRect/>
+          </a:stretch>
+        </p:blipFill>
+        <p:spPr>
+          <a:xfrm>
+            <a:off x="1193800" y="2590800"/>
+            <a:ext cx="1676400" cy="1676400"/>
+          </a:xfrm>
+          <a:prstGeom prst="rect">
+            <a:avLst/>
+          </a:prstGeom>
+        </p:spPr>
+      </p:pic>
       <p:sp>
         <p:nvSpPr>
           <p:cNvPr id="12" name="TextBox 11"/>
-          <p:cNvSpPr txBox="1"/>
-          <p:nvPr/>
-        </p:nvSpPr>
-        <p:spPr>
-          <a:xfrm>
-            <a:off x="1193800" y="2993136"/>
-            <a:ext cx="1676400" cy="1122680"/>
-          </a:xfrm>
-          <a:prstGeom prst="rect">
-            <a:avLst/>
-          </a:prstGeom>
-          <a:noFill/>
-        </p:spPr>
-        <p:txBody>
-          <a:bodyPr wrap="none" lIns="0" rIns="0" tIns="0" bIns="0" anchor="t">
-            <a:spAutoFit/>
-          </a:bodyPr>
-          <a:lstStyle/>
-          <a:p>
-            <a:pPr algn="ctr">
-              <a:lnSpc>
-                <a:spcPts val="6760"/>
-              </a:lnSpc>
-            </a:pPr>
-            <a:r>
-              <a:rPr sz="5200" b="0" i="0">
-                <a:solidFill>
-                  <a:srgbClr val="1AAB70"/>
-                </a:solidFill>
-                <a:latin typeface="Alfa Slab One"/>
-              </a:rPr>
-              <a:t>A</a:t>
-            </a:r>
-          </a:p>
-        </p:txBody>
-      </p:sp>
-      <p:sp>
-        <p:nvSpPr>
-          <p:cNvPr id="13" name="TextBox 12"/>
           <p:cNvSpPr txBox="1"/>
           <p:nvPr/>
         </p:nvSpPr>
@@ -54066,7 +54007,7 @@
       </p:sp>
       <p:sp>
         <p:nvSpPr>
-          <p:cNvPr id="14" name="TextBox 13"/>
+          <p:cNvPr id="13" name="TextBox 12"/>
           <p:cNvSpPr txBox="1"/>
           <p:nvPr/>
         </p:nvSpPr>
@@ -54105,7 +54046,7 @@
       </p:sp>
       <p:sp>
         <p:nvSpPr>
-          <p:cNvPr id="15" name="Rectangle 14"/>
+          <p:cNvPr id="14" name="Rectangle 13"/>
           <p:cNvSpPr/>
           <p:nvPr/>
         </p:nvSpPr>
@@ -54147,7 +54088,7 @@
       </p:sp>
       <p:sp>
         <p:nvSpPr>
-          <p:cNvPr id="16" name="TextBox 15"/>
+          <p:cNvPr id="15" name="TextBox 14"/>
           <p:cNvSpPr txBox="1"/>
           <p:nvPr/>
         </p:nvSpPr>
@@ -54186,7 +54127,7 @@
       </p:sp>
       <p:sp>
         <p:nvSpPr>
-          <p:cNvPr id="17" name="Rounded Rectangle 16"/>
+          <p:cNvPr id="16" name="Rounded Rectangle 15"/>
           <p:cNvSpPr/>
           <p:nvPr/>
         </p:nvSpPr>
@@ -54232,7 +54173,7 @@
       </p:sp>
       <p:sp>
         <p:nvSpPr>
-          <p:cNvPr id="18" name="Rounded Rectangle 17"/>
+          <p:cNvPr id="17" name="Rounded Rectangle 16"/>
           <p:cNvSpPr/>
           <p:nvPr/>
         </p:nvSpPr>
@@ -54276,7 +54217,7 @@
       </p:sp>
       <p:sp>
         <p:nvSpPr>
-          <p:cNvPr id="19" name="TextBox 18"/>
+          <p:cNvPr id="18" name="TextBox 17"/>
           <p:cNvSpPr txBox="1"/>
           <p:nvPr/>
         </p:nvSpPr>
@@ -54315,7 +54256,7 @@
       </p:sp>
       <p:sp>
         <p:nvSpPr>
-          <p:cNvPr id="20" name="TextBox 19"/>
+          <p:cNvPr id="19" name="TextBox 18"/>
           <p:cNvSpPr txBox="1"/>
           <p:nvPr/>
         </p:nvSpPr>
@@ -54370,7 +54311,7 @@
       </p:sp>
       <p:sp>
         <p:nvSpPr>
-          <p:cNvPr id="21" name="Rounded Rectangle 20"/>
+          <p:cNvPr id="20" name="Rounded Rectangle 19"/>
           <p:cNvSpPr/>
           <p:nvPr/>
         </p:nvSpPr>
@@ -54416,7 +54357,7 @@
       </p:sp>
       <p:sp>
         <p:nvSpPr>
-          <p:cNvPr id="22" name="Rounded Rectangle 21"/>
+          <p:cNvPr id="21" name="Rounded Rectangle 20"/>
           <p:cNvSpPr/>
           <p:nvPr/>
         </p:nvSpPr>
@@ -54460,7 +54401,7 @@
       </p:sp>
       <p:sp>
         <p:nvSpPr>
-          <p:cNvPr id="23" name="TextBox 22"/>
+          <p:cNvPr id="22" name="TextBox 21"/>
           <p:cNvSpPr txBox="1"/>
           <p:nvPr/>
         </p:nvSpPr>
@@ -54499,7 +54440,7 @@
       </p:sp>
       <p:sp>
         <p:nvSpPr>
-          <p:cNvPr id="24" name="TextBox 23"/>
+          <p:cNvPr id="23" name="TextBox 22"/>
           <p:cNvSpPr txBox="1"/>
           <p:nvPr/>
         </p:nvSpPr>
@@ -54538,7 +54479,7 @@
       </p:sp>
       <p:sp>
         <p:nvSpPr>
-          <p:cNvPr id="25" name="Rounded Rectangle 24"/>
+          <p:cNvPr id="24" name="Rounded Rectangle 23"/>
           <p:cNvSpPr/>
           <p:nvPr/>
         </p:nvSpPr>
@@ -54584,7 +54525,7 @@
       </p:sp>
       <p:sp>
         <p:nvSpPr>
-          <p:cNvPr id="26" name="Rounded Rectangle 25"/>
+          <p:cNvPr id="25" name="Rounded Rectangle 24"/>
           <p:cNvSpPr/>
           <p:nvPr/>
         </p:nvSpPr>
@@ -54628,7 +54569,7 @@
       </p:sp>
       <p:sp>
         <p:nvSpPr>
-          <p:cNvPr id="27" name="TextBox 26"/>
+          <p:cNvPr id="26" name="TextBox 25"/>
           <p:cNvSpPr txBox="1"/>
           <p:nvPr/>
         </p:nvSpPr>
@@ -54667,7 +54608,7 @@
       </p:sp>
       <p:sp>
         <p:nvSpPr>
-          <p:cNvPr id="28" name="TextBox 27"/>
+          <p:cNvPr id="27" name="TextBox 26"/>
           <p:cNvSpPr txBox="1"/>
           <p:nvPr/>
         </p:nvSpPr>
@@ -54706,7 +54647,7 @@
       </p:sp>
       <p:sp>
         <p:nvSpPr>
-          <p:cNvPr id="29" name="TextBox 28"/>
+          <p:cNvPr id="28" name="TextBox 27"/>
           <p:cNvSpPr txBox="1"/>
           <p:nvPr/>
         </p:nvSpPr>

</xml_diff>

<commit_message>
Ajout page Conclusion (slide 22) + script et audio mis a jour (4min54)
Co-authored-by: arena-agent <297053741+arena-agent@users.noreply.github.com>
</commit_message>
<xml_diff>
--- a/Pitch_Deck_Sadiya_Digital_Agri.pptx
+++ b/Pitch_Deck_Sadiya_Digital_Agri.pptx
@@ -27,6 +27,7 @@
     <p:sldId id="275" r:id="rId26"/>
     <p:sldId id="276" r:id="rId27"/>
     <p:sldId id="277" r:id="rId28"/>
+    <p:sldId id="278" r:id="rId29"/>
   </p:sldIdLst>
   <p:sldSz cx="12192000" cy="6858000" type="screen4x3"/>
   <p:notesSz cx="6858000" cy="9144000"/>
@@ -15614,7 +15615,7 @@
         </p:nvSpPr>
         <p:spPr>
           <a:xfrm>
-            <a:off x="660400" y="2108200"/>
+            <a:off x="660400" y="2184400"/>
             <a:ext cx="3403600" cy="50800"/>
           </a:xfrm>
           <a:prstGeom prst="roundRect">
@@ -16075,7 +16076,7 @@
         </p:nvSpPr>
         <p:spPr>
           <a:xfrm>
-            <a:off x="4318000" y="2108200"/>
+            <a:off x="4318000" y="2184400"/>
             <a:ext cx="3403600" cy="50800"/>
           </a:xfrm>
           <a:prstGeom prst="roundRect">
@@ -16536,7 +16537,7 @@
         </p:nvSpPr>
         <p:spPr>
           <a:xfrm>
-            <a:off x="7975600" y="2108200"/>
+            <a:off x="7975600" y="2184400"/>
             <a:ext cx="3403600" cy="50800"/>
           </a:xfrm>
           <a:prstGeom prst="roundRect">
@@ -40790,6 +40791,1387 @@
 </file>
 
 <file path=ppt/slides/slide22.xml><?xml version="1.0" encoding="utf-8"?>
+<p:sld xmlns:a="http://schemas.openxmlformats.org/drawingml/2006/main" xmlns:p="http://schemas.openxmlformats.org/presentationml/2006/main" xmlns:r="http://schemas.openxmlformats.org/officeDocument/2006/relationships">
+  <p:cSld>
+    <p:spTree>
+      <p:nvGrpSpPr>
+        <p:cNvPr id="1" name=""/>
+        <p:cNvGrpSpPr/>
+        <p:nvPr/>
+      </p:nvGrpSpPr>
+      <p:grpSpPr/>
+      <p:sp>
+        <p:nvSpPr>
+          <p:cNvPr id="2" name="Rectangle 1"/>
+          <p:cNvSpPr/>
+          <p:nvPr/>
+        </p:nvSpPr>
+        <p:spPr>
+          <a:xfrm>
+            <a:off x="0" y="0"/>
+            <a:ext cx="12192000" cy="6858000"/>
+          </a:xfrm>
+          <a:prstGeom prst="rect">
+            <a:avLst/>
+          </a:prstGeom>
+          <a:solidFill>
+            <a:srgbClr val="F4F7F5"/>
+          </a:solidFill>
+          <a:ln>
+            <a:noFill/>
+          </a:ln>
+          <a:effectLst/>
+        </p:spPr>
+        <p:style>
+          <a:lnRef idx="1">
+            <a:schemeClr val="accent1"/>
+          </a:lnRef>
+          <a:fillRef idx="3">
+            <a:schemeClr val="accent1"/>
+          </a:fillRef>
+          <a:effectRef idx="2">
+            <a:schemeClr val="accent1"/>
+          </a:effectRef>
+          <a:fontRef idx="minor">
+            <a:schemeClr val="lt1"/>
+          </a:fontRef>
+        </p:style>
+        <p:txBody>
+          <a:bodyPr rtlCol="0" anchor="ctr"/>
+          <a:lstStyle/>
+          <a:p/>
+        </p:txBody>
+      </p:sp>
+      <p:sp>
+        <p:nvSpPr>
+          <p:cNvPr id="3" name="Rectangle 2"/>
+          <p:cNvSpPr/>
+          <p:nvPr/>
+        </p:nvSpPr>
+        <p:spPr>
+          <a:xfrm>
+            <a:off x="0" y="0"/>
+            <a:ext cx="76200" cy="6858000"/>
+          </a:xfrm>
+          <a:prstGeom prst="rect">
+            <a:avLst/>
+          </a:prstGeom>
+          <a:solidFill>
+            <a:srgbClr val="1F5E3A"/>
+          </a:solidFill>
+          <a:ln>
+            <a:noFill/>
+          </a:ln>
+          <a:effectLst/>
+        </p:spPr>
+        <p:style>
+          <a:lnRef idx="1">
+            <a:schemeClr val="accent1"/>
+          </a:lnRef>
+          <a:fillRef idx="3">
+            <a:schemeClr val="accent1"/>
+          </a:fillRef>
+          <a:effectRef idx="2">
+            <a:schemeClr val="accent1"/>
+          </a:effectRef>
+          <a:fontRef idx="minor">
+            <a:schemeClr val="lt1"/>
+          </a:fontRef>
+        </p:style>
+        <p:txBody>
+          <a:bodyPr rtlCol="0" anchor="ctr"/>
+          <a:lstStyle/>
+          <a:p/>
+        </p:txBody>
+      </p:sp>
+      <p:sp>
+        <p:nvSpPr>
+          <p:cNvPr id="4" name="Rectangle 3"/>
+          <p:cNvSpPr/>
+          <p:nvPr/>
+        </p:nvSpPr>
+        <p:spPr>
+          <a:xfrm>
+            <a:off x="660400" y="508000"/>
+            <a:ext cx="44450" cy="165100"/>
+          </a:xfrm>
+          <a:prstGeom prst="rect">
+            <a:avLst/>
+          </a:prstGeom>
+          <a:solidFill>
+            <a:srgbClr val="1AAB70"/>
+          </a:solidFill>
+          <a:ln>
+            <a:noFill/>
+          </a:ln>
+          <a:effectLst/>
+        </p:spPr>
+        <p:style>
+          <a:lnRef idx="1">
+            <a:schemeClr val="accent1"/>
+          </a:lnRef>
+          <a:fillRef idx="3">
+            <a:schemeClr val="accent1"/>
+          </a:fillRef>
+          <a:effectRef idx="2">
+            <a:schemeClr val="accent1"/>
+          </a:effectRef>
+          <a:fontRef idx="minor">
+            <a:schemeClr val="lt1"/>
+          </a:fontRef>
+        </p:style>
+        <p:txBody>
+          <a:bodyPr rtlCol="0" anchor="ctr"/>
+          <a:lstStyle/>
+          <a:p/>
+        </p:txBody>
+      </p:sp>
+      <p:sp>
+        <p:nvSpPr>
+          <p:cNvPr id="5" name="TextBox 4"/>
+          <p:cNvSpPr txBox="1"/>
+          <p:nvPr/>
+        </p:nvSpPr>
+        <p:spPr>
+          <a:xfrm>
+            <a:off x="774700" y="490728"/>
+            <a:ext cx="6400800" cy="183515"/>
+          </a:xfrm>
+          <a:prstGeom prst="rect">
+            <a:avLst/>
+          </a:prstGeom>
+          <a:noFill/>
+        </p:spPr>
+        <p:txBody>
+          <a:bodyPr wrap="none" lIns="0" rIns="0" tIns="0" bIns="0" anchor="t">
+            <a:spAutoFit/>
+          </a:bodyPr>
+          <a:lstStyle/>
+          <a:p>
+            <a:pPr algn="l">
+              <a:lnSpc>
+                <a:spcPts val="1105"/>
+              </a:lnSpc>
+            </a:pPr>
+            <a:r>
+              <a:rPr sz="850" b="1" i="0" spc="190">
+                <a:solidFill>
+                  <a:srgbClr val="1AAB70"/>
+                </a:solidFill>
+                <a:latin typeface="Poppins"/>
+              </a:rPr>
+              <a:t>CONCLUSION</a:t>
+            </a:r>
+          </a:p>
+        </p:txBody>
+      </p:sp>
+      <p:sp>
+        <p:nvSpPr>
+          <p:cNvPr id="6" name="TextBox 5"/>
+          <p:cNvSpPr txBox="1"/>
+          <p:nvPr/>
+        </p:nvSpPr>
+        <p:spPr>
+          <a:xfrm>
+            <a:off x="635000" y="681736"/>
+            <a:ext cx="8178800" cy="521208"/>
+          </a:xfrm>
+          <a:prstGeom prst="rect">
+            <a:avLst/>
+          </a:prstGeom>
+          <a:noFill/>
+        </p:spPr>
+        <p:txBody>
+          <a:bodyPr wrap="none" lIns="0" rIns="0" tIns="0" bIns="0" anchor="t">
+            <a:spAutoFit/>
+          </a:bodyPr>
+          <a:lstStyle/>
+          <a:p>
+            <a:pPr algn="l">
+              <a:lnSpc>
+                <a:spcPts val="3024"/>
+              </a:lnSpc>
+            </a:pPr>
+            <a:r>
+              <a:rPr sz="2700" b="0" i="0">
+                <a:solidFill>
+                  <a:srgbClr val="1F5E3A"/>
+                </a:solidFill>
+                <a:latin typeface="Alfa Slab One"/>
+              </a:rPr>
+              <a:t>Ce Qu'il Faut Retenir</a:t>
+            </a:r>
+          </a:p>
+        </p:txBody>
+      </p:sp>
+      <p:sp>
+        <p:nvSpPr>
+          <p:cNvPr id="7" name="TextBox 6"/>
+          <p:cNvSpPr txBox="1"/>
+          <p:nvPr/>
+        </p:nvSpPr>
+        <p:spPr>
+          <a:xfrm>
+            <a:off x="635000" y="1184148"/>
+            <a:ext cx="7924800" cy="244475"/>
+          </a:xfrm>
+          <a:prstGeom prst="rect">
+            <a:avLst/>
+          </a:prstGeom>
+          <a:noFill/>
+        </p:spPr>
+        <p:txBody>
+          <a:bodyPr wrap="none" lIns="0" rIns="0" tIns="0" bIns="0" anchor="t">
+            <a:spAutoFit/>
+          </a:bodyPr>
+          <a:lstStyle/>
+          <a:p>
+            <a:pPr algn="l">
+              <a:lnSpc>
+                <a:spcPts val="1485"/>
+              </a:lnSpc>
+            </a:pPr>
+            <a:r>
+              <a:rPr sz="1100" b="0" i="0">
+                <a:solidFill>
+                  <a:srgbClr val="42612D"/>
+                </a:solidFill>
+                <a:latin typeface="Poppins"/>
+              </a:rPr>
+              <a:t>Un marché porteur, une expertise unique, un projet déjà lancé.</a:t>
+            </a:r>
+          </a:p>
+        </p:txBody>
+      </p:sp>
+      <p:pic>
+        <p:nvPicPr>
+          <p:cNvPr id="8" name="Picture 7" descr="logo-sadiya.png"/>
+          <p:cNvPicPr>
+            <a:picLocks noChangeAspect="1"/>
+          </p:cNvPicPr>
+          <p:nvPr/>
+        </p:nvPicPr>
+        <p:blipFill>
+          <a:blip r:embed="rId2"/>
+          <a:stretch>
+            <a:fillRect/>
+          </a:stretch>
+        </p:blipFill>
+        <p:spPr>
+          <a:xfrm>
+            <a:off x="10769600" y="431800"/>
+            <a:ext cx="939800" cy="381000"/>
+          </a:xfrm>
+          <a:prstGeom prst="rect">
+            <a:avLst/>
+          </a:prstGeom>
+        </p:spPr>
+      </p:pic>
+      <p:sp>
+        <p:nvSpPr>
+          <p:cNvPr id="9" name="TextBox 8"/>
+          <p:cNvSpPr txBox="1"/>
+          <p:nvPr/>
+        </p:nvSpPr>
+        <p:spPr>
+          <a:xfrm>
+            <a:off x="482600" y="6306312"/>
+            <a:ext cx="431800" cy="194310"/>
+          </a:xfrm>
+          <a:prstGeom prst="rect">
+            <a:avLst/>
+          </a:prstGeom>
+          <a:noFill/>
+        </p:spPr>
+        <p:txBody>
+          <a:bodyPr wrap="none" lIns="0" rIns="0" tIns="0" bIns="0" anchor="t">
+            <a:spAutoFit/>
+          </a:bodyPr>
+          <a:lstStyle/>
+          <a:p>
+            <a:pPr algn="l">
+              <a:lnSpc>
+                <a:spcPts val="1170"/>
+              </a:lnSpc>
+            </a:pPr>
+            <a:r>
+              <a:rPr sz="900" b="1" i="0">
+                <a:solidFill>
+                  <a:srgbClr val="1F5E3A"/>
+                </a:solidFill>
+                <a:latin typeface="Poppins"/>
+              </a:rPr>
+              <a:t>22</a:t>
+            </a:r>
+          </a:p>
+        </p:txBody>
+      </p:sp>
+      <p:sp>
+        <p:nvSpPr>
+          <p:cNvPr id="10" name="Rounded Rectangle 9"/>
+          <p:cNvSpPr/>
+          <p:nvPr/>
+        </p:nvSpPr>
+        <p:spPr>
+          <a:xfrm>
+            <a:off x="660400" y="2184400"/>
+            <a:ext cx="3403600" cy="1930400"/>
+          </a:xfrm>
+          <a:prstGeom prst="roundRect">
+            <a:avLst>
+              <a:gd name="adj" fmla="val 5921"/>
+            </a:avLst>
+          </a:prstGeom>
+          <a:solidFill>
+            <a:srgbClr val="FFFFFF"/>
+          </a:solidFill>
+          <a:ln w="12700">
+            <a:solidFill>
+              <a:srgbClr val="DCE8DE"/>
+            </a:solidFill>
+          </a:ln>
+          <a:effectLst/>
+        </p:spPr>
+        <p:style>
+          <a:lnRef idx="1">
+            <a:schemeClr val="accent1"/>
+          </a:lnRef>
+          <a:fillRef idx="3">
+            <a:schemeClr val="accent1"/>
+          </a:fillRef>
+          <a:effectRef idx="2">
+            <a:schemeClr val="accent1"/>
+          </a:effectRef>
+          <a:fontRef idx="minor">
+            <a:schemeClr val="lt1"/>
+          </a:fontRef>
+        </p:style>
+        <p:txBody>
+          <a:bodyPr rtlCol="0" anchor="ctr"/>
+          <a:lstStyle/>
+          <a:p/>
+        </p:txBody>
+      </p:sp>
+      <p:sp>
+        <p:nvSpPr>
+          <p:cNvPr id="11" name="Rounded Rectangle 10"/>
+          <p:cNvSpPr/>
+          <p:nvPr/>
+        </p:nvSpPr>
+        <p:spPr>
+          <a:xfrm>
+            <a:off x="660400" y="2108200"/>
+            <a:ext cx="3403600" cy="50800"/>
+          </a:xfrm>
+          <a:prstGeom prst="roundRect">
+            <a:avLst>
+              <a:gd name="adj" fmla="val 50000"/>
+            </a:avLst>
+          </a:prstGeom>
+          <a:solidFill>
+            <a:srgbClr val="1AAB70"/>
+          </a:solidFill>
+          <a:ln>
+            <a:noFill/>
+          </a:ln>
+          <a:effectLst/>
+        </p:spPr>
+        <p:style>
+          <a:lnRef idx="1">
+            <a:schemeClr val="accent1"/>
+          </a:lnRef>
+          <a:fillRef idx="3">
+            <a:schemeClr val="accent1"/>
+          </a:fillRef>
+          <a:effectRef idx="2">
+            <a:schemeClr val="accent1"/>
+          </a:effectRef>
+          <a:fontRef idx="minor">
+            <a:schemeClr val="lt1"/>
+          </a:fontRef>
+        </p:style>
+        <p:txBody>
+          <a:bodyPr rtlCol="0" anchor="ctr"/>
+          <a:lstStyle/>
+          <a:p/>
+        </p:txBody>
+      </p:sp>
+      <p:sp>
+        <p:nvSpPr>
+          <p:cNvPr id="12" name="TextBox 11"/>
+          <p:cNvSpPr txBox="1"/>
+          <p:nvPr/>
+        </p:nvSpPr>
+        <p:spPr>
+          <a:xfrm>
+            <a:off x="914400" y="2420925"/>
+            <a:ext cx="2895600" cy="185674"/>
+          </a:xfrm>
+          <a:prstGeom prst="rect">
+            <a:avLst/>
+          </a:prstGeom>
+          <a:noFill/>
+        </p:spPr>
+        <p:txBody>
+          <a:bodyPr wrap="none" lIns="0" rIns="0" tIns="0" bIns="0" anchor="t">
+            <a:spAutoFit/>
+          </a:bodyPr>
+          <a:lstStyle/>
+          <a:p>
+            <a:pPr algn="l">
+              <a:lnSpc>
+                <a:spcPts val="1118"/>
+              </a:lnSpc>
+            </a:pPr>
+            <a:r>
+              <a:rPr sz="860" b="1" i="0" spc="150">
+                <a:solidFill>
+                  <a:srgbClr val="1AAB70"/>
+                </a:solidFill>
+                <a:latin typeface="Poppins"/>
+              </a:rPr>
+              <a:t>UN MARCHÉ</a:t>
+            </a:r>
+          </a:p>
+        </p:txBody>
+      </p:sp>
+      <p:sp>
+        <p:nvSpPr>
+          <p:cNvPr id="13" name="TextBox 12"/>
+          <p:cNvSpPr txBox="1"/>
+          <p:nvPr/>
+        </p:nvSpPr>
+        <p:spPr>
+          <a:xfrm>
+            <a:off x="914400" y="2632456"/>
+            <a:ext cx="2921000" cy="345440"/>
+          </a:xfrm>
+          <a:prstGeom prst="rect">
+            <a:avLst/>
+          </a:prstGeom>
+          <a:noFill/>
+        </p:spPr>
+        <p:txBody>
+          <a:bodyPr wrap="none" lIns="0" rIns="0" tIns="0" bIns="0" anchor="t">
+            <a:spAutoFit/>
+          </a:bodyPr>
+          <a:lstStyle/>
+          <a:p>
+            <a:pPr algn="l">
+              <a:lnSpc>
+                <a:spcPts val="2039"/>
+              </a:lnSpc>
+            </a:pPr>
+            <a:r>
+              <a:rPr sz="1700" b="0" i="0">
+                <a:solidFill>
+                  <a:srgbClr val="1F5E3A"/>
+                </a:solidFill>
+                <a:latin typeface="Alfa Slab One"/>
+              </a:rPr>
+              <a:t>Porteur et inexploité</a:t>
+            </a:r>
+          </a:p>
+        </p:txBody>
+      </p:sp>
+      <p:cxnSp>
+        <p:nvCxnSpPr>
+          <p:cNvPr id="14" name="Connector 13"/>
+          <p:cNvCxnSpPr/>
+          <p:nvPr/>
+        </p:nvCxnSpPr>
+        <p:spPr>
+          <a:xfrm>
+            <a:off x="939800" y="3098800"/>
+            <a:ext cx="2844800" cy="0"/>
+          </a:xfrm>
+          <a:prstGeom prst="line">
+            <a:avLst/>
+          </a:prstGeom>
+          <a:ln w="12700">
+            <a:solidFill>
+              <a:srgbClr val="DCE8DE"/>
+            </a:solidFill>
+          </a:ln>
+        </p:spPr>
+        <p:style>
+          <a:lnRef idx="2">
+            <a:schemeClr val="accent1"/>
+          </a:lnRef>
+          <a:fillRef idx="0">
+            <a:schemeClr val="accent1"/>
+          </a:fillRef>
+          <a:effectRef idx="1">
+            <a:schemeClr val="accent1"/>
+          </a:effectRef>
+          <a:fontRef idx="minor">
+            <a:schemeClr val="tx1"/>
+          </a:fontRef>
+        </p:style>
+      </p:cxnSp>
+      <p:sp>
+        <p:nvSpPr>
+          <p:cNvPr id="15" name="TextBox 14"/>
+          <p:cNvSpPr txBox="1"/>
+          <p:nvPr/>
+        </p:nvSpPr>
+        <p:spPr>
+          <a:xfrm>
+            <a:off x="914400" y="3256280"/>
+            <a:ext cx="2971800" cy="622300"/>
+          </a:xfrm>
+          <a:prstGeom prst="rect">
+            <a:avLst/>
+          </a:prstGeom>
+          <a:noFill/>
+        </p:spPr>
+        <p:txBody>
+          <a:bodyPr wrap="none" lIns="0" rIns="0" tIns="0" bIns="0" anchor="t">
+            <a:spAutoFit/>
+          </a:bodyPr>
+          <a:lstStyle/>
+          <a:p>
+            <a:pPr algn="l">
+              <a:lnSpc>
+                <a:spcPts val="1500"/>
+              </a:lnSpc>
+            </a:pPr>
+            <a:r>
+              <a:rPr sz="1000" b="0" i="0">
+                <a:solidFill>
+                  <a:srgbClr val="0A1A01"/>
+                </a:solidFill>
+                <a:latin typeface="Poppins"/>
+              </a:rPr>
+              <a:t>5,42 M de Sénégalais sur les réseaux, 63 % des</a:t>
+            </a:r>
+          </a:p>
+          <a:p>
+            <a:pPr algn="l">
+              <a:lnSpc>
+                <a:spcPts val="1500"/>
+              </a:lnSpc>
+            </a:pPr>
+            <a:r>
+              <a:rPr sz="1000" b="0" i="0">
+                <a:solidFill>
+                  <a:srgbClr val="0A1A01"/>
+                </a:solidFill>
+                <a:latin typeface="Poppins"/>
+              </a:rPr>
+              <a:t>PMI dans l'agroalimentaire — et aucune</a:t>
+            </a:r>
+          </a:p>
+          <a:p>
+            <a:pPr algn="l">
+              <a:lnSpc>
+                <a:spcPts val="1500"/>
+              </a:lnSpc>
+            </a:pPr>
+            <a:r>
+              <a:rPr sz="1000" b="0" i="0">
+                <a:solidFill>
+                  <a:srgbClr val="0A1A01"/>
+                </a:solidFill>
+                <a:latin typeface="Poppins"/>
+              </a:rPr>
+              <a:t>agence spécialisée.</a:t>
+            </a:r>
+          </a:p>
+        </p:txBody>
+      </p:sp>
+      <p:sp>
+        <p:nvSpPr>
+          <p:cNvPr id="16" name="Rounded Rectangle 15"/>
+          <p:cNvSpPr/>
+          <p:nvPr/>
+        </p:nvSpPr>
+        <p:spPr>
+          <a:xfrm>
+            <a:off x="4318000" y="2184400"/>
+            <a:ext cx="3403600" cy="1930400"/>
+          </a:xfrm>
+          <a:prstGeom prst="roundRect">
+            <a:avLst>
+              <a:gd name="adj" fmla="val 5921"/>
+            </a:avLst>
+          </a:prstGeom>
+          <a:solidFill>
+            <a:srgbClr val="FFFFFF"/>
+          </a:solidFill>
+          <a:ln w="12700">
+            <a:solidFill>
+              <a:srgbClr val="DCE8DE"/>
+            </a:solidFill>
+          </a:ln>
+          <a:effectLst/>
+        </p:spPr>
+        <p:style>
+          <a:lnRef idx="1">
+            <a:schemeClr val="accent1"/>
+          </a:lnRef>
+          <a:fillRef idx="3">
+            <a:schemeClr val="accent1"/>
+          </a:fillRef>
+          <a:effectRef idx="2">
+            <a:schemeClr val="accent1"/>
+          </a:effectRef>
+          <a:fontRef idx="minor">
+            <a:schemeClr val="lt1"/>
+          </a:fontRef>
+        </p:style>
+        <p:txBody>
+          <a:bodyPr rtlCol="0" anchor="ctr"/>
+          <a:lstStyle/>
+          <a:p/>
+        </p:txBody>
+      </p:sp>
+      <p:sp>
+        <p:nvSpPr>
+          <p:cNvPr id="17" name="Rounded Rectangle 16"/>
+          <p:cNvSpPr/>
+          <p:nvPr/>
+        </p:nvSpPr>
+        <p:spPr>
+          <a:xfrm>
+            <a:off x="4318000" y="2108200"/>
+            <a:ext cx="3403600" cy="50800"/>
+          </a:xfrm>
+          <a:prstGeom prst="roundRect">
+            <a:avLst>
+              <a:gd name="adj" fmla="val 50000"/>
+            </a:avLst>
+          </a:prstGeom>
+          <a:solidFill>
+            <a:srgbClr val="1F5E3A"/>
+          </a:solidFill>
+          <a:ln>
+            <a:noFill/>
+          </a:ln>
+          <a:effectLst/>
+        </p:spPr>
+        <p:style>
+          <a:lnRef idx="1">
+            <a:schemeClr val="accent1"/>
+          </a:lnRef>
+          <a:fillRef idx="3">
+            <a:schemeClr val="accent1"/>
+          </a:fillRef>
+          <a:effectRef idx="2">
+            <a:schemeClr val="accent1"/>
+          </a:effectRef>
+          <a:fontRef idx="minor">
+            <a:schemeClr val="lt1"/>
+          </a:fontRef>
+        </p:style>
+        <p:txBody>
+          <a:bodyPr rtlCol="0" anchor="ctr"/>
+          <a:lstStyle/>
+          <a:p/>
+        </p:txBody>
+      </p:sp>
+      <p:sp>
+        <p:nvSpPr>
+          <p:cNvPr id="18" name="TextBox 17"/>
+          <p:cNvSpPr txBox="1"/>
+          <p:nvPr/>
+        </p:nvSpPr>
+        <p:spPr>
+          <a:xfrm>
+            <a:off x="4572000" y="2420925"/>
+            <a:ext cx="2895600" cy="185674"/>
+          </a:xfrm>
+          <a:prstGeom prst="rect">
+            <a:avLst/>
+          </a:prstGeom>
+          <a:noFill/>
+        </p:spPr>
+        <p:txBody>
+          <a:bodyPr wrap="none" lIns="0" rIns="0" tIns="0" bIns="0" anchor="t">
+            <a:spAutoFit/>
+          </a:bodyPr>
+          <a:lstStyle/>
+          <a:p>
+            <a:pPr algn="l">
+              <a:lnSpc>
+                <a:spcPts val="1118"/>
+              </a:lnSpc>
+            </a:pPr>
+            <a:r>
+              <a:rPr sz="860" b="1" i="0" spc="150">
+                <a:solidFill>
+                  <a:srgbClr val="1F5E3A"/>
+                </a:solidFill>
+                <a:latin typeface="Poppins"/>
+              </a:rPr>
+              <a:t>UNE EXPERTISE</a:t>
+            </a:r>
+          </a:p>
+        </p:txBody>
+      </p:sp>
+      <p:sp>
+        <p:nvSpPr>
+          <p:cNvPr id="19" name="TextBox 18"/>
+          <p:cNvSpPr txBox="1"/>
+          <p:nvPr/>
+        </p:nvSpPr>
+        <p:spPr>
+          <a:xfrm>
+            <a:off x="4572000" y="2632456"/>
+            <a:ext cx="2921000" cy="345440"/>
+          </a:xfrm>
+          <a:prstGeom prst="rect">
+            <a:avLst/>
+          </a:prstGeom>
+          <a:noFill/>
+        </p:spPr>
+        <p:txBody>
+          <a:bodyPr wrap="none" lIns="0" rIns="0" tIns="0" bIns="0" anchor="t">
+            <a:spAutoFit/>
+          </a:bodyPr>
+          <a:lstStyle/>
+          <a:p>
+            <a:pPr algn="l">
+              <a:lnSpc>
+                <a:spcPts val="2039"/>
+              </a:lnSpc>
+            </a:pPr>
+            <a:r>
+              <a:rPr sz="1700" b="0" i="0">
+                <a:solidFill>
+                  <a:srgbClr val="1F5E3A"/>
+                </a:solidFill>
+                <a:latin typeface="Alfa Slab One"/>
+              </a:rPr>
+              <a:t>Agricole et digitale</a:t>
+            </a:r>
+          </a:p>
+        </p:txBody>
+      </p:sp>
+      <p:cxnSp>
+        <p:nvCxnSpPr>
+          <p:cNvPr id="20" name="Connector 19"/>
+          <p:cNvCxnSpPr/>
+          <p:nvPr/>
+        </p:nvCxnSpPr>
+        <p:spPr>
+          <a:xfrm>
+            <a:off x="4597400" y="3098800"/>
+            <a:ext cx="2844800" cy="0"/>
+          </a:xfrm>
+          <a:prstGeom prst="line">
+            <a:avLst/>
+          </a:prstGeom>
+          <a:ln w="12700">
+            <a:solidFill>
+              <a:srgbClr val="DCE8DE"/>
+            </a:solidFill>
+          </a:ln>
+        </p:spPr>
+        <p:style>
+          <a:lnRef idx="2">
+            <a:schemeClr val="accent1"/>
+          </a:lnRef>
+          <a:fillRef idx="0">
+            <a:schemeClr val="accent1"/>
+          </a:fillRef>
+          <a:effectRef idx="1">
+            <a:schemeClr val="accent1"/>
+          </a:effectRef>
+          <a:fontRef idx="minor">
+            <a:schemeClr val="tx1"/>
+          </a:fontRef>
+        </p:style>
+      </p:cxnSp>
+      <p:sp>
+        <p:nvSpPr>
+          <p:cNvPr id="21" name="TextBox 20"/>
+          <p:cNvSpPr txBox="1"/>
+          <p:nvPr/>
+        </p:nvSpPr>
+        <p:spPr>
+          <a:xfrm>
+            <a:off x="4572000" y="3256280"/>
+            <a:ext cx="2971800" cy="622300"/>
+          </a:xfrm>
+          <a:prstGeom prst="rect">
+            <a:avLst/>
+          </a:prstGeom>
+          <a:noFill/>
+        </p:spPr>
+        <p:txBody>
+          <a:bodyPr wrap="none" lIns="0" rIns="0" tIns="0" bIns="0" anchor="t">
+            <a:spAutoFit/>
+          </a:bodyPr>
+          <a:lstStyle/>
+          <a:p>
+            <a:pPr algn="l">
+              <a:lnSpc>
+                <a:spcPts val="1500"/>
+              </a:lnSpc>
+            </a:pPr>
+            <a:r>
+              <a:rPr sz="1000" b="0" i="0">
+                <a:solidFill>
+                  <a:srgbClr val="0A1A01"/>
+                </a:solidFill>
+                <a:latin typeface="Poppins"/>
+              </a:rPr>
+              <a:t>Agronome de l'UCAD et community manager</a:t>
+            </a:r>
+          </a:p>
+          <a:p>
+            <a:pPr algn="l">
+              <a:lnSpc>
+                <a:spcPts val="1500"/>
+              </a:lnSpc>
+            </a:pPr>
+            <a:r>
+              <a:rPr sz="1000" b="0" i="0">
+                <a:solidFill>
+                  <a:srgbClr val="0A1A01"/>
+                </a:solidFill>
+                <a:latin typeface="Poppins"/>
+              </a:rPr>
+              <a:t>formée à Simplon : une double compétence</a:t>
+            </a:r>
+          </a:p>
+          <a:p>
+            <a:pPr algn="l">
+              <a:lnSpc>
+                <a:spcPts val="1500"/>
+              </a:lnSpc>
+            </a:pPr>
+            <a:r>
+              <a:rPr sz="1000" b="0" i="0">
+                <a:solidFill>
+                  <a:srgbClr val="0A1A01"/>
+                </a:solidFill>
+                <a:latin typeface="Poppins"/>
+              </a:rPr>
+              <a:t>unique sur ce marché.</a:t>
+            </a:r>
+          </a:p>
+        </p:txBody>
+      </p:sp>
+      <p:sp>
+        <p:nvSpPr>
+          <p:cNvPr id="22" name="Rounded Rectangle 21"/>
+          <p:cNvSpPr/>
+          <p:nvPr/>
+        </p:nvSpPr>
+        <p:spPr>
+          <a:xfrm>
+            <a:off x="7975600" y="2184400"/>
+            <a:ext cx="3403600" cy="1930400"/>
+          </a:xfrm>
+          <a:prstGeom prst="roundRect">
+            <a:avLst>
+              <a:gd name="adj" fmla="val 5921"/>
+            </a:avLst>
+          </a:prstGeom>
+          <a:solidFill>
+            <a:srgbClr val="FFFFFF"/>
+          </a:solidFill>
+          <a:ln w="12700">
+            <a:solidFill>
+              <a:srgbClr val="DCE8DE"/>
+            </a:solidFill>
+          </a:ln>
+          <a:effectLst/>
+        </p:spPr>
+        <p:style>
+          <a:lnRef idx="1">
+            <a:schemeClr val="accent1"/>
+          </a:lnRef>
+          <a:fillRef idx="3">
+            <a:schemeClr val="accent1"/>
+          </a:fillRef>
+          <a:effectRef idx="2">
+            <a:schemeClr val="accent1"/>
+          </a:effectRef>
+          <a:fontRef idx="minor">
+            <a:schemeClr val="lt1"/>
+          </a:fontRef>
+        </p:style>
+        <p:txBody>
+          <a:bodyPr rtlCol="0" anchor="ctr"/>
+          <a:lstStyle/>
+          <a:p/>
+        </p:txBody>
+      </p:sp>
+      <p:sp>
+        <p:nvSpPr>
+          <p:cNvPr id="23" name="Rounded Rectangle 22"/>
+          <p:cNvSpPr/>
+          <p:nvPr/>
+        </p:nvSpPr>
+        <p:spPr>
+          <a:xfrm>
+            <a:off x="7975600" y="2108200"/>
+            <a:ext cx="3403600" cy="50800"/>
+          </a:xfrm>
+          <a:prstGeom prst="roundRect">
+            <a:avLst>
+              <a:gd name="adj" fmla="val 50000"/>
+            </a:avLst>
+          </a:prstGeom>
+          <a:solidFill>
+            <a:srgbClr val="42612D"/>
+          </a:solidFill>
+          <a:ln>
+            <a:noFill/>
+          </a:ln>
+          <a:effectLst/>
+        </p:spPr>
+        <p:style>
+          <a:lnRef idx="1">
+            <a:schemeClr val="accent1"/>
+          </a:lnRef>
+          <a:fillRef idx="3">
+            <a:schemeClr val="accent1"/>
+          </a:fillRef>
+          <a:effectRef idx="2">
+            <a:schemeClr val="accent1"/>
+          </a:effectRef>
+          <a:fontRef idx="minor">
+            <a:schemeClr val="lt1"/>
+          </a:fontRef>
+        </p:style>
+        <p:txBody>
+          <a:bodyPr rtlCol="0" anchor="ctr"/>
+          <a:lstStyle/>
+          <a:p/>
+        </p:txBody>
+      </p:sp>
+      <p:sp>
+        <p:nvSpPr>
+          <p:cNvPr id="24" name="TextBox 23"/>
+          <p:cNvSpPr txBox="1"/>
+          <p:nvPr/>
+        </p:nvSpPr>
+        <p:spPr>
+          <a:xfrm>
+            <a:off x="8229600" y="2420925"/>
+            <a:ext cx="2895600" cy="185674"/>
+          </a:xfrm>
+          <a:prstGeom prst="rect">
+            <a:avLst/>
+          </a:prstGeom>
+          <a:noFill/>
+        </p:spPr>
+        <p:txBody>
+          <a:bodyPr wrap="none" lIns="0" rIns="0" tIns="0" bIns="0" anchor="t">
+            <a:spAutoFit/>
+          </a:bodyPr>
+          <a:lstStyle/>
+          <a:p>
+            <a:pPr algn="l">
+              <a:lnSpc>
+                <a:spcPts val="1118"/>
+              </a:lnSpc>
+            </a:pPr>
+            <a:r>
+              <a:rPr sz="860" b="1" i="0" spc="150">
+                <a:solidFill>
+                  <a:srgbClr val="42612D"/>
+                </a:solidFill>
+                <a:latin typeface="Poppins"/>
+              </a:rPr>
+              <a:t>UN PROJET</a:t>
+            </a:r>
+          </a:p>
+        </p:txBody>
+      </p:sp>
+      <p:sp>
+        <p:nvSpPr>
+          <p:cNvPr id="25" name="TextBox 24"/>
+          <p:cNvSpPr txBox="1"/>
+          <p:nvPr/>
+        </p:nvSpPr>
+        <p:spPr>
+          <a:xfrm>
+            <a:off x="8229600" y="2632456"/>
+            <a:ext cx="2921000" cy="345440"/>
+          </a:xfrm>
+          <a:prstGeom prst="rect">
+            <a:avLst/>
+          </a:prstGeom>
+          <a:noFill/>
+        </p:spPr>
+        <p:txBody>
+          <a:bodyPr wrap="none" lIns="0" rIns="0" tIns="0" bIns="0" anchor="t">
+            <a:spAutoFit/>
+          </a:bodyPr>
+          <a:lstStyle/>
+          <a:p>
+            <a:pPr algn="l">
+              <a:lnSpc>
+                <a:spcPts val="2039"/>
+              </a:lnSpc>
+            </a:pPr>
+            <a:r>
+              <a:rPr sz="1700" b="0" i="0">
+                <a:solidFill>
+                  <a:srgbClr val="1F5E3A"/>
+                </a:solidFill>
+                <a:latin typeface="Alfa Slab One"/>
+              </a:rPr>
+              <a:t>Déjà lancé, pas une idée</a:t>
+            </a:r>
+          </a:p>
+        </p:txBody>
+      </p:sp>
+      <p:cxnSp>
+        <p:nvCxnSpPr>
+          <p:cNvPr id="26" name="Connector 25"/>
+          <p:cNvCxnSpPr/>
+          <p:nvPr/>
+        </p:nvCxnSpPr>
+        <p:spPr>
+          <a:xfrm>
+            <a:off x="8255000" y="3098800"/>
+            <a:ext cx="2844800" cy="0"/>
+          </a:xfrm>
+          <a:prstGeom prst="line">
+            <a:avLst/>
+          </a:prstGeom>
+          <a:ln w="12700">
+            <a:solidFill>
+              <a:srgbClr val="DCE8DE"/>
+            </a:solidFill>
+          </a:ln>
+        </p:spPr>
+        <p:style>
+          <a:lnRef idx="2">
+            <a:schemeClr val="accent1"/>
+          </a:lnRef>
+          <a:fillRef idx="0">
+            <a:schemeClr val="accent1"/>
+          </a:fillRef>
+          <a:effectRef idx="1">
+            <a:schemeClr val="accent1"/>
+          </a:effectRef>
+          <a:fontRef idx="minor">
+            <a:schemeClr val="tx1"/>
+          </a:fontRef>
+        </p:style>
+      </p:cxnSp>
+      <p:sp>
+        <p:nvSpPr>
+          <p:cNvPr id="27" name="TextBox 26"/>
+          <p:cNvSpPr txBox="1"/>
+          <p:nvPr/>
+        </p:nvSpPr>
+        <p:spPr>
+          <a:xfrm>
+            <a:off x="8229600" y="3256280"/>
+            <a:ext cx="2971800" cy="431800"/>
+          </a:xfrm>
+          <a:prstGeom prst="rect">
+            <a:avLst/>
+          </a:prstGeom>
+          <a:noFill/>
+        </p:spPr>
+        <p:txBody>
+          <a:bodyPr wrap="none" lIns="0" rIns="0" tIns="0" bIns="0" anchor="t">
+            <a:spAutoFit/>
+          </a:bodyPr>
+          <a:lstStyle/>
+          <a:p>
+            <a:pPr algn="l">
+              <a:lnSpc>
+                <a:spcPts val="1500"/>
+              </a:lnSpc>
+            </a:pPr>
+            <a:r>
+              <a:rPr sz="1000" b="0" i="0">
+                <a:solidFill>
+                  <a:srgbClr val="0A1A01"/>
+                </a:solidFill>
+                <a:latin typeface="Poppins"/>
+              </a:rPr>
+              <a:t>Entreprise formalisée, marque construite,</a:t>
+            </a:r>
+          </a:p>
+          <a:p>
+            <a:pPr algn="l">
+              <a:lnSpc>
+                <a:spcPts val="1500"/>
+              </a:lnSpc>
+            </a:pPr>
+            <a:r>
+              <a:rPr sz="1000" b="0" i="0">
+                <a:solidFill>
+                  <a:srgbClr val="0A1A01"/>
+                </a:solidFill>
+                <a:latin typeface="Poppins"/>
+              </a:rPr>
+              <a:t>présence digitale active et offres structurées.</a:t>
+            </a:r>
+          </a:p>
+        </p:txBody>
+      </p:sp>
+      <p:sp>
+        <p:nvSpPr>
+          <p:cNvPr id="28" name="Rounded Rectangle 27"/>
+          <p:cNvSpPr/>
+          <p:nvPr/>
+        </p:nvSpPr>
+        <p:spPr>
+          <a:xfrm>
+            <a:off x="660400" y="4470400"/>
+            <a:ext cx="10871200" cy="939800"/>
+          </a:xfrm>
+          <a:prstGeom prst="roundRect">
+            <a:avLst>
+              <a:gd name="adj" fmla="val 14864"/>
+            </a:avLst>
+          </a:prstGeom>
+          <a:solidFill>
+            <a:srgbClr val="1F5E3A"/>
+          </a:solidFill>
+          <a:ln>
+            <a:noFill/>
+          </a:ln>
+          <a:effectLst/>
+        </p:spPr>
+        <p:style>
+          <a:lnRef idx="1">
+            <a:schemeClr val="accent1"/>
+          </a:lnRef>
+          <a:fillRef idx="3">
+            <a:schemeClr val="accent1"/>
+          </a:fillRef>
+          <a:effectRef idx="2">
+            <a:schemeClr val="accent1"/>
+          </a:effectRef>
+          <a:fontRef idx="minor">
+            <a:schemeClr val="lt1"/>
+          </a:fontRef>
+        </p:style>
+        <p:txBody>
+          <a:bodyPr rtlCol="0" anchor="ctr"/>
+          <a:lstStyle/>
+          <a:p/>
+        </p:txBody>
+      </p:sp>
+      <p:sp>
+        <p:nvSpPr>
+          <p:cNvPr id="29" name="TextBox 28"/>
+          <p:cNvSpPr txBox="1"/>
+          <p:nvPr/>
+        </p:nvSpPr>
+        <p:spPr>
+          <a:xfrm>
+            <a:off x="990600" y="4706925"/>
+            <a:ext cx="2844800" cy="185674"/>
+          </a:xfrm>
+          <a:prstGeom prst="rect">
+            <a:avLst/>
+          </a:prstGeom>
+          <a:noFill/>
+        </p:spPr>
+        <p:txBody>
+          <a:bodyPr wrap="none" lIns="0" rIns="0" tIns="0" bIns="0" anchor="t">
+            <a:spAutoFit/>
+          </a:bodyPr>
+          <a:lstStyle/>
+          <a:p>
+            <a:pPr algn="l">
+              <a:lnSpc>
+                <a:spcPts val="1118"/>
+              </a:lnSpc>
+            </a:pPr>
+            <a:r>
+              <a:rPr sz="860" b="1" i="0" spc="150">
+                <a:solidFill>
+                  <a:srgbClr val="1AAB70"/>
+                </a:solidFill>
+                <a:latin typeface="Poppins"/>
+              </a:rPr>
+              <a:t>CE QUE JE DEMANDE</a:t>
+            </a:r>
+          </a:p>
+        </p:txBody>
+      </p:sp>
+      <p:sp>
+        <p:nvSpPr>
+          <p:cNvPr id="30" name="TextBox 29"/>
+          <p:cNvSpPr txBox="1"/>
+          <p:nvPr/>
+        </p:nvSpPr>
+        <p:spPr>
+          <a:xfrm>
+            <a:off x="990600" y="4876800"/>
+            <a:ext cx="3352800" cy="539750"/>
+          </a:xfrm>
+          <a:prstGeom prst="rect">
+            <a:avLst/>
+          </a:prstGeom>
+          <a:noFill/>
+        </p:spPr>
+        <p:txBody>
+          <a:bodyPr wrap="none" lIns="0" rIns="0" tIns="0" bIns="0" anchor="t">
+            <a:spAutoFit/>
+          </a:bodyPr>
+          <a:lstStyle/>
+          <a:p>
+            <a:pPr algn="l">
+              <a:lnSpc>
+                <a:spcPts val="3250"/>
+              </a:lnSpc>
+            </a:pPr>
+            <a:r>
+              <a:rPr sz="2500" b="0" i="0">
+                <a:solidFill>
+                  <a:srgbClr val="FFFFFF"/>
+                </a:solidFill>
+                <a:latin typeface="Alfa Slab One"/>
+              </a:rPr>
+              <a:t>1 850 000 FCFA</a:t>
+            </a:r>
+          </a:p>
+        </p:txBody>
+      </p:sp>
+      <p:cxnSp>
+        <p:nvCxnSpPr>
+          <p:cNvPr id="31" name="Connector 30"/>
+          <p:cNvCxnSpPr/>
+          <p:nvPr/>
+        </p:nvCxnSpPr>
+        <p:spPr>
+          <a:xfrm>
+            <a:off x="4699000" y="4724400"/>
+            <a:ext cx="0" cy="431800"/>
+          </a:xfrm>
+          <a:prstGeom prst="line">
+            <a:avLst/>
+          </a:prstGeom>
+          <a:ln w="15240">
+            <a:solidFill>
+              <a:srgbClr val="1AAB70"/>
+            </a:solidFill>
+          </a:ln>
+        </p:spPr>
+        <p:style>
+          <a:lnRef idx="2">
+            <a:schemeClr val="accent1"/>
+          </a:lnRef>
+          <a:fillRef idx="0">
+            <a:schemeClr val="accent1"/>
+          </a:fillRef>
+          <a:effectRef idx="1">
+            <a:schemeClr val="accent1"/>
+          </a:effectRef>
+          <a:fontRef idx="minor">
+            <a:schemeClr val="tx1"/>
+          </a:fontRef>
+        </p:style>
+      </p:cxnSp>
+      <p:sp>
+        <p:nvSpPr>
+          <p:cNvPr id="32" name="TextBox 31"/>
+          <p:cNvSpPr txBox="1"/>
+          <p:nvPr/>
+        </p:nvSpPr>
+        <p:spPr>
+          <a:xfrm>
+            <a:off x="5029200" y="4777232"/>
+            <a:ext cx="6273800" cy="481965"/>
+          </a:xfrm>
+          <a:prstGeom prst="rect">
+            <a:avLst/>
+          </a:prstGeom>
+          <a:noFill/>
+        </p:spPr>
+        <p:txBody>
+          <a:bodyPr wrap="none" lIns="0" rIns="0" tIns="0" bIns="0" anchor="t">
+            <a:spAutoFit/>
+          </a:bodyPr>
+          <a:lstStyle/>
+          <a:p>
+            <a:pPr algn="l">
+              <a:lnSpc>
+                <a:spcPts val="1667"/>
+              </a:lnSpc>
+            </a:pPr>
+            <a:r>
+              <a:rPr sz="1150" b="0" i="0">
+                <a:solidFill>
+                  <a:srgbClr val="FFFFFF"/>
+                </a:solidFill>
+                <a:latin typeface="Poppins"/>
+              </a:rPr>
+              <a:t>Pour équiper la production, me former, lancer le site vitrine et signer mes cinq</a:t>
+            </a:r>
+          </a:p>
+          <a:p>
+            <a:pPr algn="l">
+              <a:lnSpc>
+                <a:spcPts val="1667"/>
+              </a:lnSpc>
+            </a:pPr>
+            <a:r>
+              <a:rPr sz="1150" b="0" i="0">
+                <a:solidFill>
+                  <a:srgbClr val="FFFFFF"/>
+                </a:solidFill>
+                <a:latin typeface="Poppins"/>
+              </a:rPr>
+              <a:t>premiers clients.</a:t>
+            </a:r>
+          </a:p>
+        </p:txBody>
+      </p:sp>
+      <p:sp>
+        <p:nvSpPr>
+          <p:cNvPr id="33" name="TextBox 32"/>
+          <p:cNvSpPr txBox="1"/>
+          <p:nvPr/>
+        </p:nvSpPr>
+        <p:spPr>
+          <a:xfrm>
+            <a:off x="635000" y="5711952"/>
+            <a:ext cx="10922000" cy="302260"/>
+          </a:xfrm>
+          <a:prstGeom prst="rect">
+            <a:avLst/>
+          </a:prstGeom>
+          <a:noFill/>
+        </p:spPr>
+        <p:txBody>
+          <a:bodyPr wrap="none" lIns="0" rIns="0" tIns="0" bIns="0" anchor="t">
+            <a:spAutoFit/>
+          </a:bodyPr>
+          <a:lstStyle/>
+          <a:p>
+            <a:pPr algn="ctr">
+              <a:lnSpc>
+                <a:spcPts val="1820"/>
+              </a:lnSpc>
+            </a:pPr>
+            <a:r>
+              <a:rPr sz="1400" b="0" i="0">
+                <a:solidFill>
+                  <a:srgbClr val="1F5E3A"/>
+                </a:solidFill>
+                <a:latin typeface="Alfa Slab One"/>
+              </a:rPr>
+              <a:t>« Rendre les produits locaux sénégalais aussi visibles en ligne qu'ils le sont dans les rayons. »</a:t>
+            </a:r>
+          </a:p>
+        </p:txBody>
+      </p:sp>
+    </p:spTree>
+  </p:cSld>
+  <p:clrMapOvr>
+    <a:masterClrMapping/>
+  </p:clrMapOvr>
+</p:sld>
+</file>
+
+<file path=ppt/slides/slide23.xml><?xml version="1.0" encoding="utf-8"?>
 <p:sld xmlns:a="http://schemas.openxmlformats.org/drawingml/2006/main" xmlns:p="http://schemas.openxmlformats.org/presentationml/2006/main" xmlns:r="http://schemas.openxmlformats.org/officeDocument/2006/relationships">
   <p:cSld>
     <p:spTree>
@@ -43792,7 +45174,7 @@
                 </a:solidFill>
                 <a:latin typeface="Poppins"/>
               </a:rPr>
-              <a:t>22</a:t>
+              <a:t>23</a:t>
             </a:r>
           </a:p>
         </p:txBody>

</xml_diff>

<commit_message>
Conclusion simplifiee: un paragraphe (visibilite, marketing, juste prix pour les producteurs)
Co-authored-by: arena-agent <297053741+arena-agent@users.noreply.github.com>
</commit_message>
<xml_diff>
--- a/Pitch_Deck_Sadiya_Digital_Agri.pptx
+++ b/Pitch_Deck_Sadiya_Digital_Agri.pptx
@@ -40999,53 +40999,14 @@
                 </a:solidFill>
                 <a:latin typeface="Alfa Slab One"/>
               </a:rPr>
-              <a:t>Ce Qu'il Faut Retenir</a:t>
-            </a:r>
-          </a:p>
-        </p:txBody>
-      </p:sp>
-      <p:sp>
-        <p:nvSpPr>
-          <p:cNvPr id="7" name="TextBox 6"/>
-          <p:cNvSpPr txBox="1"/>
-          <p:nvPr/>
-        </p:nvSpPr>
-        <p:spPr>
-          <a:xfrm>
-            <a:off x="635000" y="1184148"/>
-            <a:ext cx="7924800" cy="244475"/>
-          </a:xfrm>
-          <a:prstGeom prst="rect">
-            <a:avLst/>
-          </a:prstGeom>
-          <a:noFill/>
-        </p:spPr>
-        <p:txBody>
-          <a:bodyPr wrap="none" lIns="0" rIns="0" tIns="0" bIns="0" anchor="t">
-            <a:spAutoFit/>
-          </a:bodyPr>
-          <a:lstStyle/>
-          <a:p>
-            <a:pPr algn="l">
-              <a:lnSpc>
-                <a:spcPts val="1485"/>
-              </a:lnSpc>
-            </a:pPr>
-            <a:r>
-              <a:rPr sz="1100" b="0" i="0">
-                <a:solidFill>
-                  <a:srgbClr val="42612D"/>
-                </a:solidFill>
-                <a:latin typeface="Poppins"/>
-              </a:rPr>
-              <a:t>Un marché porteur, une expertise unique, un projet déjà lancé.</a:t>
+              <a:t>Conclusion</a:t>
             </a:r>
           </a:p>
         </p:txBody>
       </p:sp>
       <p:pic>
         <p:nvPicPr>
-          <p:cNvPr id="8" name="Picture 7" descr="logo-sadiya.png"/>
+          <p:cNvPr id="7" name="Picture 6" descr="logo-sadiya.png"/>
           <p:cNvPicPr>
             <a:picLocks noChangeAspect="1"/>
           </p:cNvPicPr>
@@ -41069,7 +41030,7 @@
       </p:pic>
       <p:sp>
         <p:nvSpPr>
-          <p:cNvPr id="9" name="TextBox 8"/>
+          <p:cNvPr id="8" name="TextBox 7"/>
           <p:cNvSpPr txBox="1"/>
           <p:nvPr/>
         </p:nvSpPr>
@@ -41108,18 +41069,18 @@
       </p:sp>
       <p:sp>
         <p:nvSpPr>
-          <p:cNvPr id="10" name="Rounded Rectangle 9"/>
-          <p:cNvSpPr/>
-          <p:nvPr/>
-        </p:nvSpPr>
-        <p:spPr>
-          <a:xfrm>
-            <a:off x="660400" y="2184400"/>
-            <a:ext cx="3403600" cy="1930400"/>
+          <p:cNvPr id="9" name="Rounded Rectangle 8"/>
+          <p:cNvSpPr/>
+          <p:nvPr/>
+        </p:nvSpPr>
+        <p:spPr>
+          <a:xfrm>
+            <a:off x="660400" y="2311400"/>
+            <a:ext cx="10871200" cy="2717800"/>
           </a:xfrm>
           <a:prstGeom prst="roundRect">
             <a:avLst>
-              <a:gd name="adj" fmla="val 5921"/>
+              <a:gd name="adj" fmla="val 6074"/>
             </a:avLst>
           </a:prstGeom>
           <a:solidFill>
@@ -41154,18 +41115,18 @@
       </p:sp>
       <p:sp>
         <p:nvSpPr>
-          <p:cNvPr id="11" name="Rounded Rectangle 10"/>
-          <p:cNvSpPr/>
-          <p:nvPr/>
-        </p:nvSpPr>
-        <p:spPr>
-          <a:xfrm>
-            <a:off x="660400" y="2108200"/>
-            <a:ext cx="3403600" cy="50800"/>
+          <p:cNvPr id="10" name="Rounded Rectangle 9"/>
+          <p:cNvSpPr/>
+          <p:nvPr/>
+        </p:nvSpPr>
+        <p:spPr>
+          <a:xfrm>
+            <a:off x="660400" y="2311400"/>
+            <a:ext cx="10871200" cy="63500"/>
           </a:xfrm>
           <a:prstGeom prst="roundRect">
             <a:avLst>
-              <a:gd name="adj" fmla="val 50000"/>
+              <a:gd name="adj" fmla="val 40000"/>
             </a:avLst>
           </a:prstGeom>
           <a:solidFill>
@@ -41198,14 +41159,14 @@
       </p:sp>
       <p:sp>
         <p:nvSpPr>
-          <p:cNvPr id="12" name="TextBox 11"/>
+          <p:cNvPr id="11" name="TextBox 10"/>
           <p:cNvSpPr txBox="1"/>
           <p:nvPr/>
         </p:nvSpPr>
         <p:spPr>
           <a:xfrm>
-            <a:off x="914400" y="2420925"/>
-            <a:ext cx="2895600" cy="185674"/>
+            <a:off x="1295400" y="2735072"/>
+            <a:ext cx="9601200" cy="1885950"/>
           </a:xfrm>
           <a:prstGeom prst="rect">
             <a:avLst/>
@@ -41218,498 +41179,97 @@
           </a:bodyPr>
           <a:lstStyle/>
           <a:p>
-            <a:pPr algn="l">
+            <a:pPr algn="just">
               <a:lnSpc>
-                <a:spcPts val="1118"/>
+                <a:spcPts val="2838"/>
               </a:lnSpc>
             </a:pPr>
             <a:r>
-              <a:rPr sz="860" b="1" i="0" spc="150">
-                <a:solidFill>
-                  <a:srgbClr val="1AAB70"/>
-                </a:solidFill>
-                <a:latin typeface="Poppins"/>
-              </a:rPr>
-              <a:t>UN MARCHÉ</a:t>
-            </a:r>
-          </a:p>
-        </p:txBody>
-      </p:sp>
-      <p:sp>
-        <p:nvSpPr>
-          <p:cNvPr id="13" name="TextBox 12"/>
-          <p:cNvSpPr txBox="1"/>
-          <p:nvPr/>
-        </p:nvSpPr>
-        <p:spPr>
-          <a:xfrm>
-            <a:off x="914400" y="2632456"/>
-            <a:ext cx="2921000" cy="345440"/>
-          </a:xfrm>
-          <a:prstGeom prst="rect">
-            <a:avLst/>
-          </a:prstGeom>
-          <a:noFill/>
-        </p:spPr>
-        <p:txBody>
-          <a:bodyPr wrap="none" lIns="0" rIns="0" tIns="0" bIns="0" anchor="t">
-            <a:spAutoFit/>
-          </a:bodyPr>
-          <a:lstStyle/>
-          <a:p>
-            <a:pPr algn="l">
-              <a:lnSpc>
-                <a:spcPts val="2039"/>
-              </a:lnSpc>
-            </a:pPr>
-            <a:r>
-              <a:rPr sz="1700" b="0" i="0">
-                <a:solidFill>
-                  <a:srgbClr val="1F5E3A"/>
-                </a:solidFill>
-                <a:latin typeface="Alfa Slab One"/>
-              </a:rPr>
-              <a:t>Porteur et inexploité</a:t>
-            </a:r>
-          </a:p>
-        </p:txBody>
-      </p:sp>
-      <p:cxnSp>
-        <p:nvCxnSpPr>
-          <p:cNvPr id="14" name="Connector 13"/>
-          <p:cNvCxnSpPr/>
-          <p:nvPr/>
-        </p:nvCxnSpPr>
-        <p:spPr>
-          <a:xfrm>
-            <a:off x="939800" y="3098800"/>
-            <a:ext cx="2844800" cy="0"/>
-          </a:xfrm>
-          <a:prstGeom prst="line">
-            <a:avLst/>
-          </a:prstGeom>
-          <a:ln w="12700">
-            <a:solidFill>
-              <a:srgbClr val="DCE8DE"/>
-            </a:solidFill>
-          </a:ln>
-        </p:spPr>
-        <p:style>
-          <a:lnRef idx="2">
-            <a:schemeClr val="accent1"/>
-          </a:lnRef>
-          <a:fillRef idx="0">
-            <a:schemeClr val="accent1"/>
-          </a:fillRef>
-          <a:effectRef idx="1">
-            <a:schemeClr val="accent1"/>
-          </a:effectRef>
-          <a:fontRef idx="minor">
-            <a:schemeClr val="tx1"/>
-          </a:fontRef>
-        </p:style>
-      </p:cxnSp>
-      <p:sp>
-        <p:nvSpPr>
-          <p:cNvPr id="15" name="TextBox 14"/>
-          <p:cNvSpPr txBox="1"/>
-          <p:nvPr/>
-        </p:nvSpPr>
-        <p:spPr>
-          <a:xfrm>
-            <a:off x="914400" y="3256280"/>
-            <a:ext cx="2971800" cy="622300"/>
-          </a:xfrm>
-          <a:prstGeom prst="rect">
-            <a:avLst/>
-          </a:prstGeom>
-          <a:noFill/>
-        </p:spPr>
-        <p:txBody>
-          <a:bodyPr wrap="none" lIns="0" rIns="0" tIns="0" bIns="0" anchor="t">
-            <a:spAutoFit/>
-          </a:bodyPr>
-          <a:lstStyle/>
-          <a:p>
-            <a:pPr algn="l">
-              <a:lnSpc>
-                <a:spcPts val="1500"/>
-              </a:lnSpc>
-            </a:pPr>
-            <a:r>
-              <a:rPr sz="1000" b="0" i="0">
+              <a:rPr sz="1650" b="0" i="0">
                 <a:solidFill>
                   <a:srgbClr val="0A1A01"/>
                 </a:solidFill>
                 <a:latin typeface="Poppins"/>
               </a:rPr>
-              <a:t>5,42 M de Sénégalais sur les réseaux, 63 % des</a:t>
+              <a:t>Sadiya Digital Agri rend visibles les produits agroalimentaires sénégalais. Grâce à un</a:t>
             </a:r>
           </a:p>
           <a:p>
-            <a:pPr algn="l">
+            <a:pPr algn="just">
               <a:lnSpc>
-                <a:spcPts val="1500"/>
+                <a:spcPts val="2838"/>
               </a:lnSpc>
             </a:pPr>
             <a:r>
-              <a:rPr sz="1000" b="0" i="0">
+              <a:rPr sz="1650" b="0" i="0">
                 <a:solidFill>
                   <a:srgbClr val="0A1A01"/>
                 </a:solidFill>
                 <a:latin typeface="Poppins"/>
               </a:rPr>
-              <a:t>PMI dans l'agroalimentaire — et aucune</a:t>
+              <a:t>meilleur marketing digital, les entreprises que j'accompagne gagnent en notoriété,</a:t>
             </a:r>
           </a:p>
           <a:p>
-            <a:pPr algn="l">
+            <a:pPr algn="just">
               <a:lnSpc>
-                <a:spcPts val="1500"/>
+                <a:spcPts val="2838"/>
               </a:lnSpc>
             </a:pPr>
             <a:r>
-              <a:rPr sz="1000" b="0" i="0">
+              <a:rPr sz="1650" b="0" i="0">
                 <a:solidFill>
                   <a:srgbClr val="0A1A01"/>
                 </a:solidFill>
                 <a:latin typeface="Poppins"/>
               </a:rPr>
-              <a:t>agence spécialisée.</a:t>
+              <a:t>trouvent de nouveaux clients et vendent davantage. Et en bout de chaîne, ce sont les</a:t>
             </a:r>
           </a:p>
-        </p:txBody>
-      </p:sp>
-      <p:sp>
-        <p:nvSpPr>
-          <p:cNvPr id="16" name="Rounded Rectangle 15"/>
-          <p:cNvSpPr/>
-          <p:nvPr/>
-        </p:nvSpPr>
-        <p:spPr>
-          <a:xfrm>
-            <a:off x="4318000" y="2184400"/>
-            <a:ext cx="3403600" cy="1930400"/>
-          </a:xfrm>
-          <a:prstGeom prst="roundRect">
-            <a:avLst>
-              <a:gd name="adj" fmla="val 5921"/>
-            </a:avLst>
-          </a:prstGeom>
-          <a:solidFill>
-            <a:srgbClr val="FFFFFF"/>
-          </a:solidFill>
-          <a:ln w="12700">
-            <a:solidFill>
-              <a:srgbClr val="DCE8DE"/>
-            </a:solidFill>
-          </a:ln>
-          <a:effectLst/>
-        </p:spPr>
-        <p:style>
-          <a:lnRef idx="1">
-            <a:schemeClr val="accent1"/>
-          </a:lnRef>
-          <a:fillRef idx="3">
-            <a:schemeClr val="accent1"/>
-          </a:fillRef>
-          <a:effectRef idx="2">
-            <a:schemeClr val="accent1"/>
-          </a:effectRef>
-          <a:fontRef idx="minor">
-            <a:schemeClr val="lt1"/>
-          </a:fontRef>
-        </p:style>
-        <p:txBody>
-          <a:bodyPr rtlCol="0" anchor="ctr"/>
-          <a:lstStyle/>
-          <a:p/>
-        </p:txBody>
-      </p:sp>
-      <p:sp>
-        <p:nvSpPr>
-          <p:cNvPr id="17" name="Rounded Rectangle 16"/>
-          <p:cNvSpPr/>
-          <p:nvPr/>
-        </p:nvSpPr>
-        <p:spPr>
-          <a:xfrm>
-            <a:off x="4318000" y="2108200"/>
-            <a:ext cx="3403600" cy="50800"/>
-          </a:xfrm>
-          <a:prstGeom prst="roundRect">
-            <a:avLst>
-              <a:gd name="adj" fmla="val 50000"/>
-            </a:avLst>
-          </a:prstGeom>
-          <a:solidFill>
-            <a:srgbClr val="1F5E3A"/>
-          </a:solidFill>
-          <a:ln>
-            <a:noFill/>
-          </a:ln>
-          <a:effectLst/>
-        </p:spPr>
-        <p:style>
-          <a:lnRef idx="1">
-            <a:schemeClr val="accent1"/>
-          </a:lnRef>
-          <a:fillRef idx="3">
-            <a:schemeClr val="accent1"/>
-          </a:fillRef>
-          <a:effectRef idx="2">
-            <a:schemeClr val="accent1"/>
-          </a:effectRef>
-          <a:fontRef idx="minor">
-            <a:schemeClr val="lt1"/>
-          </a:fontRef>
-        </p:style>
-        <p:txBody>
-          <a:bodyPr rtlCol="0" anchor="ctr"/>
-          <a:lstStyle/>
-          <a:p/>
-        </p:txBody>
-      </p:sp>
-      <p:sp>
-        <p:nvSpPr>
-          <p:cNvPr id="18" name="TextBox 17"/>
-          <p:cNvSpPr txBox="1"/>
-          <p:nvPr/>
-        </p:nvSpPr>
-        <p:spPr>
-          <a:xfrm>
-            <a:off x="4572000" y="2420925"/>
-            <a:ext cx="2895600" cy="185674"/>
-          </a:xfrm>
-          <a:prstGeom prst="rect">
-            <a:avLst/>
-          </a:prstGeom>
-          <a:noFill/>
-        </p:spPr>
-        <p:txBody>
-          <a:bodyPr wrap="none" lIns="0" rIns="0" tIns="0" bIns="0" anchor="t">
-            <a:spAutoFit/>
-          </a:bodyPr>
-          <a:lstStyle/>
-          <a:p>
-            <a:pPr algn="l">
+          <a:p>
+            <a:pPr algn="just">
               <a:lnSpc>
-                <a:spcPts val="1118"/>
+                <a:spcPts val="2838"/>
               </a:lnSpc>
             </a:pPr>
             <a:r>
-              <a:rPr sz="860" b="1" i="0" spc="150">
-                <a:solidFill>
-                  <a:srgbClr val="1F5E3A"/>
-                </a:solidFill>
-                <a:latin typeface="Poppins"/>
-              </a:rPr>
-              <a:t>UNE EXPERTISE</a:t>
-            </a:r>
-          </a:p>
-        </p:txBody>
-      </p:sp>
-      <p:sp>
-        <p:nvSpPr>
-          <p:cNvPr id="19" name="TextBox 18"/>
-          <p:cNvSpPr txBox="1"/>
-          <p:nvPr/>
-        </p:nvSpPr>
-        <p:spPr>
-          <a:xfrm>
-            <a:off x="4572000" y="2632456"/>
-            <a:ext cx="2921000" cy="345440"/>
-          </a:xfrm>
-          <a:prstGeom prst="rect">
-            <a:avLst/>
-          </a:prstGeom>
-          <a:noFill/>
-        </p:spPr>
-        <p:txBody>
-          <a:bodyPr wrap="none" lIns="0" rIns="0" tIns="0" bIns="0" anchor="t">
-            <a:spAutoFit/>
-          </a:bodyPr>
-          <a:lstStyle/>
-          <a:p>
-            <a:pPr algn="l">
-              <a:lnSpc>
-                <a:spcPts val="2039"/>
-              </a:lnSpc>
-            </a:pPr>
-            <a:r>
-              <a:rPr sz="1700" b="0" i="0">
-                <a:solidFill>
-                  <a:srgbClr val="1F5E3A"/>
-                </a:solidFill>
-                <a:latin typeface="Alfa Slab One"/>
-              </a:rPr>
-              <a:t>Agricole et digitale</a:t>
-            </a:r>
-          </a:p>
-        </p:txBody>
-      </p:sp>
-      <p:cxnSp>
-        <p:nvCxnSpPr>
-          <p:cNvPr id="20" name="Connector 19"/>
-          <p:cNvCxnSpPr/>
-          <p:nvPr/>
-        </p:nvCxnSpPr>
-        <p:spPr>
-          <a:xfrm>
-            <a:off x="4597400" y="3098800"/>
-            <a:ext cx="2844800" cy="0"/>
-          </a:xfrm>
-          <a:prstGeom prst="line">
-            <a:avLst/>
-          </a:prstGeom>
-          <a:ln w="12700">
-            <a:solidFill>
-              <a:srgbClr val="DCE8DE"/>
-            </a:solidFill>
-          </a:ln>
-        </p:spPr>
-        <p:style>
-          <a:lnRef idx="2">
-            <a:schemeClr val="accent1"/>
-          </a:lnRef>
-          <a:fillRef idx="0">
-            <a:schemeClr val="accent1"/>
-          </a:fillRef>
-          <a:effectRef idx="1">
-            <a:schemeClr val="accent1"/>
-          </a:effectRef>
-          <a:fontRef idx="minor">
-            <a:schemeClr val="tx1"/>
-          </a:fontRef>
-        </p:style>
-      </p:cxnSp>
-      <p:sp>
-        <p:nvSpPr>
-          <p:cNvPr id="21" name="TextBox 20"/>
-          <p:cNvSpPr txBox="1"/>
-          <p:nvPr/>
-        </p:nvSpPr>
-        <p:spPr>
-          <a:xfrm>
-            <a:off x="4572000" y="3256280"/>
-            <a:ext cx="2971800" cy="622300"/>
-          </a:xfrm>
-          <a:prstGeom prst="rect">
-            <a:avLst/>
-          </a:prstGeom>
-          <a:noFill/>
-        </p:spPr>
-        <p:txBody>
-          <a:bodyPr wrap="none" lIns="0" rIns="0" tIns="0" bIns="0" anchor="t">
-            <a:spAutoFit/>
-          </a:bodyPr>
-          <a:lstStyle/>
-          <a:p>
-            <a:pPr algn="l">
-              <a:lnSpc>
-                <a:spcPts val="1500"/>
-              </a:lnSpc>
-            </a:pPr>
-            <a:r>
-              <a:rPr sz="1000" b="0" i="0">
+              <a:rPr sz="1650" b="0" i="0">
                 <a:solidFill>
                   <a:srgbClr val="0A1A01"/>
                 </a:solidFill>
                 <a:latin typeface="Poppins"/>
               </a:rPr>
-              <a:t>Agronome de l'UCAD et community manager</a:t>
+              <a:t>producteurs qui y gagnent : mieux connus et mieux valorisés, ils peuvent vendre leur</a:t>
             </a:r>
           </a:p>
           <a:p>
-            <a:pPr algn="l">
+            <a:pPr algn="just">
               <a:lnSpc>
-                <a:spcPts val="1500"/>
+                <a:spcPts val="2838"/>
               </a:lnSpc>
             </a:pPr>
             <a:r>
-              <a:rPr sz="1000" b="0" i="0">
+              <a:rPr sz="1650" b="0" i="0">
                 <a:solidFill>
                   <a:srgbClr val="0A1A01"/>
                 </a:solidFill>
                 <a:latin typeface="Poppins"/>
               </a:rPr>
-              <a:t>formée à Simplon : une double compétence</a:t>
+              <a:t>récolte à son juste prix, au lieu de la brader aux banabana faute d'acheteurs.</a:t>
             </a:r>
           </a:p>
-          <a:p>
-            <a:pPr algn="l">
-              <a:lnSpc>
-                <a:spcPts val="1500"/>
-              </a:lnSpc>
-            </a:pPr>
-            <a:r>
-              <a:rPr sz="1000" b="0" i="0">
-                <a:solidFill>
-                  <a:srgbClr val="0A1A01"/>
-                </a:solidFill>
-                <a:latin typeface="Poppins"/>
-              </a:rPr>
-              <a:t>unique sur ce marché.</a:t>
-            </a:r>
-          </a:p>
-        </p:txBody>
-      </p:sp>
-      <p:sp>
-        <p:nvSpPr>
-          <p:cNvPr id="22" name="Rounded Rectangle 21"/>
-          <p:cNvSpPr/>
-          <p:nvPr/>
-        </p:nvSpPr>
-        <p:spPr>
-          <a:xfrm>
-            <a:off x="7975600" y="2184400"/>
-            <a:ext cx="3403600" cy="1930400"/>
-          </a:xfrm>
-          <a:prstGeom prst="roundRect">
-            <a:avLst>
-              <a:gd name="adj" fmla="val 5921"/>
-            </a:avLst>
-          </a:prstGeom>
-          <a:solidFill>
-            <a:srgbClr val="FFFFFF"/>
-          </a:solidFill>
-          <a:ln w="12700">
-            <a:solidFill>
-              <a:srgbClr val="DCE8DE"/>
-            </a:solidFill>
-          </a:ln>
-          <a:effectLst/>
-        </p:spPr>
-        <p:style>
-          <a:lnRef idx="1">
-            <a:schemeClr val="accent1"/>
-          </a:lnRef>
-          <a:fillRef idx="3">
-            <a:schemeClr val="accent1"/>
-          </a:fillRef>
-          <a:effectRef idx="2">
-            <a:schemeClr val="accent1"/>
-          </a:effectRef>
-          <a:fontRef idx="minor">
-            <a:schemeClr val="lt1"/>
-          </a:fontRef>
-        </p:style>
-        <p:txBody>
-          <a:bodyPr rtlCol="0" anchor="ctr"/>
-          <a:lstStyle/>
-          <a:p/>
-        </p:txBody>
-      </p:sp>
-      <p:sp>
-        <p:nvSpPr>
-          <p:cNvPr id="23" name="Rounded Rectangle 22"/>
-          <p:cNvSpPr/>
-          <p:nvPr/>
-        </p:nvSpPr>
-        <p:spPr>
-          <a:xfrm>
-            <a:off x="7975600" y="2108200"/>
-            <a:ext cx="3403600" cy="50800"/>
+        </p:txBody>
+      </p:sp>
+      <p:sp>
+        <p:nvSpPr>
+          <p:cNvPr id="12" name="Rounded Rectangle 11"/>
+          <p:cNvSpPr/>
+          <p:nvPr/>
+        </p:nvSpPr>
+        <p:spPr>
+          <a:xfrm>
+            <a:off x="1320800" y="4673600"/>
+            <a:ext cx="787400" cy="50800"/>
           </a:xfrm>
           <a:prstGeom prst="roundRect">
             <a:avLst>
@@ -41717,7 +41277,7 @@
             </a:avLst>
           </a:prstGeom>
           <a:solidFill>
-            <a:srgbClr val="42612D"/>
+            <a:srgbClr val="1AAB70"/>
           </a:solidFill>
           <a:ln>
             <a:noFill/>
@@ -41746,14 +41306,58 @@
       </p:sp>
       <p:sp>
         <p:nvSpPr>
-          <p:cNvPr id="24" name="TextBox 23"/>
+          <p:cNvPr id="13" name="Rounded Rectangle 12"/>
+          <p:cNvSpPr/>
+          <p:nvPr/>
+        </p:nvSpPr>
+        <p:spPr>
+          <a:xfrm>
+            <a:off x="660400" y="5384800"/>
+            <a:ext cx="10871200" cy="558800"/>
+          </a:xfrm>
+          <a:prstGeom prst="roundRect">
+            <a:avLst>
+              <a:gd name="adj" fmla="val 22727"/>
+            </a:avLst>
+          </a:prstGeom>
+          <a:solidFill>
+            <a:srgbClr val="1F5E3A"/>
+          </a:solidFill>
+          <a:ln>
+            <a:noFill/>
+          </a:ln>
+          <a:effectLst/>
+        </p:spPr>
+        <p:style>
+          <a:lnRef idx="1">
+            <a:schemeClr val="accent1"/>
+          </a:lnRef>
+          <a:fillRef idx="3">
+            <a:schemeClr val="accent1"/>
+          </a:fillRef>
+          <a:effectRef idx="2">
+            <a:schemeClr val="accent1"/>
+          </a:effectRef>
+          <a:fontRef idx="minor">
+            <a:schemeClr val="lt1"/>
+          </a:fontRef>
+        </p:style>
+        <p:txBody>
+          <a:bodyPr rtlCol="0" anchor="ctr"/>
+          <a:lstStyle/>
+          <a:p/>
+        </p:txBody>
+      </p:sp>
+      <p:sp>
+        <p:nvSpPr>
+          <p:cNvPr id="14" name="TextBox 13"/>
           <p:cNvSpPr txBox="1"/>
           <p:nvPr/>
         </p:nvSpPr>
         <p:spPr>
           <a:xfrm>
-            <a:off x="8229600" y="2420925"/>
-            <a:ext cx="2895600" cy="185674"/>
+            <a:off x="635000" y="5535168"/>
+            <a:ext cx="10922000" cy="291465"/>
           </a:xfrm>
           <a:prstGeom prst="rect">
             <a:avLst/>
@@ -41766,399 +41370,19 @@
           </a:bodyPr>
           <a:lstStyle/>
           <a:p>
-            <a:pPr algn="l">
+            <a:pPr algn="ctr">
               <a:lnSpc>
-                <a:spcPts val="1118"/>
+                <a:spcPts val="1755"/>
               </a:lnSpc>
             </a:pPr>
             <a:r>
-              <a:rPr sz="860" b="1" i="0" spc="150">
-                <a:solidFill>
-                  <a:srgbClr val="42612D"/>
-                </a:solidFill>
-                <a:latin typeface="Poppins"/>
-              </a:rPr>
-              <a:t>UN PROJET</a:t>
-            </a:r>
-          </a:p>
-        </p:txBody>
-      </p:sp>
-      <p:sp>
-        <p:nvSpPr>
-          <p:cNvPr id="25" name="TextBox 24"/>
-          <p:cNvSpPr txBox="1"/>
-          <p:nvPr/>
-        </p:nvSpPr>
-        <p:spPr>
-          <a:xfrm>
-            <a:off x="8229600" y="2632456"/>
-            <a:ext cx="2921000" cy="345440"/>
-          </a:xfrm>
-          <a:prstGeom prst="rect">
-            <a:avLst/>
-          </a:prstGeom>
-          <a:noFill/>
-        </p:spPr>
-        <p:txBody>
-          <a:bodyPr wrap="none" lIns="0" rIns="0" tIns="0" bIns="0" anchor="t">
-            <a:spAutoFit/>
-          </a:bodyPr>
-          <a:lstStyle/>
-          <a:p>
-            <a:pPr algn="l">
-              <a:lnSpc>
-                <a:spcPts val="2039"/>
-              </a:lnSpc>
-            </a:pPr>
-            <a:r>
-              <a:rPr sz="1700" b="0" i="0">
-                <a:solidFill>
-                  <a:srgbClr val="1F5E3A"/>
-                </a:solidFill>
-                <a:latin typeface="Alfa Slab One"/>
-              </a:rPr>
-              <a:t>Déjà lancé, pas une idée</a:t>
-            </a:r>
-          </a:p>
-        </p:txBody>
-      </p:sp>
-      <p:cxnSp>
-        <p:nvCxnSpPr>
-          <p:cNvPr id="26" name="Connector 25"/>
-          <p:cNvCxnSpPr/>
-          <p:nvPr/>
-        </p:nvCxnSpPr>
-        <p:spPr>
-          <a:xfrm>
-            <a:off x="8255000" y="3098800"/>
-            <a:ext cx="2844800" cy="0"/>
-          </a:xfrm>
-          <a:prstGeom prst="line">
-            <a:avLst/>
-          </a:prstGeom>
-          <a:ln w="12700">
-            <a:solidFill>
-              <a:srgbClr val="DCE8DE"/>
-            </a:solidFill>
-          </a:ln>
-        </p:spPr>
-        <p:style>
-          <a:lnRef idx="2">
-            <a:schemeClr val="accent1"/>
-          </a:lnRef>
-          <a:fillRef idx="0">
-            <a:schemeClr val="accent1"/>
-          </a:fillRef>
-          <a:effectRef idx="1">
-            <a:schemeClr val="accent1"/>
-          </a:effectRef>
-          <a:fontRef idx="minor">
-            <a:schemeClr val="tx1"/>
-          </a:fontRef>
-        </p:style>
-      </p:cxnSp>
-      <p:sp>
-        <p:nvSpPr>
-          <p:cNvPr id="27" name="TextBox 26"/>
-          <p:cNvSpPr txBox="1"/>
-          <p:nvPr/>
-        </p:nvSpPr>
-        <p:spPr>
-          <a:xfrm>
-            <a:off x="8229600" y="3256280"/>
-            <a:ext cx="2971800" cy="431800"/>
-          </a:xfrm>
-          <a:prstGeom prst="rect">
-            <a:avLst/>
-          </a:prstGeom>
-          <a:noFill/>
-        </p:spPr>
-        <p:txBody>
-          <a:bodyPr wrap="none" lIns="0" rIns="0" tIns="0" bIns="0" anchor="t">
-            <a:spAutoFit/>
-          </a:bodyPr>
-          <a:lstStyle/>
-          <a:p>
-            <a:pPr algn="l">
-              <a:lnSpc>
-                <a:spcPts val="1500"/>
-              </a:lnSpc>
-            </a:pPr>
-            <a:r>
-              <a:rPr sz="1000" b="0" i="0">
-                <a:solidFill>
-                  <a:srgbClr val="0A1A01"/>
-                </a:solidFill>
-                <a:latin typeface="Poppins"/>
-              </a:rPr>
-              <a:t>Entreprise formalisée, marque construite,</a:t>
-            </a:r>
-          </a:p>
-          <a:p>
-            <a:pPr algn="l">
-              <a:lnSpc>
-                <a:spcPts val="1500"/>
-              </a:lnSpc>
-            </a:pPr>
-            <a:r>
-              <a:rPr sz="1000" b="0" i="0">
-                <a:solidFill>
-                  <a:srgbClr val="0A1A01"/>
-                </a:solidFill>
-                <a:latin typeface="Poppins"/>
-              </a:rPr>
-              <a:t>présence digitale active et offres structurées.</a:t>
-            </a:r>
-          </a:p>
-        </p:txBody>
-      </p:sp>
-      <p:sp>
-        <p:nvSpPr>
-          <p:cNvPr id="28" name="Rounded Rectangle 27"/>
-          <p:cNvSpPr/>
-          <p:nvPr/>
-        </p:nvSpPr>
-        <p:spPr>
-          <a:xfrm>
-            <a:off x="660400" y="4470400"/>
-            <a:ext cx="10871200" cy="939800"/>
-          </a:xfrm>
-          <a:prstGeom prst="roundRect">
-            <a:avLst>
-              <a:gd name="adj" fmla="val 14864"/>
-            </a:avLst>
-          </a:prstGeom>
-          <a:solidFill>
-            <a:srgbClr val="1F5E3A"/>
-          </a:solidFill>
-          <a:ln>
-            <a:noFill/>
-          </a:ln>
-          <a:effectLst/>
-        </p:spPr>
-        <p:style>
-          <a:lnRef idx="1">
-            <a:schemeClr val="accent1"/>
-          </a:lnRef>
-          <a:fillRef idx="3">
-            <a:schemeClr val="accent1"/>
-          </a:fillRef>
-          <a:effectRef idx="2">
-            <a:schemeClr val="accent1"/>
-          </a:effectRef>
-          <a:fontRef idx="minor">
-            <a:schemeClr val="lt1"/>
-          </a:fontRef>
-        </p:style>
-        <p:txBody>
-          <a:bodyPr rtlCol="0" anchor="ctr"/>
-          <a:lstStyle/>
-          <a:p/>
-        </p:txBody>
-      </p:sp>
-      <p:sp>
-        <p:nvSpPr>
-          <p:cNvPr id="29" name="TextBox 28"/>
-          <p:cNvSpPr txBox="1"/>
-          <p:nvPr/>
-        </p:nvSpPr>
-        <p:spPr>
-          <a:xfrm>
-            <a:off x="990600" y="4706925"/>
-            <a:ext cx="2844800" cy="185674"/>
-          </a:xfrm>
-          <a:prstGeom prst="rect">
-            <a:avLst/>
-          </a:prstGeom>
-          <a:noFill/>
-        </p:spPr>
-        <p:txBody>
-          <a:bodyPr wrap="none" lIns="0" rIns="0" tIns="0" bIns="0" anchor="t">
-            <a:spAutoFit/>
-          </a:bodyPr>
-          <a:lstStyle/>
-          <a:p>
-            <a:pPr algn="l">
-              <a:lnSpc>
-                <a:spcPts val="1118"/>
-              </a:lnSpc>
-            </a:pPr>
-            <a:r>
-              <a:rPr sz="860" b="1" i="0" spc="150">
-                <a:solidFill>
-                  <a:srgbClr val="1AAB70"/>
-                </a:solidFill>
-                <a:latin typeface="Poppins"/>
-              </a:rPr>
-              <a:t>CE QUE JE DEMANDE</a:t>
-            </a:r>
-          </a:p>
-        </p:txBody>
-      </p:sp>
-      <p:sp>
-        <p:nvSpPr>
-          <p:cNvPr id="30" name="TextBox 29"/>
-          <p:cNvSpPr txBox="1"/>
-          <p:nvPr/>
-        </p:nvSpPr>
-        <p:spPr>
-          <a:xfrm>
-            <a:off x="990600" y="4876800"/>
-            <a:ext cx="3352800" cy="539750"/>
-          </a:xfrm>
-          <a:prstGeom prst="rect">
-            <a:avLst/>
-          </a:prstGeom>
-          <a:noFill/>
-        </p:spPr>
-        <p:txBody>
-          <a:bodyPr wrap="none" lIns="0" rIns="0" tIns="0" bIns="0" anchor="t">
-            <a:spAutoFit/>
-          </a:bodyPr>
-          <a:lstStyle/>
-          <a:p>
-            <a:pPr algn="l">
-              <a:lnSpc>
-                <a:spcPts val="3250"/>
-              </a:lnSpc>
-            </a:pPr>
-            <a:r>
-              <a:rPr sz="2500" b="0" i="0">
-                <a:solidFill>
-                  <a:srgbClr val="FFFFFF"/>
-                </a:solidFill>
-                <a:latin typeface="Alfa Slab One"/>
-              </a:rPr>
-              <a:t>1 850 000 FCFA</a:t>
-            </a:r>
-          </a:p>
-        </p:txBody>
-      </p:sp>
-      <p:cxnSp>
-        <p:nvCxnSpPr>
-          <p:cNvPr id="31" name="Connector 30"/>
-          <p:cNvCxnSpPr/>
-          <p:nvPr/>
-        </p:nvCxnSpPr>
-        <p:spPr>
-          <a:xfrm>
-            <a:off x="4699000" y="4724400"/>
-            <a:ext cx="0" cy="431800"/>
-          </a:xfrm>
-          <a:prstGeom prst="line">
-            <a:avLst/>
-          </a:prstGeom>
-          <a:ln w="15240">
-            <a:solidFill>
-              <a:srgbClr val="1AAB70"/>
-            </a:solidFill>
-          </a:ln>
-        </p:spPr>
-        <p:style>
-          <a:lnRef idx="2">
-            <a:schemeClr val="accent1"/>
-          </a:lnRef>
-          <a:fillRef idx="0">
-            <a:schemeClr val="accent1"/>
-          </a:fillRef>
-          <a:effectRef idx="1">
-            <a:schemeClr val="accent1"/>
-          </a:effectRef>
-          <a:fontRef idx="minor">
-            <a:schemeClr val="tx1"/>
-          </a:fontRef>
-        </p:style>
-      </p:cxnSp>
-      <p:sp>
-        <p:nvSpPr>
-          <p:cNvPr id="32" name="TextBox 31"/>
-          <p:cNvSpPr txBox="1"/>
-          <p:nvPr/>
-        </p:nvSpPr>
-        <p:spPr>
-          <a:xfrm>
-            <a:off x="5029200" y="4777232"/>
-            <a:ext cx="6273800" cy="481965"/>
-          </a:xfrm>
-          <a:prstGeom prst="rect">
-            <a:avLst/>
-          </a:prstGeom>
-          <a:noFill/>
-        </p:spPr>
-        <p:txBody>
-          <a:bodyPr wrap="none" lIns="0" rIns="0" tIns="0" bIns="0" anchor="t">
-            <a:spAutoFit/>
-          </a:bodyPr>
-          <a:lstStyle/>
-          <a:p>
-            <a:pPr algn="l">
-              <a:lnSpc>
-                <a:spcPts val="1667"/>
-              </a:lnSpc>
-            </a:pPr>
-            <a:r>
-              <a:rPr sz="1150" b="0" i="0">
+              <a:rPr sz="1350" b="1" i="0">
                 <a:solidFill>
                   <a:srgbClr val="FFFFFF"/>
                 </a:solidFill>
                 <a:latin typeface="Poppins"/>
               </a:rPr>
-              <a:t>Pour équiper la production, me former, lancer le site vitrine et signer mes cinq</a:t>
-            </a:r>
-          </a:p>
-          <a:p>
-            <a:pPr algn="l">
-              <a:lnSpc>
-                <a:spcPts val="1667"/>
-              </a:lnSpc>
-            </a:pPr>
-            <a:r>
-              <a:rPr sz="1150" b="0" i="0">
-                <a:solidFill>
-                  <a:srgbClr val="FFFFFF"/>
-                </a:solidFill>
-                <a:latin typeface="Poppins"/>
-              </a:rPr>
-              <a:t>premiers clients.</a:t>
-            </a:r>
-          </a:p>
-        </p:txBody>
-      </p:sp>
-      <p:sp>
-        <p:nvSpPr>
-          <p:cNvPr id="33" name="TextBox 32"/>
-          <p:cNvSpPr txBox="1"/>
-          <p:nvPr/>
-        </p:nvSpPr>
-        <p:spPr>
-          <a:xfrm>
-            <a:off x="635000" y="5711952"/>
-            <a:ext cx="10922000" cy="302260"/>
-          </a:xfrm>
-          <a:prstGeom prst="rect">
-            <a:avLst/>
-          </a:prstGeom>
-          <a:noFill/>
-        </p:spPr>
-        <p:txBody>
-          <a:bodyPr wrap="none" lIns="0" rIns="0" tIns="0" bIns="0" anchor="t">
-            <a:spAutoFit/>
-          </a:bodyPr>
-          <a:lstStyle/>
-          <a:p>
-            <a:pPr algn="ctr">
-              <a:lnSpc>
-                <a:spcPts val="1820"/>
-              </a:lnSpc>
-            </a:pPr>
-            <a:r>
-              <a:rPr sz="1400" b="0" i="0">
-                <a:solidFill>
-                  <a:srgbClr val="1F5E3A"/>
-                </a:solidFill>
-                <a:latin typeface="Alfa Slab One"/>
-              </a:rPr>
-              <a:t>« Rendre les produits locaux sénégalais aussi visibles en ligne qu'ils le sont dans les rayons. »</a:t>
+              <a:t>Plus de visibilité pour les marques, un meilleur revenu pour ceux qui cultivent.</a:t>
             </a:r>
           </a:p>
         </p:txBody>

</xml_diff>